<commit_message>
Remove personal review commentary from project documentation
</commit_message>
<xml_diff>
--- a/submission/ModelCheck_Capstone.pptx
+++ b/submission/ModelCheck_Capstone.pptx
@@ -2,18 +2,18 @@
 <file path=ppt/presentation.xml><?xml version="1.0" encoding="utf-8"?>
 <p:presentation xmlns:p="http://schemas.openxmlformats.org/presentationml/2006/main">
   <p:sldMasterIdLst>
-    <p:sldMasterId xmlns:r="http://schemas.openxmlformats.org/officeDocument/2006/relationships" id="2147483648" r:id="Rd33c0ad5d53244a3"/>
+    <p:sldMasterId xmlns:r="http://schemas.openxmlformats.org/officeDocument/2006/relationships" id="2147483648" r:id="Rcbba99485d024769"/>
   </p:sldMasterIdLst>
   <p:notesMasterIdLst>
-    <p:notesMasterId xmlns:r="http://schemas.openxmlformats.org/officeDocument/2006/relationships" r:id="R54469332d01a433a"/>
+    <p:notesMasterId xmlns:r="http://schemas.openxmlformats.org/officeDocument/2006/relationships" r:id="Rc532ff39f4f1444b"/>
   </p:notesMasterIdLst>
   <p:sldIdLst>
-    <p:sldId xmlns:r="http://schemas.openxmlformats.org/officeDocument/2006/relationships" id="256" r:id="R4c278f22be134218"/>
-    <p:sldId xmlns:r="http://schemas.openxmlformats.org/officeDocument/2006/relationships" id="257" r:id="Rad79a83ed2c44d63"/>
-    <p:sldId xmlns:r="http://schemas.openxmlformats.org/officeDocument/2006/relationships" id="258" r:id="Ra36bd4482c384836"/>
-    <p:sldId xmlns:r="http://schemas.openxmlformats.org/officeDocument/2006/relationships" id="259" r:id="R637c42f78f32486e"/>
-    <p:sldId xmlns:r="http://schemas.openxmlformats.org/officeDocument/2006/relationships" id="260" r:id="R863296f6b9fd411e"/>
-    <p:sldId xmlns:r="http://schemas.openxmlformats.org/officeDocument/2006/relationships" id="261" r:id="R51bad7754bf5412c"/>
+    <p:sldId xmlns:r="http://schemas.openxmlformats.org/officeDocument/2006/relationships" id="256" r:id="R21f32971941f4e73"/>
+    <p:sldId xmlns:r="http://schemas.openxmlformats.org/officeDocument/2006/relationships" id="257" r:id="R9acf1e5f96b84d96"/>
+    <p:sldId xmlns:r="http://schemas.openxmlformats.org/officeDocument/2006/relationships" id="258" r:id="R09b5ceee378d4a82"/>
+    <p:sldId xmlns:r="http://schemas.openxmlformats.org/officeDocument/2006/relationships" id="259" r:id="R83f1b96813b24e0e"/>
+    <p:sldId xmlns:r="http://schemas.openxmlformats.org/officeDocument/2006/relationships" id="260" r:id="R4eb31664e44d4ec7"/>
+    <p:sldId xmlns:r="http://schemas.openxmlformats.org/officeDocument/2006/relationships" id="261" r:id="R7cf1dd34ba6f497b"/>
   </p:sldIdLst>
   <p:sldSz cx="12192000" cy="6858000"/>
   <p:notesSz cx="6858000" cy="9144000"/>
@@ -447,7 +447,7 @@
           <a:lstStyle xmlns:a="http://schemas.openxmlformats.org/drawingml/2006/main"/>
           <a:p xmlns:a="http://schemas.openxmlformats.org/drawingml/2006/main">
             <a:r>
-              <a:t>Problem: developers can report a good aggregate score while missing source-specific errors, incomplete coverage or unreliable provenance. This is a portfolio prototype built with Codex assistance. Sources: README.md; ../labs/capstone/README.md. Do not claim independent ownership before reviewing the code.</a:t>
+              <a:t>Problem: developers can report a good aggregate score while missing source-specific errors, incomplete coverage or unreliable provenance. Sources: README.md; ../labs/capstone/README.md.</a:t>
             </a:r>
           </a:p>
         </p:txBody>
@@ -844,7 +844,7 @@
           <p:cNvPr id="3" name="Title">
             <a:extLst xmlns:a="http://schemas.openxmlformats.org/drawingml/2006/main">
               <a:ext uri="{FF2B5EF4-FFF2-40B4-BE49-F238E27FC236}">
-                <a16:creationId xmlns:a16="http://schemas.microsoft.com/office/drawing/2014/main" id="{E6F0632F-9780-4103-A8F1-67205177607F}"/>
+                <a16:creationId xmlns:a16="http://schemas.microsoft.com/office/drawing/2014/main" id="{0B055A38-EDB6-415C-96F8-2D5571C4FE47}"/>
               </a:ext>
             </a:extLst>
           </p:cNvPr>
@@ -1073,7 +1073,7 @@
           <p:cNvPr id="2" name="Subtitle">
             <a:extLst xmlns:a="http://schemas.openxmlformats.org/drawingml/2006/main">
               <a:ext uri="{FF2B5EF4-FFF2-40B4-BE49-F238E27FC236}">
-                <a16:creationId xmlns:a16="http://schemas.microsoft.com/office/drawing/2014/main" id="{75DDB0FD-816A-4F32-96FD-DAE4EFFFC020}"/>
+                <a16:creationId xmlns:a16="http://schemas.microsoft.com/office/drawing/2014/main" id="{4AC41EA8-C913-4B75-B73E-CA06672A2F4A}"/>
               </a:ext>
             </a:extLst>
           </p:cNvPr>
@@ -1319,7 +1319,7 @@
           <p:cNvPr id="2" name="Section title">
             <a:extLst xmlns:a="http://schemas.openxmlformats.org/drawingml/2006/main">
               <a:ext uri="{FF2B5EF4-FFF2-40B4-BE49-F238E27FC236}">
-                <a16:creationId xmlns:a16="http://schemas.microsoft.com/office/drawing/2014/main" id="{0E636742-5FE7-4FBA-8D41-19F4FF0EE92D}"/>
+                <a16:creationId xmlns:a16="http://schemas.microsoft.com/office/drawing/2014/main" id="{1E10736F-2762-4EE0-A4B9-25B80C13220B}"/>
               </a:ext>
             </a:extLst>
           </p:cNvPr>
@@ -1565,7 +1565,7 @@
           <p:cNvPr id="3" name="Title">
             <a:extLst xmlns:a="http://schemas.openxmlformats.org/drawingml/2006/main">
               <a:ext uri="{FF2B5EF4-FFF2-40B4-BE49-F238E27FC236}">
-                <a16:creationId xmlns:a16="http://schemas.microsoft.com/office/drawing/2014/main" id="{EDDAA371-FC07-403D-967B-DC0532AF0730}"/>
+                <a16:creationId xmlns:a16="http://schemas.microsoft.com/office/drawing/2014/main" id="{4BEB8804-A834-4E16-90DE-D2E05808577C}"/>
               </a:ext>
             </a:extLst>
           </p:cNvPr>
@@ -1794,7 +1794,7 @@
           <p:cNvPr id="2" name="Body">
             <a:extLst xmlns:a="http://schemas.openxmlformats.org/drawingml/2006/main">
               <a:ext uri="{FF2B5EF4-FFF2-40B4-BE49-F238E27FC236}">
-                <a16:creationId xmlns:a16="http://schemas.microsoft.com/office/drawing/2014/main" id="{4BBD6DE0-A161-4B2A-896D-2B67ED0F0235}"/>
+                <a16:creationId xmlns:a16="http://schemas.microsoft.com/office/drawing/2014/main" id="{11DC3C67-B2E4-49E0-94E5-CBC243E626F9}"/>
               </a:ext>
             </a:extLst>
           </p:cNvPr>
@@ -2040,7 +2040,7 @@
           <p:cNvPr id="4" name="Title">
             <a:extLst xmlns:a="http://schemas.openxmlformats.org/drawingml/2006/main">
               <a:ext uri="{FF2B5EF4-FFF2-40B4-BE49-F238E27FC236}">
-                <a16:creationId xmlns:a16="http://schemas.microsoft.com/office/drawing/2014/main" id="{A5023577-90FB-4BC8-B4D8-5F2AD43BC65A}"/>
+                <a16:creationId xmlns:a16="http://schemas.microsoft.com/office/drawing/2014/main" id="{55015270-D17D-4B98-AB08-2948F1B92E25}"/>
               </a:ext>
             </a:extLst>
           </p:cNvPr>
@@ -2269,7 +2269,7 @@
           <p:cNvPr id="2" name="Left column">
             <a:extLst xmlns:a="http://schemas.openxmlformats.org/drawingml/2006/main">
               <a:ext uri="{FF2B5EF4-FFF2-40B4-BE49-F238E27FC236}">
-                <a16:creationId xmlns:a16="http://schemas.microsoft.com/office/drawing/2014/main" id="{6D611E03-0A12-4906-8A50-66D8FD495059}"/>
+                <a16:creationId xmlns:a16="http://schemas.microsoft.com/office/drawing/2014/main" id="{0A5ACB6D-723B-452D-8B90-3F7BD52EE5A4}"/>
               </a:ext>
             </a:extLst>
           </p:cNvPr>
@@ -2498,7 +2498,7 @@
           <p:cNvPr id="3" name="Right column">
             <a:extLst xmlns:a="http://schemas.openxmlformats.org/drawingml/2006/main">
               <a:ext uri="{FF2B5EF4-FFF2-40B4-BE49-F238E27FC236}">
-                <a16:creationId xmlns:a16="http://schemas.microsoft.com/office/drawing/2014/main" id="{BA5EDFF4-A471-44C1-8D23-72F7E3DE6DCA}"/>
+                <a16:creationId xmlns:a16="http://schemas.microsoft.com/office/drawing/2014/main" id="{578D9EAE-D28F-41AC-BBBF-57B163082573}"/>
               </a:ext>
             </a:extLst>
           </p:cNvPr>
@@ -2744,7 +2744,7 @@
           <p:cNvPr id="3" name="Title">
             <a:extLst xmlns:a="http://schemas.openxmlformats.org/drawingml/2006/main">
               <a:ext uri="{FF2B5EF4-FFF2-40B4-BE49-F238E27FC236}">
-                <a16:creationId xmlns:a16="http://schemas.microsoft.com/office/drawing/2014/main" id="{5577A8AE-DD8E-431E-89D7-E7067131B1AC}"/>
+                <a16:creationId xmlns:a16="http://schemas.microsoft.com/office/drawing/2014/main" id="{A685FD02-5F2C-466D-BAE2-CB3F257AD926}"/>
               </a:ext>
             </a:extLst>
           </p:cNvPr>
@@ -2973,7 +2973,7 @@
           <p:cNvPr id="2" name="Left column">
             <a:extLst xmlns:a="http://schemas.openxmlformats.org/drawingml/2006/main">
               <a:ext uri="{FF2B5EF4-FFF2-40B4-BE49-F238E27FC236}">
-                <a16:creationId xmlns:a16="http://schemas.microsoft.com/office/drawing/2014/main" id="{C48810E5-30F2-4EF0-9B90-4AA3B3A84EC7}"/>
+                <a16:creationId xmlns:a16="http://schemas.microsoft.com/office/drawing/2014/main" id="{ED06A847-262E-4DE5-B6E8-2AFA92E422C9}"/>
               </a:ext>
             </a:extLst>
           </p:cNvPr>
@@ -3240,12 +3240,12 @@
   </p:cSld>
   <p:clrMap bg1="lt1" tx1="dk1" bg2="lt2" tx2="dk2" accent1="accent1" accent2="accent2" accent3="accent3" accent4="accent4" accent5="accent5" accent6="accent6" hlink="hlink" folHlink="folHlink"/>
   <p:sldLayoutIdLst>
-    <p:sldLayoutId xmlns:r="http://schemas.openxmlformats.org/officeDocument/2006/relationships" id="2147483649" r:id="R6972f56274524351"/>
-    <p:sldLayoutId xmlns:r="http://schemas.openxmlformats.org/officeDocument/2006/relationships" id="2147483650" r:id="R0073c363d10d40a7"/>
-    <p:sldLayoutId xmlns:r="http://schemas.openxmlformats.org/officeDocument/2006/relationships" id="2147483651" r:id="Rb268fded58874d2b"/>
-    <p:sldLayoutId xmlns:r="http://schemas.openxmlformats.org/officeDocument/2006/relationships" id="2147483652" r:id="Rf7dca0b18dbc4f98"/>
-    <p:sldLayoutId xmlns:r="http://schemas.openxmlformats.org/officeDocument/2006/relationships" id="2147483653" r:id="R06a49d04c6704720"/>
-    <p:sldLayoutId xmlns:r="http://schemas.openxmlformats.org/officeDocument/2006/relationships" id="2147483654" r:id="Rc784817b24ff4ead"/>
+    <p:sldLayoutId xmlns:r="http://schemas.openxmlformats.org/officeDocument/2006/relationships" id="2147483649" r:id="R5b51370f78dd4b1a"/>
+    <p:sldLayoutId xmlns:r="http://schemas.openxmlformats.org/officeDocument/2006/relationships" id="2147483650" r:id="Ree3277e6d1b84294"/>
+    <p:sldLayoutId xmlns:r="http://schemas.openxmlformats.org/officeDocument/2006/relationships" id="2147483651" r:id="R5d8ae103e3e140e8"/>
+    <p:sldLayoutId xmlns:r="http://schemas.openxmlformats.org/officeDocument/2006/relationships" id="2147483652" r:id="R6ab888e89de94ead"/>
+    <p:sldLayoutId xmlns:r="http://schemas.openxmlformats.org/officeDocument/2006/relationships" id="2147483653" r:id="Rc12c9526562e45a1"/>
+    <p:sldLayoutId xmlns:r="http://schemas.openxmlformats.org/officeDocument/2006/relationships" id="2147483654" r:id="R8f767aefb2e0497e"/>
   </p:sldLayoutIdLst>
   <p:txStyles>
     <p:titleStyle>
@@ -3796,7 +3796,7 @@
           <p:cNvPr id="6" name="">
             <a:extLst xmlns:a="http://schemas.openxmlformats.org/drawingml/2006/main">
               <a:ext uri="{FF2B5EF4-FFF2-40B4-BE49-F238E27FC236}">
-                <a16:creationId xmlns:a16="http://schemas.microsoft.com/office/drawing/2014/main" id="{B5677B34-7FD3-4261-8A4B-3E4C3D681E23}"/>
+                <a16:creationId xmlns:a16="http://schemas.microsoft.com/office/drawing/2014/main" id="{F5E36BA3-F1EB-45B9-9D49-9F1626EF38B1}"/>
               </a:ext>
             </a:extLst>
           </p:cNvPr>
@@ -3952,7 +3952,7 @@
           <p:cNvPr id="2" name="">
             <a:extLst xmlns:a="http://schemas.openxmlformats.org/drawingml/2006/main">
               <a:ext uri="{FF2B5EF4-FFF2-40B4-BE49-F238E27FC236}">
-                <a16:creationId xmlns:a16="http://schemas.microsoft.com/office/drawing/2014/main" id="{B2F85672-FE56-4F57-9B47-A0E437C30C33}"/>
+                <a16:creationId xmlns:a16="http://schemas.microsoft.com/office/drawing/2014/main" id="{6300A597-EC74-4D5B-A811-774B515C2F76}"/>
               </a:ext>
             </a:extLst>
           </p:cNvPr>
@@ -4108,7 +4108,7 @@
           <p:cNvPr id="3" name="">
             <a:extLst xmlns:a="http://schemas.openxmlformats.org/drawingml/2006/main">
               <a:ext uri="{FF2B5EF4-FFF2-40B4-BE49-F238E27FC236}">
-                <a16:creationId xmlns:a16="http://schemas.microsoft.com/office/drawing/2014/main" id="{9C89C339-2113-435C-8AE0-5A9F02FAA01C}"/>
+                <a16:creationId xmlns:a16="http://schemas.microsoft.com/office/drawing/2014/main" id="{10DBFC3B-C4DD-4AC9-9CFA-5A86B46BF047}"/>
               </a:ext>
             </a:extLst>
           </p:cNvPr>
@@ -4264,7 +4264,7 @@
           <p:cNvPr id="4" name="">
             <a:extLst xmlns:a="http://schemas.openxmlformats.org/drawingml/2006/main">
               <a:ext uri="{FF2B5EF4-FFF2-40B4-BE49-F238E27FC236}">
-                <a16:creationId xmlns:a16="http://schemas.microsoft.com/office/drawing/2014/main" id="{29ADA8B4-D597-418D-A720-BEA5B706444D}"/>
+                <a16:creationId xmlns:a16="http://schemas.microsoft.com/office/drawing/2014/main" id="{DE218C72-E39D-4B2C-9217-A607B46CA4FC}"/>
               </a:ext>
             </a:extLst>
           </p:cNvPr>
@@ -4443,7 +4443,7 @@
           <p:cNvPr id="5" name="">
             <a:extLst xmlns:a="http://schemas.openxmlformats.org/drawingml/2006/main">
               <a:ext uri="{FF2B5EF4-FFF2-40B4-BE49-F238E27FC236}">
-                <a16:creationId xmlns:a16="http://schemas.microsoft.com/office/drawing/2014/main" id="{3384232B-23B6-4FA3-BDC8-CB9A9F2CB0B5}"/>
+                <a16:creationId xmlns:a16="http://schemas.microsoft.com/office/drawing/2014/main" id="{C700F9E3-5CFA-4458-A2FD-E154056AB752}"/>
               </a:ext>
             </a:extLst>
           </p:cNvPr>
@@ -4620,7 +4620,7 @@
     </p:spTree>
     <p:extLst>
       <p:ext uri="{BB962C8B-B14F-4D97-AF65-F5344CB8AC3E}">
-        <p14:creationId xmlns:p14="http://schemas.microsoft.com/office/powerpoint/2010/main" val="1535527880"/>
+        <p14:creationId xmlns:p14="http://schemas.microsoft.com/office/powerpoint/2010/main" val="1191174934"/>
       </p:ext>
     </p:extLst>
   </p:cSld>
@@ -4651,7 +4651,7 @@
           <p:cNvPr id="7" name="">
             <a:extLst xmlns:a="http://schemas.openxmlformats.org/drawingml/2006/main">
               <a:ext uri="{FF2B5EF4-FFF2-40B4-BE49-F238E27FC236}">
-                <a16:creationId xmlns:a16="http://schemas.microsoft.com/office/drawing/2014/main" id="{71935902-27E5-438C-8F35-BC9A094F3C92}"/>
+                <a16:creationId xmlns:a16="http://schemas.microsoft.com/office/drawing/2014/main" id="{9E791CED-5C13-449E-A88C-A782A6E47D5D}"/>
               </a:ext>
             </a:extLst>
           </p:cNvPr>
@@ -4807,7 +4807,7 @@
           <p:cNvPr id="2" name="">
             <a:extLst xmlns:a="http://schemas.openxmlformats.org/drawingml/2006/main">
               <a:ext uri="{FF2B5EF4-FFF2-40B4-BE49-F238E27FC236}">
-                <a16:creationId xmlns:a16="http://schemas.microsoft.com/office/drawing/2014/main" id="{C0881559-ADC3-4B2F-94DE-D2943C7B6F34}"/>
+                <a16:creationId xmlns:a16="http://schemas.microsoft.com/office/drawing/2014/main" id="{69618C86-2519-4E4E-9E94-BC6DCD00E6E7}"/>
               </a:ext>
             </a:extLst>
           </p:cNvPr>
@@ -4963,7 +4963,7 @@
           <p:cNvPr id="3" name="">
             <a:extLst xmlns:a="http://schemas.openxmlformats.org/drawingml/2006/main">
               <a:ext uri="{FF2B5EF4-FFF2-40B4-BE49-F238E27FC236}">
-                <a16:creationId xmlns:a16="http://schemas.microsoft.com/office/drawing/2014/main" id="{113AC7B4-B838-43D2-8BD5-9BA8D8B36196}"/>
+                <a16:creationId xmlns:a16="http://schemas.microsoft.com/office/drawing/2014/main" id="{882D4488-E980-4AC8-8DDD-03B11A11F7C2}"/>
               </a:ext>
             </a:extLst>
           </p:cNvPr>
@@ -5119,7 +5119,7 @@
           <p:cNvPr id="4" name="">
             <a:extLst xmlns:a="http://schemas.openxmlformats.org/drawingml/2006/main">
               <a:ext uri="{FF2B5EF4-FFF2-40B4-BE49-F238E27FC236}">
-                <a16:creationId xmlns:a16="http://schemas.microsoft.com/office/drawing/2014/main" id="{39FEF904-A0DF-4813-9128-B9AAB3DD8BC7}"/>
+                <a16:creationId xmlns:a16="http://schemas.microsoft.com/office/drawing/2014/main" id="{08AF86DA-2B7B-4C0E-9E6C-23E5F313CAAC}"/>
               </a:ext>
             </a:extLst>
           </p:cNvPr>
@@ -5275,7 +5275,7 @@
           <p:cNvPr id="5" name="">
             <a:extLst xmlns:a="http://schemas.openxmlformats.org/drawingml/2006/main">
               <a:ext uri="{FF2B5EF4-FFF2-40B4-BE49-F238E27FC236}">
-                <a16:creationId xmlns:a16="http://schemas.microsoft.com/office/drawing/2014/main" id="{F1133835-5D38-4B2E-9754-37C4A1747B39}"/>
+                <a16:creationId xmlns:a16="http://schemas.microsoft.com/office/drawing/2014/main" id="{95F3FFB3-4F16-43FD-BEF0-AB1F8A64A60D}"/>
               </a:ext>
             </a:extLst>
           </p:cNvPr>
@@ -5786,7 +5786,7 @@
           <p:cNvPr id="6" name="">
             <a:extLst xmlns:a="http://schemas.openxmlformats.org/drawingml/2006/main">
               <a:ext uri="{FF2B5EF4-FFF2-40B4-BE49-F238E27FC236}">
-                <a16:creationId xmlns:a16="http://schemas.microsoft.com/office/drawing/2014/main" id="{47763744-8909-49C0-A04D-E2744A01EBCF}"/>
+                <a16:creationId xmlns:a16="http://schemas.microsoft.com/office/drawing/2014/main" id="{ACBD4758-9643-4EA0-9790-2096F31ABD87}"/>
               </a:ext>
             </a:extLst>
           </p:cNvPr>
@@ -5963,7 +5963,7 @@
     </p:spTree>
     <p:extLst>
       <p:ext uri="{BB962C8B-B14F-4D97-AF65-F5344CB8AC3E}">
-        <p14:creationId xmlns:p14="http://schemas.microsoft.com/office/powerpoint/2010/main" val="1213075136"/>
+        <p14:creationId xmlns:p14="http://schemas.microsoft.com/office/powerpoint/2010/main" val="279968203"/>
       </p:ext>
     </p:extLst>
   </p:cSld>
@@ -5994,7 +5994,7 @@
           <p:cNvPr id="6" name="">
             <a:extLst xmlns:a="http://schemas.openxmlformats.org/drawingml/2006/main">
               <a:ext uri="{FF2B5EF4-FFF2-40B4-BE49-F238E27FC236}">
-                <a16:creationId xmlns:a16="http://schemas.microsoft.com/office/drawing/2014/main" id="{81BFC97C-056A-47B3-A1FC-899FDCCAB22B}"/>
+                <a16:creationId xmlns:a16="http://schemas.microsoft.com/office/drawing/2014/main" id="{81931FEF-23C5-44A7-B943-C8826DD3FACF}"/>
               </a:ext>
             </a:extLst>
           </p:cNvPr>
@@ -6150,7 +6150,7 @@
           <p:cNvPr id="2" name="">
             <a:extLst xmlns:a="http://schemas.openxmlformats.org/drawingml/2006/main">
               <a:ext uri="{FF2B5EF4-FFF2-40B4-BE49-F238E27FC236}">
-                <a16:creationId xmlns:a16="http://schemas.microsoft.com/office/drawing/2014/main" id="{F01BBCE9-EE17-405C-9A3E-B28D62831C40}"/>
+                <a16:creationId xmlns:a16="http://schemas.microsoft.com/office/drawing/2014/main" id="{575DD9F2-A94C-40DA-BAFC-06EC09EAB05F}"/>
               </a:ext>
             </a:extLst>
           </p:cNvPr>
@@ -6306,7 +6306,7 @@
           <p:cNvPr id="3" name="">
             <a:extLst xmlns:a="http://schemas.openxmlformats.org/drawingml/2006/main">
               <a:ext uri="{FF2B5EF4-FFF2-40B4-BE49-F238E27FC236}">
-                <a16:creationId xmlns:a16="http://schemas.microsoft.com/office/drawing/2014/main" id="{3C92E5CD-2E6B-49E2-B7FB-80C9702BB8CB}"/>
+                <a16:creationId xmlns:a16="http://schemas.microsoft.com/office/drawing/2014/main" id="{CD966DEE-8D07-4BB0-9332-16EBA0D1F658}"/>
               </a:ext>
             </a:extLst>
           </p:cNvPr>
@@ -6462,7 +6462,7 @@
           <p:cNvPr id="4" name="">
             <a:extLst xmlns:a="http://schemas.openxmlformats.org/drawingml/2006/main">
               <a:ext uri="{FF2B5EF4-FFF2-40B4-BE49-F238E27FC236}">
-                <a16:creationId xmlns:a16="http://schemas.microsoft.com/office/drawing/2014/main" id="{043F25D2-350A-47BD-9DBF-9A1B08DAB1AA}"/>
+                <a16:creationId xmlns:a16="http://schemas.microsoft.com/office/drawing/2014/main" id="{827E617C-8A8B-401B-8F07-52A4D183249F}"/>
               </a:ext>
             </a:extLst>
           </p:cNvPr>
@@ -7089,7 +7089,7 @@
           <p:cNvPr id="5" name="">
             <a:extLst xmlns:a="http://schemas.openxmlformats.org/drawingml/2006/main">
               <a:ext uri="{FF2B5EF4-FFF2-40B4-BE49-F238E27FC236}">
-                <a16:creationId xmlns:a16="http://schemas.microsoft.com/office/drawing/2014/main" id="{6D8B526E-D55A-4F8E-8B2A-F0E81E7A62E9}"/>
+                <a16:creationId xmlns:a16="http://schemas.microsoft.com/office/drawing/2014/main" id="{2CE0B4D4-E6C6-4CC7-984A-43A6A8965EC0}"/>
               </a:ext>
             </a:extLst>
           </p:cNvPr>
@@ -7243,7 +7243,7 @@
     </p:spTree>
     <p:extLst>
       <p:ext uri="{BB962C8B-B14F-4D97-AF65-F5344CB8AC3E}">
-        <p14:creationId xmlns:p14="http://schemas.microsoft.com/office/powerpoint/2010/main" val="1379592579"/>
+        <p14:creationId xmlns:p14="http://schemas.microsoft.com/office/powerpoint/2010/main" val="1637127022"/>
       </p:ext>
     </p:extLst>
   </p:cSld>
@@ -7274,7 +7274,7 @@
           <p:cNvPr id="9" name="">
             <a:extLst xmlns:a="http://schemas.openxmlformats.org/drawingml/2006/main">
               <a:ext uri="{FF2B5EF4-FFF2-40B4-BE49-F238E27FC236}">
-                <a16:creationId xmlns:a16="http://schemas.microsoft.com/office/drawing/2014/main" id="{E6FEB1F7-FE94-4FC1-8395-8CCC4CEF45DA}"/>
+                <a16:creationId xmlns:a16="http://schemas.microsoft.com/office/drawing/2014/main" id="{47ADBCB2-D834-4051-9FCF-646711594F42}"/>
               </a:ext>
             </a:extLst>
           </p:cNvPr>
@@ -7430,7 +7430,7 @@
           <p:cNvPr id="2" name="">
             <a:extLst xmlns:a="http://schemas.openxmlformats.org/drawingml/2006/main">
               <a:ext uri="{FF2B5EF4-FFF2-40B4-BE49-F238E27FC236}">
-                <a16:creationId xmlns:a16="http://schemas.microsoft.com/office/drawing/2014/main" id="{64FF9670-C5F6-4E93-9FAC-578D7439E192}"/>
+                <a16:creationId xmlns:a16="http://schemas.microsoft.com/office/drawing/2014/main" id="{48DB0C69-3271-46D4-806D-F309C641AF7D}"/>
               </a:ext>
             </a:extLst>
           </p:cNvPr>
@@ -7586,7 +7586,7 @@
           <p:cNvPr id="3" name="">
             <a:extLst xmlns:a="http://schemas.openxmlformats.org/drawingml/2006/main">
               <a:ext uri="{FF2B5EF4-FFF2-40B4-BE49-F238E27FC236}">
-                <a16:creationId xmlns:a16="http://schemas.microsoft.com/office/drawing/2014/main" id="{FA218A86-33A8-4C71-A8B7-C7A60A14BBB1}"/>
+                <a16:creationId xmlns:a16="http://schemas.microsoft.com/office/drawing/2014/main" id="{B1E1E87F-E015-4E2D-9410-844940C02AF3}"/>
               </a:ext>
             </a:extLst>
           </p:cNvPr>
@@ -7742,7 +7742,7 @@
           <p:cNvPr id="4" name="">
             <a:extLst xmlns:a="http://schemas.openxmlformats.org/drawingml/2006/main">
               <a:ext uri="{FF2B5EF4-FFF2-40B4-BE49-F238E27FC236}">
-                <a16:creationId xmlns:a16="http://schemas.microsoft.com/office/drawing/2014/main" id="{DA773F9E-FA4D-4814-A1E4-CA0A5BFE3048}"/>
+                <a16:creationId xmlns:a16="http://schemas.microsoft.com/office/drawing/2014/main" id="{9F2CD625-4476-43F4-ADDC-D687FE3DD30F}"/>
               </a:ext>
             </a:extLst>
           </p:cNvPr>
@@ -7898,7 +7898,7 @@
           <p:cNvPr id="5" name="">
             <a:extLst xmlns:a="http://schemas.openxmlformats.org/drawingml/2006/main">
               <a:ext uri="{FF2B5EF4-FFF2-40B4-BE49-F238E27FC236}">
-                <a16:creationId xmlns:a16="http://schemas.microsoft.com/office/drawing/2014/main" id="{5983E426-2E18-425F-A2C4-523DCBEA0C36}"/>
+                <a16:creationId xmlns:a16="http://schemas.microsoft.com/office/drawing/2014/main" id="{4FFEF8F9-AB22-436A-9FD1-428A9BD94E96}"/>
               </a:ext>
             </a:extLst>
           </p:cNvPr>
@@ -8100,7 +8100,7 @@
           <p:cNvPr id="6" name="">
             <a:extLst xmlns:a="http://schemas.openxmlformats.org/drawingml/2006/main">
               <a:ext uri="{FF2B5EF4-FFF2-40B4-BE49-F238E27FC236}">
-                <a16:creationId xmlns:a16="http://schemas.microsoft.com/office/drawing/2014/main" id="{C0ACC1F5-C052-4FB6-AD6D-C7D531FEEC81}"/>
+                <a16:creationId xmlns:a16="http://schemas.microsoft.com/office/drawing/2014/main" id="{7F4F01F5-4F36-4A62-9725-C32D71AAB3A9}"/>
               </a:ext>
             </a:extLst>
           </p:cNvPr>
@@ -8256,7 +8256,7 @@
           <p:cNvPr id="7" name="">
             <a:extLst xmlns:a="http://schemas.openxmlformats.org/drawingml/2006/main">
               <a:ext uri="{FF2B5EF4-FFF2-40B4-BE49-F238E27FC236}">
-                <a16:creationId xmlns:a16="http://schemas.microsoft.com/office/drawing/2014/main" id="{9936A124-36D9-4A3D-92BF-5455051E67D1}"/>
+                <a16:creationId xmlns:a16="http://schemas.microsoft.com/office/drawing/2014/main" id="{A3D1C57D-36E6-4C5D-8C03-7FF29FAABA92}"/>
               </a:ext>
             </a:extLst>
           </p:cNvPr>
@@ -8458,7 +8458,7 @@
           <p:cNvPr id="8" name="">
             <a:extLst xmlns:a="http://schemas.openxmlformats.org/drawingml/2006/main">
               <a:ext uri="{FF2B5EF4-FFF2-40B4-BE49-F238E27FC236}">
-                <a16:creationId xmlns:a16="http://schemas.microsoft.com/office/drawing/2014/main" id="{E9C2E34F-B29B-4DD5-B127-DA4D967DC68A}"/>
+                <a16:creationId xmlns:a16="http://schemas.microsoft.com/office/drawing/2014/main" id="{BB8C4C62-053A-4363-BB50-EE053B6B797A}"/>
               </a:ext>
             </a:extLst>
           </p:cNvPr>
@@ -8635,7 +8635,7 @@
     </p:spTree>
     <p:extLst>
       <p:ext uri="{BB962C8B-B14F-4D97-AF65-F5344CB8AC3E}">
-        <p14:creationId xmlns:p14="http://schemas.microsoft.com/office/powerpoint/2010/main" val="194005283"/>
+        <p14:creationId xmlns:p14="http://schemas.microsoft.com/office/powerpoint/2010/main" val="954871955"/>
       </p:ext>
     </p:extLst>
   </p:cSld>
@@ -8666,7 +8666,7 @@
           <p:cNvPr id="7" name="">
             <a:extLst xmlns:a="http://schemas.openxmlformats.org/drawingml/2006/main">
               <a:ext uri="{FF2B5EF4-FFF2-40B4-BE49-F238E27FC236}">
-                <a16:creationId xmlns:a16="http://schemas.microsoft.com/office/drawing/2014/main" id="{A65E595B-E8F3-4D9F-B699-DF50BD69C8CC}"/>
+                <a16:creationId xmlns:a16="http://schemas.microsoft.com/office/drawing/2014/main" id="{6913F1D3-D897-4337-9C1A-2A27A8F6EA93}"/>
               </a:ext>
             </a:extLst>
           </p:cNvPr>
@@ -8822,7 +8822,7 @@
           <p:cNvPr id="2" name="">
             <a:extLst xmlns:a="http://schemas.openxmlformats.org/drawingml/2006/main">
               <a:ext uri="{FF2B5EF4-FFF2-40B4-BE49-F238E27FC236}">
-                <a16:creationId xmlns:a16="http://schemas.microsoft.com/office/drawing/2014/main" id="{F3780C60-EB35-4AAD-8E8A-D194ACCA8F99}"/>
+                <a16:creationId xmlns:a16="http://schemas.microsoft.com/office/drawing/2014/main" id="{7B67A859-3E69-46B3-AA12-A4CCDDBC616F}"/>
               </a:ext>
             </a:extLst>
           </p:cNvPr>
@@ -8978,7 +8978,7 @@
           <p:cNvPr id="3" name="">
             <a:extLst xmlns:a="http://schemas.openxmlformats.org/drawingml/2006/main">
               <a:ext uri="{FF2B5EF4-FFF2-40B4-BE49-F238E27FC236}">
-                <a16:creationId xmlns:a16="http://schemas.microsoft.com/office/drawing/2014/main" id="{A5FB4211-1754-4E2D-B953-237EA10D7324}"/>
+                <a16:creationId xmlns:a16="http://schemas.microsoft.com/office/drawing/2014/main" id="{0F03B0DC-C906-4E65-8062-73CE406EA3A8}"/>
               </a:ext>
             </a:extLst>
           </p:cNvPr>
@@ -9134,7 +9134,7 @@
           <p:cNvPr id="4" name="">
             <a:extLst xmlns:a="http://schemas.openxmlformats.org/drawingml/2006/main">
               <a:ext uri="{FF2B5EF4-FFF2-40B4-BE49-F238E27FC236}">
-                <a16:creationId xmlns:a16="http://schemas.microsoft.com/office/drawing/2014/main" id="{1BF5B5DC-B23F-4082-83F5-D8C752C49BA0}"/>
+                <a16:creationId xmlns:a16="http://schemas.microsoft.com/office/drawing/2014/main" id="{6E8D068A-3021-4DF5-A59A-BEA67D3D672D}"/>
               </a:ext>
             </a:extLst>
           </p:cNvPr>
@@ -9644,7 +9644,7 @@
           <p:cNvPr id="5" name="">
             <a:extLst xmlns:a="http://schemas.openxmlformats.org/drawingml/2006/main">
               <a:ext uri="{FF2B5EF4-FFF2-40B4-BE49-F238E27FC236}">
-                <a16:creationId xmlns:a16="http://schemas.microsoft.com/office/drawing/2014/main" id="{C9A627D3-505D-49EC-91CE-C2D592AF047B}"/>
+                <a16:creationId xmlns:a16="http://schemas.microsoft.com/office/drawing/2014/main" id="{12CE89E3-28A3-4968-848D-50B8F49A1DE0}"/>
               </a:ext>
             </a:extLst>
           </p:cNvPr>
@@ -9823,7 +9823,7 @@
           <p:cNvPr id="6" name="">
             <a:extLst xmlns:a="http://schemas.openxmlformats.org/drawingml/2006/main">
               <a:ext uri="{FF2B5EF4-FFF2-40B4-BE49-F238E27FC236}">
-                <a16:creationId xmlns:a16="http://schemas.microsoft.com/office/drawing/2014/main" id="{381605EA-C0CF-41F2-9901-5CB86F8F81E3}"/>
+                <a16:creationId xmlns:a16="http://schemas.microsoft.com/office/drawing/2014/main" id="{AED7886E-A416-4492-BDE6-2FC75921E3C6}"/>
               </a:ext>
             </a:extLst>
           </p:cNvPr>
@@ -10000,7 +10000,7 @@
     </p:spTree>
     <p:extLst>
       <p:ext uri="{BB962C8B-B14F-4D97-AF65-F5344CB8AC3E}">
-        <p14:creationId xmlns:p14="http://schemas.microsoft.com/office/powerpoint/2010/main" val="413752961"/>
+        <p14:creationId xmlns:p14="http://schemas.microsoft.com/office/powerpoint/2010/main" val="1251662375"/>
       </p:ext>
     </p:extLst>
   </p:cSld>
@@ -10031,7 +10031,7 @@
           <p:cNvPr id="9" name="">
             <a:extLst xmlns:a="http://schemas.openxmlformats.org/drawingml/2006/main">
               <a:ext uri="{FF2B5EF4-FFF2-40B4-BE49-F238E27FC236}">
-                <a16:creationId xmlns:a16="http://schemas.microsoft.com/office/drawing/2014/main" id="{3DA427F7-F7BB-48BE-9994-6F20FB9EE1DC}"/>
+                <a16:creationId xmlns:a16="http://schemas.microsoft.com/office/drawing/2014/main" id="{479CEDDD-CF8F-4228-8C90-7F44ECFCCBA5}"/>
               </a:ext>
             </a:extLst>
           </p:cNvPr>
@@ -10187,7 +10187,7 @@
           <p:cNvPr id="2" name="">
             <a:extLst xmlns:a="http://schemas.openxmlformats.org/drawingml/2006/main">
               <a:ext uri="{FF2B5EF4-FFF2-40B4-BE49-F238E27FC236}">
-                <a16:creationId xmlns:a16="http://schemas.microsoft.com/office/drawing/2014/main" id="{FA778563-D586-47F4-AFE3-1F4A318C9962}"/>
+                <a16:creationId xmlns:a16="http://schemas.microsoft.com/office/drawing/2014/main" id="{4928E991-3C05-4898-8850-3685C7429DD1}"/>
               </a:ext>
             </a:extLst>
           </p:cNvPr>
@@ -10343,7 +10343,7 @@
           <p:cNvPr id="3" name="">
             <a:extLst xmlns:a="http://schemas.openxmlformats.org/drawingml/2006/main">
               <a:ext uri="{FF2B5EF4-FFF2-40B4-BE49-F238E27FC236}">
-                <a16:creationId xmlns:a16="http://schemas.microsoft.com/office/drawing/2014/main" id="{AFED7EA2-A263-49B1-9B36-CD781F5AB0D0}"/>
+                <a16:creationId xmlns:a16="http://schemas.microsoft.com/office/drawing/2014/main" id="{92F5D0A8-3E2B-44DA-9BC5-BDD958CF390D}"/>
               </a:ext>
             </a:extLst>
           </p:cNvPr>
@@ -10499,7 +10499,7 @@
           <p:cNvPr id="4" name="">
             <a:extLst xmlns:a="http://schemas.openxmlformats.org/drawingml/2006/main">
               <a:ext uri="{FF2B5EF4-FFF2-40B4-BE49-F238E27FC236}">
-                <a16:creationId xmlns:a16="http://schemas.microsoft.com/office/drawing/2014/main" id="{33B53640-270E-469C-9DF2-266D239F9E8B}"/>
+                <a16:creationId xmlns:a16="http://schemas.microsoft.com/office/drawing/2014/main" id="{5BDE0F08-14C6-4D82-BE88-A05C8904CE01}"/>
               </a:ext>
             </a:extLst>
           </p:cNvPr>
@@ -10655,7 +10655,7 @@
           <p:cNvPr id="5" name="">
             <a:extLst xmlns:a="http://schemas.openxmlformats.org/drawingml/2006/main">
               <a:ext uri="{FF2B5EF4-FFF2-40B4-BE49-F238E27FC236}">
-                <a16:creationId xmlns:a16="http://schemas.microsoft.com/office/drawing/2014/main" id="{F5838BE5-CE9E-4AA0-A1C8-CE4016CB8E57}"/>
+                <a16:creationId xmlns:a16="http://schemas.microsoft.com/office/drawing/2014/main" id="{63F1B255-8E31-4D17-814C-F91E462A9564}"/>
               </a:ext>
             </a:extLst>
           </p:cNvPr>
@@ -10834,7 +10834,7 @@
           <p:cNvPr id="6" name="">
             <a:extLst xmlns:a="http://schemas.openxmlformats.org/drawingml/2006/main">
               <a:ext uri="{FF2B5EF4-FFF2-40B4-BE49-F238E27FC236}">
-                <a16:creationId xmlns:a16="http://schemas.microsoft.com/office/drawing/2014/main" id="{906DDA3C-ED32-4A09-AF92-3D0EA839FE43}"/>
+                <a16:creationId xmlns:a16="http://schemas.microsoft.com/office/drawing/2014/main" id="{AB4AD61D-F5CA-47DC-91D7-248397419D48}"/>
               </a:ext>
             </a:extLst>
           </p:cNvPr>
@@ -10990,7 +10990,7 @@
           <p:cNvPr id="7" name="">
             <a:extLst xmlns:a="http://schemas.openxmlformats.org/drawingml/2006/main">
               <a:ext uri="{FF2B5EF4-FFF2-40B4-BE49-F238E27FC236}">
-                <a16:creationId xmlns:a16="http://schemas.microsoft.com/office/drawing/2014/main" id="{5E2840AA-7202-403A-B6D4-546675ACC29E}"/>
+                <a16:creationId xmlns:a16="http://schemas.microsoft.com/office/drawing/2014/main" id="{BD0F51C5-E534-486F-9D64-D88568DA0177}"/>
               </a:ext>
             </a:extLst>
           </p:cNvPr>
@@ -11169,7 +11169,7 @@
           <p:cNvPr id="8" name="">
             <a:extLst xmlns:a="http://schemas.openxmlformats.org/drawingml/2006/main">
               <a:ext uri="{FF2B5EF4-FFF2-40B4-BE49-F238E27FC236}">
-                <a16:creationId xmlns:a16="http://schemas.microsoft.com/office/drawing/2014/main" id="{B93C532E-AA97-48F5-B48F-95AD37ECC439}"/>
+                <a16:creationId xmlns:a16="http://schemas.microsoft.com/office/drawing/2014/main" id="{9D5A99F6-6AF2-472E-A7FA-2BD87A6F5BD3}"/>
               </a:ext>
             </a:extLst>
           </p:cNvPr>
@@ -11346,7 +11346,7 @@
     </p:spTree>
     <p:extLst>
       <p:ext uri="{BB962C8B-B14F-4D97-AF65-F5344CB8AC3E}">
-        <p14:creationId xmlns:p14="http://schemas.microsoft.com/office/powerpoint/2010/main" val="1445751433"/>
+        <p14:creationId xmlns:p14="http://schemas.microsoft.com/office/powerpoint/2010/main" val="669391018"/>
       </p:ext>
     </p:extLst>
   </p:cSld>

</xml_diff>

<commit_message>
Polish project documentation and presentation notes
</commit_message>
<xml_diff>
--- a/submission/ModelCheck_Capstone.pptx
+++ b/submission/ModelCheck_Capstone.pptx
@@ -2,18 +2,18 @@
 <file path=ppt/presentation.xml><?xml version="1.0" encoding="utf-8"?>
 <p:presentation xmlns:p="http://schemas.openxmlformats.org/presentationml/2006/main">
   <p:sldMasterIdLst>
-    <p:sldMasterId xmlns:r="http://schemas.openxmlformats.org/officeDocument/2006/relationships" id="2147483648" r:id="Rcbba99485d024769"/>
+    <p:sldMasterId xmlns:r="http://schemas.openxmlformats.org/officeDocument/2006/relationships" id="2147483648" r:id="Raa3bd2e7efd045e3"/>
   </p:sldMasterIdLst>
   <p:notesMasterIdLst>
-    <p:notesMasterId xmlns:r="http://schemas.openxmlformats.org/officeDocument/2006/relationships" r:id="Rc532ff39f4f1444b"/>
+    <p:notesMasterId xmlns:r="http://schemas.openxmlformats.org/officeDocument/2006/relationships" r:id="R25b5f492226c47a7"/>
   </p:notesMasterIdLst>
   <p:sldIdLst>
-    <p:sldId xmlns:r="http://schemas.openxmlformats.org/officeDocument/2006/relationships" id="256" r:id="R21f32971941f4e73"/>
-    <p:sldId xmlns:r="http://schemas.openxmlformats.org/officeDocument/2006/relationships" id="257" r:id="R9acf1e5f96b84d96"/>
-    <p:sldId xmlns:r="http://schemas.openxmlformats.org/officeDocument/2006/relationships" id="258" r:id="R09b5ceee378d4a82"/>
-    <p:sldId xmlns:r="http://schemas.openxmlformats.org/officeDocument/2006/relationships" id="259" r:id="R83f1b96813b24e0e"/>
-    <p:sldId xmlns:r="http://schemas.openxmlformats.org/officeDocument/2006/relationships" id="260" r:id="R4eb31664e44d4ec7"/>
-    <p:sldId xmlns:r="http://schemas.openxmlformats.org/officeDocument/2006/relationships" id="261" r:id="R7cf1dd34ba6f497b"/>
+    <p:sldId xmlns:r="http://schemas.openxmlformats.org/officeDocument/2006/relationships" id="256" r:id="R1113b8f1c7174f36"/>
+    <p:sldId xmlns:r="http://schemas.openxmlformats.org/officeDocument/2006/relationships" id="257" r:id="R4011923905e84c48"/>
+    <p:sldId xmlns:r="http://schemas.openxmlformats.org/officeDocument/2006/relationships" id="258" r:id="R67a702c755e740fa"/>
+    <p:sldId xmlns:r="http://schemas.openxmlformats.org/officeDocument/2006/relationships" id="259" r:id="Rc77d3a369d2043d6"/>
+    <p:sldId xmlns:r="http://schemas.openxmlformats.org/officeDocument/2006/relationships" id="260" r:id="R40cac453eec54f92"/>
+    <p:sldId xmlns:r="http://schemas.openxmlformats.org/officeDocument/2006/relationships" id="261" r:id="Raf1112d3b13a4f26"/>
   </p:sldIdLst>
   <p:sldSz cx="12192000" cy="6858000"/>
   <p:notesSz cx="6858000" cy="9144000"/>
@@ -447,7 +447,7 @@
           <a:lstStyle xmlns:a="http://schemas.openxmlformats.org/drawingml/2006/main"/>
           <a:p xmlns:a="http://schemas.openxmlformats.org/drawingml/2006/main">
             <a:r>
-              <a:t>Problem: developers can report a good aggregate score while missing source-specific errors, incomplete coverage or unreliable provenance. Sources: README.md; ../labs/capstone/README.md.</a:t>
+              <a:t>ModelCheck reviews classification experiment exports for aggregate and source-specific errors, coverage and provenance. Sources: README.md; SDAIA capstone requirements at https://github.com/SDAIAAcademy/agentic-ai/tree/main/labs/capstone.</a:t>
             </a:r>
           </a:p>
         </p:txBody>
@@ -517,7 +517,7 @@
           <a:lstStyle xmlns:a="http://schemas.openxmlformats.org/drawingml/2006/main"/>
           <a:p xmlns:a="http://schemas.openxmlformats.org/drawingml/2006/main">
             <a:r>
-              <a:t>Live demonstration: load sample, inspect source rows, select recorded AI review if quota is constrained, draft a validation-only follow-up, reject or approve. Source: samples.py and data.py; baseline counts tn18 fp2 fn2 tp18, candidate tn19 fp1 fn5 tp15. Descriptive comparison only, no causal or significance claim.</a:t>
+              <a:t>The synthetic fixture contains 40 test examples. Baseline counts: tn 18, fp 2, fn 2, tp 18. Candidate counts: tn 19, fp 1, fn 5, tp 15. The demo supports sample inspection, recorded or live review and an approved validation-only follow-up specification. Source: samples.py and data.py. Differences are descriptive; the fixture provides no causal or statistical-significance evidence.</a:t>
             </a:r>
           </a:p>
         </p:txBody>
@@ -587,7 +587,7 @@
           <a:lstStyle xmlns:a="http://schemas.openxmlformats.org/drawingml/2006/main"/>
           <a:p xmlns:a="http://schemas.openxmlformats.org/drawingml/2006/main">
             <a:r>
-              <a:t>Architecture source: app.py, bridge.py, mcp_server.py and store.py. Four tools actually run across stdio MCP. The runtime has no shell or arbitrary URL tool. Local UI does not imply local inference. ModelCheck posts bounded tool results to OpenRouter.</a:t>
+              <a:t>Browser requests pass through the local FastAPI session boundary. Four read tools use stdio MCP. SQLite stores evidence and pending actions; the approval handler controls the exact file save. Live inference sends questions and bounded tool results to OpenRouter. Sources: app.py, bridge.py, mcp_server.py and store.py.</a:t>
             </a:r>
           </a:p>
         </p:txBody>
@@ -657,7 +657,7 @@
           <a:lstStyle xmlns:a="http://schemas.openxmlformats.org/drawingml/2006/main"/>
           <a:p xmlns:a="http://schemas.openxmlformats.org/drawingml/2006/main">
             <a:r>
-              <a:t>Sources: agent.py, store.py, skills/review-experiment/SKILL.md and submission/traces. Additional caps: 16 tool executions, 1200 output tokens/call, 30000 cumulative reported tokens, 180 seconds and USD0.05 estimated cost. One early development run hit the token budget and is not a completed evaluation. No LangGraph or multi-agent requirement applies to this Track 2 capstone.</a:t>
+              <a:t>The runtime offers on-demand protocol retrieval, evidence IDs and bounded context. Observed protocol invocation is inconsistent. Additional caps: 16 tool executions, 1,200 output tokens per call, 30,000 cumulative reported tokens, 180 seconds and USD 0.05 estimated cost. One unscored development run reached the token budget. Sources: agent.py, store.py, skills/review-experiment/SKILL.md and submission/traces.</a:t>
             </a:r>
           </a:p>
         </p:txBody>
@@ -727,7 +727,7 @@
           <a:lstStyle xmlns:a="http://schemas.openxmlformats.org/drawingml/2006/main"/>
           <a:p xmlns:a="http://schemas.openxmlformats.org/drawingml/2006/main">
             <a:r>
-              <a:t>Sources: submission/summary.json, A.csv, B.csv and matched-comparison-B trace. Eighteen frozen tasks exist. Only six paired tasks ran. B used two compute_metrics calls, produced -5 percentage points, and skipped compare_runs; tool-compliance and comparison-outcome graders failed. Review the grader boundary before concluding that the answer was wrong. Retain the recorded failure rather than changing gold tasks. Both configurations share the same code-enforced safety controls.</a:t>
+              <a:t>Eighteen tasks define 36 scheduled reviews across A and B. Six paired tasks executed. B used two compute_metrics calls for matched-comparison and returned the correct minus-five-percentage-point accuracy delta, but omitted compare_runs. The tool-use and comparison-outcome graders failed. Both configurations use identical application controls. Sources: submission/summary.json, A.csv, B.csv and traces/matched-comparison-B.json.</a:t>
             </a:r>
           </a:p>
         </p:txBody>
@@ -797,7 +797,7 @@
           <a:lstStyle xmlns:a="http://schemas.openxmlformats.org/drawingml/2006/main"/>
           <a:p xmlns:a="http://schemas.openxmlformats.org/drawingml/2006/main">
             <a:r>
-              <a:t>Sources: submission/security/live-attack.json, SECURITY.md, tests/test_core.py and tests/test_agent.py. The live attack took two requests and called inspect_manifest only. Model refusal for one fixture does not prove universal injection resistance. Mandatory live security/action evaluation rows remain pending. UI approval and handler positive controls exercised actual saved JSON. No production or legal compliance certification is claimed.</a:t>
+              <a:t>The live malicious-description test used two requests and called inspect_manifest only. It reported the injection and created no pending action or file. Handler tests separately cover path fields, tampered digests, foreign sessions and valid saves. Broader live security and action evaluations remain pending. Sources: submission/security/live-attack.json, SECURITY.md, tests/test_core.py and tests/test_agent.py.</a:t>
             </a:r>
           </a:p>
         </p:txBody>
@@ -844,7 +844,7 @@
           <p:cNvPr id="3" name="Title">
             <a:extLst xmlns:a="http://schemas.openxmlformats.org/drawingml/2006/main">
               <a:ext uri="{FF2B5EF4-FFF2-40B4-BE49-F238E27FC236}">
-                <a16:creationId xmlns:a16="http://schemas.microsoft.com/office/drawing/2014/main" id="{0B055A38-EDB6-415C-96F8-2D5571C4FE47}"/>
+                <a16:creationId xmlns:a16="http://schemas.microsoft.com/office/drawing/2014/main" id="{ADAF05B3-FD25-43CA-9487-7D7D4740C78D}"/>
               </a:ext>
             </a:extLst>
           </p:cNvPr>
@@ -1073,7 +1073,7 @@
           <p:cNvPr id="2" name="Subtitle">
             <a:extLst xmlns:a="http://schemas.openxmlformats.org/drawingml/2006/main">
               <a:ext uri="{FF2B5EF4-FFF2-40B4-BE49-F238E27FC236}">
-                <a16:creationId xmlns:a16="http://schemas.microsoft.com/office/drawing/2014/main" id="{4AC41EA8-C913-4B75-B73E-CA06672A2F4A}"/>
+                <a16:creationId xmlns:a16="http://schemas.microsoft.com/office/drawing/2014/main" id="{2C4A1F26-03ED-431C-8E39-3540CB5F5489}"/>
               </a:ext>
             </a:extLst>
           </p:cNvPr>
@@ -1319,7 +1319,7 @@
           <p:cNvPr id="2" name="Section title">
             <a:extLst xmlns:a="http://schemas.openxmlformats.org/drawingml/2006/main">
               <a:ext uri="{FF2B5EF4-FFF2-40B4-BE49-F238E27FC236}">
-                <a16:creationId xmlns:a16="http://schemas.microsoft.com/office/drawing/2014/main" id="{1E10736F-2762-4EE0-A4B9-25B80C13220B}"/>
+                <a16:creationId xmlns:a16="http://schemas.microsoft.com/office/drawing/2014/main" id="{1A0B0784-4245-4264-8BFE-944FED781C56}"/>
               </a:ext>
             </a:extLst>
           </p:cNvPr>
@@ -1565,7 +1565,7 @@
           <p:cNvPr id="3" name="Title">
             <a:extLst xmlns:a="http://schemas.openxmlformats.org/drawingml/2006/main">
               <a:ext uri="{FF2B5EF4-FFF2-40B4-BE49-F238E27FC236}">
-                <a16:creationId xmlns:a16="http://schemas.microsoft.com/office/drawing/2014/main" id="{4BEB8804-A834-4E16-90DE-D2E05808577C}"/>
+                <a16:creationId xmlns:a16="http://schemas.microsoft.com/office/drawing/2014/main" id="{002B8807-C4CA-4D85-AD67-2546F59D9148}"/>
               </a:ext>
             </a:extLst>
           </p:cNvPr>
@@ -1794,7 +1794,7 @@
           <p:cNvPr id="2" name="Body">
             <a:extLst xmlns:a="http://schemas.openxmlformats.org/drawingml/2006/main">
               <a:ext uri="{FF2B5EF4-FFF2-40B4-BE49-F238E27FC236}">
-                <a16:creationId xmlns:a16="http://schemas.microsoft.com/office/drawing/2014/main" id="{11DC3C67-B2E4-49E0-94E5-CBC243E626F9}"/>
+                <a16:creationId xmlns:a16="http://schemas.microsoft.com/office/drawing/2014/main" id="{6550346C-8B6C-4ED6-AF3F-3B137F90D16C}"/>
               </a:ext>
             </a:extLst>
           </p:cNvPr>
@@ -2040,7 +2040,7 @@
           <p:cNvPr id="4" name="Title">
             <a:extLst xmlns:a="http://schemas.openxmlformats.org/drawingml/2006/main">
               <a:ext uri="{FF2B5EF4-FFF2-40B4-BE49-F238E27FC236}">
-                <a16:creationId xmlns:a16="http://schemas.microsoft.com/office/drawing/2014/main" id="{55015270-D17D-4B98-AB08-2948F1B92E25}"/>
+                <a16:creationId xmlns:a16="http://schemas.microsoft.com/office/drawing/2014/main" id="{DB116AC6-E19A-4D91-99F5-2FB3D6F67A4A}"/>
               </a:ext>
             </a:extLst>
           </p:cNvPr>
@@ -2269,7 +2269,7 @@
           <p:cNvPr id="2" name="Left column">
             <a:extLst xmlns:a="http://schemas.openxmlformats.org/drawingml/2006/main">
               <a:ext uri="{FF2B5EF4-FFF2-40B4-BE49-F238E27FC236}">
-                <a16:creationId xmlns:a16="http://schemas.microsoft.com/office/drawing/2014/main" id="{0A5ACB6D-723B-452D-8B90-3F7BD52EE5A4}"/>
+                <a16:creationId xmlns:a16="http://schemas.microsoft.com/office/drawing/2014/main" id="{C23DF8A5-7E22-4D30-92E9-AC8950F5D3FE}"/>
               </a:ext>
             </a:extLst>
           </p:cNvPr>
@@ -2498,7 +2498,7 @@
           <p:cNvPr id="3" name="Right column">
             <a:extLst xmlns:a="http://schemas.openxmlformats.org/drawingml/2006/main">
               <a:ext uri="{FF2B5EF4-FFF2-40B4-BE49-F238E27FC236}">
-                <a16:creationId xmlns:a16="http://schemas.microsoft.com/office/drawing/2014/main" id="{578D9EAE-D28F-41AC-BBBF-57B163082573}"/>
+                <a16:creationId xmlns:a16="http://schemas.microsoft.com/office/drawing/2014/main" id="{9CCE6DE1-A56D-4A25-80F7-627B5E67D316}"/>
               </a:ext>
             </a:extLst>
           </p:cNvPr>
@@ -2744,7 +2744,7 @@
           <p:cNvPr id="3" name="Title">
             <a:extLst xmlns:a="http://schemas.openxmlformats.org/drawingml/2006/main">
               <a:ext uri="{FF2B5EF4-FFF2-40B4-BE49-F238E27FC236}">
-                <a16:creationId xmlns:a16="http://schemas.microsoft.com/office/drawing/2014/main" id="{A685FD02-5F2C-466D-BAE2-CB3F257AD926}"/>
+                <a16:creationId xmlns:a16="http://schemas.microsoft.com/office/drawing/2014/main" id="{6E2144FF-B775-43F6-BA1B-4FFB4BDD8A74}"/>
               </a:ext>
             </a:extLst>
           </p:cNvPr>
@@ -2973,7 +2973,7 @@
           <p:cNvPr id="2" name="Left column">
             <a:extLst xmlns:a="http://schemas.openxmlformats.org/drawingml/2006/main">
               <a:ext uri="{FF2B5EF4-FFF2-40B4-BE49-F238E27FC236}">
-                <a16:creationId xmlns:a16="http://schemas.microsoft.com/office/drawing/2014/main" id="{ED06A847-262E-4DE5-B6E8-2AFA92E422C9}"/>
+                <a16:creationId xmlns:a16="http://schemas.microsoft.com/office/drawing/2014/main" id="{D3445C89-D363-4D20-A433-D5F9994C5EED}"/>
               </a:ext>
             </a:extLst>
           </p:cNvPr>
@@ -3240,12 +3240,12 @@
   </p:cSld>
   <p:clrMap bg1="lt1" tx1="dk1" bg2="lt2" tx2="dk2" accent1="accent1" accent2="accent2" accent3="accent3" accent4="accent4" accent5="accent5" accent6="accent6" hlink="hlink" folHlink="folHlink"/>
   <p:sldLayoutIdLst>
-    <p:sldLayoutId xmlns:r="http://schemas.openxmlformats.org/officeDocument/2006/relationships" id="2147483649" r:id="R5b51370f78dd4b1a"/>
-    <p:sldLayoutId xmlns:r="http://schemas.openxmlformats.org/officeDocument/2006/relationships" id="2147483650" r:id="Ree3277e6d1b84294"/>
-    <p:sldLayoutId xmlns:r="http://schemas.openxmlformats.org/officeDocument/2006/relationships" id="2147483651" r:id="R5d8ae103e3e140e8"/>
-    <p:sldLayoutId xmlns:r="http://schemas.openxmlformats.org/officeDocument/2006/relationships" id="2147483652" r:id="R6ab888e89de94ead"/>
-    <p:sldLayoutId xmlns:r="http://schemas.openxmlformats.org/officeDocument/2006/relationships" id="2147483653" r:id="Rc12c9526562e45a1"/>
-    <p:sldLayoutId xmlns:r="http://schemas.openxmlformats.org/officeDocument/2006/relationships" id="2147483654" r:id="R8f767aefb2e0497e"/>
+    <p:sldLayoutId xmlns:r="http://schemas.openxmlformats.org/officeDocument/2006/relationships" id="2147483649" r:id="R5929986f24c2431b"/>
+    <p:sldLayoutId xmlns:r="http://schemas.openxmlformats.org/officeDocument/2006/relationships" id="2147483650" r:id="R8c5e24f8923f4f33"/>
+    <p:sldLayoutId xmlns:r="http://schemas.openxmlformats.org/officeDocument/2006/relationships" id="2147483651" r:id="Rac0f7d8c4fcb4634"/>
+    <p:sldLayoutId xmlns:r="http://schemas.openxmlformats.org/officeDocument/2006/relationships" id="2147483652" r:id="R050a53ea655d4be6"/>
+    <p:sldLayoutId xmlns:r="http://schemas.openxmlformats.org/officeDocument/2006/relationships" id="2147483653" r:id="Rb63e435307f741d8"/>
+    <p:sldLayoutId xmlns:r="http://schemas.openxmlformats.org/officeDocument/2006/relationships" id="2147483654" r:id="R22beb598a3d24566"/>
   </p:sldLayoutIdLst>
   <p:txStyles>
     <p:titleStyle>
@@ -3796,7 +3796,7 @@
           <p:cNvPr id="6" name="">
             <a:extLst xmlns:a="http://schemas.openxmlformats.org/drawingml/2006/main">
               <a:ext uri="{FF2B5EF4-FFF2-40B4-BE49-F238E27FC236}">
-                <a16:creationId xmlns:a16="http://schemas.microsoft.com/office/drawing/2014/main" id="{F5E36BA3-F1EB-45B9-9D49-9F1626EF38B1}"/>
+                <a16:creationId xmlns:a16="http://schemas.microsoft.com/office/drawing/2014/main" id="{22BC544D-88D0-400D-B236-66C815D36531}"/>
               </a:ext>
             </a:extLst>
           </p:cNvPr>
@@ -3952,7 +3952,7 @@
           <p:cNvPr id="2" name="">
             <a:extLst xmlns:a="http://schemas.openxmlformats.org/drawingml/2006/main">
               <a:ext uri="{FF2B5EF4-FFF2-40B4-BE49-F238E27FC236}">
-                <a16:creationId xmlns:a16="http://schemas.microsoft.com/office/drawing/2014/main" id="{6300A597-EC74-4D5B-A811-774B515C2F76}"/>
+                <a16:creationId xmlns:a16="http://schemas.microsoft.com/office/drawing/2014/main" id="{B5FEB4C0-644A-4B72-BFD3-BE2636A2439A}"/>
               </a:ext>
             </a:extLst>
           </p:cNvPr>
@@ -4108,7 +4108,7 @@
           <p:cNvPr id="3" name="">
             <a:extLst xmlns:a="http://schemas.openxmlformats.org/drawingml/2006/main">
               <a:ext uri="{FF2B5EF4-FFF2-40B4-BE49-F238E27FC236}">
-                <a16:creationId xmlns:a16="http://schemas.microsoft.com/office/drawing/2014/main" id="{10DBFC3B-C4DD-4AC9-9CFA-5A86B46BF047}"/>
+                <a16:creationId xmlns:a16="http://schemas.microsoft.com/office/drawing/2014/main" id="{899D92C5-68A2-4283-90DB-51BFA9292D91}"/>
               </a:ext>
             </a:extLst>
           </p:cNvPr>
@@ -4264,7 +4264,7 @@
           <p:cNvPr id="4" name="">
             <a:extLst xmlns:a="http://schemas.openxmlformats.org/drawingml/2006/main">
               <a:ext uri="{FF2B5EF4-FFF2-40B4-BE49-F238E27FC236}">
-                <a16:creationId xmlns:a16="http://schemas.microsoft.com/office/drawing/2014/main" id="{DE218C72-E39D-4B2C-9217-A607B46CA4FC}"/>
+                <a16:creationId xmlns:a16="http://schemas.microsoft.com/office/drawing/2014/main" id="{5ECE3725-817D-418F-B129-AB9F49F4FE61}"/>
               </a:ext>
             </a:extLst>
           </p:cNvPr>
@@ -4443,7 +4443,7 @@
           <p:cNvPr id="5" name="">
             <a:extLst xmlns:a="http://schemas.openxmlformats.org/drawingml/2006/main">
               <a:ext uri="{FF2B5EF4-FFF2-40B4-BE49-F238E27FC236}">
-                <a16:creationId xmlns:a16="http://schemas.microsoft.com/office/drawing/2014/main" id="{C700F9E3-5CFA-4458-A2FD-E154056AB752}"/>
+                <a16:creationId xmlns:a16="http://schemas.microsoft.com/office/drawing/2014/main" id="{BF1992BF-7AA1-4B92-8489-923277D39AF3}"/>
               </a:ext>
             </a:extLst>
           </p:cNvPr>
@@ -4620,7 +4620,7 @@
     </p:spTree>
     <p:extLst>
       <p:ext uri="{BB962C8B-B14F-4D97-AF65-F5344CB8AC3E}">
-        <p14:creationId xmlns:p14="http://schemas.microsoft.com/office/powerpoint/2010/main" val="1191174934"/>
+        <p14:creationId xmlns:p14="http://schemas.microsoft.com/office/powerpoint/2010/main" val="2003658697"/>
       </p:ext>
     </p:extLst>
   </p:cSld>
@@ -4651,7 +4651,7 @@
           <p:cNvPr id="7" name="">
             <a:extLst xmlns:a="http://schemas.openxmlformats.org/drawingml/2006/main">
               <a:ext uri="{FF2B5EF4-FFF2-40B4-BE49-F238E27FC236}">
-                <a16:creationId xmlns:a16="http://schemas.microsoft.com/office/drawing/2014/main" id="{9E791CED-5C13-449E-A88C-A782A6E47D5D}"/>
+                <a16:creationId xmlns:a16="http://schemas.microsoft.com/office/drawing/2014/main" id="{8E2C5154-B0F5-48C7-BA42-3F5478021EC3}"/>
               </a:ext>
             </a:extLst>
           </p:cNvPr>
@@ -4807,7 +4807,7 @@
           <p:cNvPr id="2" name="">
             <a:extLst xmlns:a="http://schemas.openxmlformats.org/drawingml/2006/main">
               <a:ext uri="{FF2B5EF4-FFF2-40B4-BE49-F238E27FC236}">
-                <a16:creationId xmlns:a16="http://schemas.microsoft.com/office/drawing/2014/main" id="{69618C86-2519-4E4E-9E94-BC6DCD00E6E7}"/>
+                <a16:creationId xmlns:a16="http://schemas.microsoft.com/office/drawing/2014/main" id="{576C1B7F-4D95-4392-A864-99F29D175E21}"/>
               </a:ext>
             </a:extLst>
           </p:cNvPr>
@@ -4963,7 +4963,7 @@
           <p:cNvPr id="3" name="">
             <a:extLst xmlns:a="http://schemas.openxmlformats.org/drawingml/2006/main">
               <a:ext uri="{FF2B5EF4-FFF2-40B4-BE49-F238E27FC236}">
-                <a16:creationId xmlns:a16="http://schemas.microsoft.com/office/drawing/2014/main" id="{882D4488-E980-4AC8-8DDD-03B11A11F7C2}"/>
+                <a16:creationId xmlns:a16="http://schemas.microsoft.com/office/drawing/2014/main" id="{5ACDABED-CE7F-4702-9BF6-4831C411B249}"/>
               </a:ext>
             </a:extLst>
           </p:cNvPr>
@@ -5119,7 +5119,7 @@
           <p:cNvPr id="4" name="">
             <a:extLst xmlns:a="http://schemas.openxmlformats.org/drawingml/2006/main">
               <a:ext uri="{FF2B5EF4-FFF2-40B4-BE49-F238E27FC236}">
-                <a16:creationId xmlns:a16="http://schemas.microsoft.com/office/drawing/2014/main" id="{08AF86DA-2B7B-4C0E-9E6C-23E5F313CAAC}"/>
+                <a16:creationId xmlns:a16="http://schemas.microsoft.com/office/drawing/2014/main" id="{F3ACAC91-14DD-476A-BB95-064847F8AD92}"/>
               </a:ext>
             </a:extLst>
           </p:cNvPr>
@@ -5275,7 +5275,7 @@
           <p:cNvPr id="5" name="">
             <a:extLst xmlns:a="http://schemas.openxmlformats.org/drawingml/2006/main">
               <a:ext uri="{FF2B5EF4-FFF2-40B4-BE49-F238E27FC236}">
-                <a16:creationId xmlns:a16="http://schemas.microsoft.com/office/drawing/2014/main" id="{95F3FFB3-4F16-43FD-BEF0-AB1F8A64A60D}"/>
+                <a16:creationId xmlns:a16="http://schemas.microsoft.com/office/drawing/2014/main" id="{5973BDDA-7E14-4A68-865B-2539A26ABD8F}"/>
               </a:ext>
             </a:extLst>
           </p:cNvPr>
@@ -5786,7 +5786,7 @@
           <p:cNvPr id="6" name="">
             <a:extLst xmlns:a="http://schemas.openxmlformats.org/drawingml/2006/main">
               <a:ext uri="{FF2B5EF4-FFF2-40B4-BE49-F238E27FC236}">
-                <a16:creationId xmlns:a16="http://schemas.microsoft.com/office/drawing/2014/main" id="{ACBD4758-9643-4EA0-9790-2096F31ABD87}"/>
+                <a16:creationId xmlns:a16="http://schemas.microsoft.com/office/drawing/2014/main" id="{B009466B-279B-4D2D-8378-2413EE6B376F}"/>
               </a:ext>
             </a:extLst>
           </p:cNvPr>
@@ -5963,7 +5963,7 @@
     </p:spTree>
     <p:extLst>
       <p:ext uri="{BB962C8B-B14F-4D97-AF65-F5344CB8AC3E}">
-        <p14:creationId xmlns:p14="http://schemas.microsoft.com/office/powerpoint/2010/main" val="279968203"/>
+        <p14:creationId xmlns:p14="http://schemas.microsoft.com/office/powerpoint/2010/main" val="571809844"/>
       </p:ext>
     </p:extLst>
   </p:cSld>
@@ -5994,7 +5994,7 @@
           <p:cNvPr id="6" name="">
             <a:extLst xmlns:a="http://schemas.openxmlformats.org/drawingml/2006/main">
               <a:ext uri="{FF2B5EF4-FFF2-40B4-BE49-F238E27FC236}">
-                <a16:creationId xmlns:a16="http://schemas.microsoft.com/office/drawing/2014/main" id="{81931FEF-23C5-44A7-B943-C8826DD3FACF}"/>
+                <a16:creationId xmlns:a16="http://schemas.microsoft.com/office/drawing/2014/main" id="{4B0AECDA-6C3E-4F56-8500-CB4892C4131C}"/>
               </a:ext>
             </a:extLst>
           </p:cNvPr>
@@ -6150,7 +6150,7 @@
           <p:cNvPr id="2" name="">
             <a:extLst xmlns:a="http://schemas.openxmlformats.org/drawingml/2006/main">
               <a:ext uri="{FF2B5EF4-FFF2-40B4-BE49-F238E27FC236}">
-                <a16:creationId xmlns:a16="http://schemas.microsoft.com/office/drawing/2014/main" id="{575DD9F2-A94C-40DA-BAFC-06EC09EAB05F}"/>
+                <a16:creationId xmlns:a16="http://schemas.microsoft.com/office/drawing/2014/main" id="{E47D1EC3-4D1C-4066-AED4-76AF042AD8B9}"/>
               </a:ext>
             </a:extLst>
           </p:cNvPr>
@@ -6306,7 +6306,7 @@
           <p:cNvPr id="3" name="">
             <a:extLst xmlns:a="http://schemas.openxmlformats.org/drawingml/2006/main">
               <a:ext uri="{FF2B5EF4-FFF2-40B4-BE49-F238E27FC236}">
-                <a16:creationId xmlns:a16="http://schemas.microsoft.com/office/drawing/2014/main" id="{CD966DEE-8D07-4BB0-9332-16EBA0D1F658}"/>
+                <a16:creationId xmlns:a16="http://schemas.microsoft.com/office/drawing/2014/main" id="{68199EC2-4DEB-469C-8AB4-108105DCB611}"/>
               </a:ext>
             </a:extLst>
           </p:cNvPr>
@@ -6462,7 +6462,7 @@
           <p:cNvPr id="4" name="">
             <a:extLst xmlns:a="http://schemas.openxmlformats.org/drawingml/2006/main">
               <a:ext uri="{FF2B5EF4-FFF2-40B4-BE49-F238E27FC236}">
-                <a16:creationId xmlns:a16="http://schemas.microsoft.com/office/drawing/2014/main" id="{827E617C-8A8B-401B-8F07-52A4D183249F}"/>
+                <a16:creationId xmlns:a16="http://schemas.microsoft.com/office/drawing/2014/main" id="{D374D7CF-4226-4E8B-BA9B-BDA9651F86BD}"/>
               </a:ext>
             </a:extLst>
           </p:cNvPr>
@@ -7089,7 +7089,7 @@
           <p:cNvPr id="5" name="">
             <a:extLst xmlns:a="http://schemas.openxmlformats.org/drawingml/2006/main">
               <a:ext uri="{FF2B5EF4-FFF2-40B4-BE49-F238E27FC236}">
-                <a16:creationId xmlns:a16="http://schemas.microsoft.com/office/drawing/2014/main" id="{2CE0B4D4-E6C6-4CC7-984A-43A6A8965EC0}"/>
+                <a16:creationId xmlns:a16="http://schemas.microsoft.com/office/drawing/2014/main" id="{48B37A41-9598-4611-8DC4-71C5216F4FCF}"/>
               </a:ext>
             </a:extLst>
           </p:cNvPr>
@@ -7243,7 +7243,7 @@
     </p:spTree>
     <p:extLst>
       <p:ext uri="{BB962C8B-B14F-4D97-AF65-F5344CB8AC3E}">
-        <p14:creationId xmlns:p14="http://schemas.microsoft.com/office/powerpoint/2010/main" val="1637127022"/>
+        <p14:creationId xmlns:p14="http://schemas.microsoft.com/office/powerpoint/2010/main" val="1660574062"/>
       </p:ext>
     </p:extLst>
   </p:cSld>
@@ -7274,7 +7274,7 @@
           <p:cNvPr id="9" name="">
             <a:extLst xmlns:a="http://schemas.openxmlformats.org/drawingml/2006/main">
               <a:ext uri="{FF2B5EF4-FFF2-40B4-BE49-F238E27FC236}">
-                <a16:creationId xmlns:a16="http://schemas.microsoft.com/office/drawing/2014/main" id="{47ADBCB2-D834-4051-9FCF-646711594F42}"/>
+                <a16:creationId xmlns:a16="http://schemas.microsoft.com/office/drawing/2014/main" id="{3AEB0710-4B5F-4877-A589-DC0A9C468666}"/>
               </a:ext>
             </a:extLst>
           </p:cNvPr>
@@ -7430,7 +7430,7 @@
           <p:cNvPr id="2" name="">
             <a:extLst xmlns:a="http://schemas.openxmlformats.org/drawingml/2006/main">
               <a:ext uri="{FF2B5EF4-FFF2-40B4-BE49-F238E27FC236}">
-                <a16:creationId xmlns:a16="http://schemas.microsoft.com/office/drawing/2014/main" id="{48DB0C69-3271-46D4-806D-F309C641AF7D}"/>
+                <a16:creationId xmlns:a16="http://schemas.microsoft.com/office/drawing/2014/main" id="{437CC711-641E-41D8-B554-6296CD07657F}"/>
               </a:ext>
             </a:extLst>
           </p:cNvPr>
@@ -7586,7 +7586,7 @@
           <p:cNvPr id="3" name="">
             <a:extLst xmlns:a="http://schemas.openxmlformats.org/drawingml/2006/main">
               <a:ext uri="{FF2B5EF4-FFF2-40B4-BE49-F238E27FC236}">
-                <a16:creationId xmlns:a16="http://schemas.microsoft.com/office/drawing/2014/main" id="{B1E1E87F-E015-4E2D-9410-844940C02AF3}"/>
+                <a16:creationId xmlns:a16="http://schemas.microsoft.com/office/drawing/2014/main" id="{F9AAE78E-CAFD-46D9-B2FC-A254D23C3171}"/>
               </a:ext>
             </a:extLst>
           </p:cNvPr>
@@ -7742,7 +7742,7 @@
           <p:cNvPr id="4" name="">
             <a:extLst xmlns:a="http://schemas.openxmlformats.org/drawingml/2006/main">
               <a:ext uri="{FF2B5EF4-FFF2-40B4-BE49-F238E27FC236}">
-                <a16:creationId xmlns:a16="http://schemas.microsoft.com/office/drawing/2014/main" id="{9F2CD625-4476-43F4-ADDC-D687FE3DD30F}"/>
+                <a16:creationId xmlns:a16="http://schemas.microsoft.com/office/drawing/2014/main" id="{A24068C1-9198-4CEA-8A34-FBB015CF0DE6}"/>
               </a:ext>
             </a:extLst>
           </p:cNvPr>
@@ -7898,7 +7898,7 @@
           <p:cNvPr id="5" name="">
             <a:extLst xmlns:a="http://schemas.openxmlformats.org/drawingml/2006/main">
               <a:ext uri="{FF2B5EF4-FFF2-40B4-BE49-F238E27FC236}">
-                <a16:creationId xmlns:a16="http://schemas.microsoft.com/office/drawing/2014/main" id="{4FFEF8F9-AB22-436A-9FD1-428A9BD94E96}"/>
+                <a16:creationId xmlns:a16="http://schemas.microsoft.com/office/drawing/2014/main" id="{5635992D-8874-47C4-8570-56A55C721C13}"/>
               </a:ext>
             </a:extLst>
           </p:cNvPr>
@@ -8100,7 +8100,7 @@
           <p:cNvPr id="6" name="">
             <a:extLst xmlns:a="http://schemas.openxmlformats.org/drawingml/2006/main">
               <a:ext uri="{FF2B5EF4-FFF2-40B4-BE49-F238E27FC236}">
-                <a16:creationId xmlns:a16="http://schemas.microsoft.com/office/drawing/2014/main" id="{7F4F01F5-4F36-4A62-9725-C32D71AAB3A9}"/>
+                <a16:creationId xmlns:a16="http://schemas.microsoft.com/office/drawing/2014/main" id="{31018EF1-998C-42D6-BA30-1C0A546605C8}"/>
               </a:ext>
             </a:extLst>
           </p:cNvPr>
@@ -8256,7 +8256,7 @@
           <p:cNvPr id="7" name="">
             <a:extLst xmlns:a="http://schemas.openxmlformats.org/drawingml/2006/main">
               <a:ext uri="{FF2B5EF4-FFF2-40B4-BE49-F238E27FC236}">
-                <a16:creationId xmlns:a16="http://schemas.microsoft.com/office/drawing/2014/main" id="{A3D1C57D-36E6-4C5D-8C03-7FF29FAABA92}"/>
+                <a16:creationId xmlns:a16="http://schemas.microsoft.com/office/drawing/2014/main" id="{127AE2B2-CE0B-4685-A57D-E0C61D597977}"/>
               </a:ext>
             </a:extLst>
           </p:cNvPr>
@@ -8458,7 +8458,7 @@
           <p:cNvPr id="8" name="">
             <a:extLst xmlns:a="http://schemas.openxmlformats.org/drawingml/2006/main">
               <a:ext uri="{FF2B5EF4-FFF2-40B4-BE49-F238E27FC236}">
-                <a16:creationId xmlns:a16="http://schemas.microsoft.com/office/drawing/2014/main" id="{BB8C4C62-053A-4363-BB50-EE053B6B797A}"/>
+                <a16:creationId xmlns:a16="http://schemas.microsoft.com/office/drawing/2014/main" id="{938BE7B1-3E2F-4C98-BF58-7B9694F6054E}"/>
               </a:ext>
             </a:extLst>
           </p:cNvPr>
@@ -8635,7 +8635,7 @@
     </p:spTree>
     <p:extLst>
       <p:ext uri="{BB962C8B-B14F-4D97-AF65-F5344CB8AC3E}">
-        <p14:creationId xmlns:p14="http://schemas.microsoft.com/office/powerpoint/2010/main" val="954871955"/>
+        <p14:creationId xmlns:p14="http://schemas.microsoft.com/office/powerpoint/2010/main" val="642350540"/>
       </p:ext>
     </p:extLst>
   </p:cSld>
@@ -8666,7 +8666,7 @@
           <p:cNvPr id="7" name="">
             <a:extLst xmlns:a="http://schemas.openxmlformats.org/drawingml/2006/main">
               <a:ext uri="{FF2B5EF4-FFF2-40B4-BE49-F238E27FC236}">
-                <a16:creationId xmlns:a16="http://schemas.microsoft.com/office/drawing/2014/main" id="{6913F1D3-D897-4337-9C1A-2A27A8F6EA93}"/>
+                <a16:creationId xmlns:a16="http://schemas.microsoft.com/office/drawing/2014/main" id="{BA96930F-5D34-423B-9430-8DB58B5C4267}"/>
               </a:ext>
             </a:extLst>
           </p:cNvPr>
@@ -8822,7 +8822,7 @@
           <p:cNvPr id="2" name="">
             <a:extLst xmlns:a="http://schemas.openxmlformats.org/drawingml/2006/main">
               <a:ext uri="{FF2B5EF4-FFF2-40B4-BE49-F238E27FC236}">
-                <a16:creationId xmlns:a16="http://schemas.microsoft.com/office/drawing/2014/main" id="{7B67A859-3E69-46B3-AA12-A4CCDDBC616F}"/>
+                <a16:creationId xmlns:a16="http://schemas.microsoft.com/office/drawing/2014/main" id="{562166DF-9C0C-4DD5-938B-0D97EDB46F58}"/>
               </a:ext>
             </a:extLst>
           </p:cNvPr>
@@ -8978,7 +8978,7 @@
           <p:cNvPr id="3" name="">
             <a:extLst xmlns:a="http://schemas.openxmlformats.org/drawingml/2006/main">
               <a:ext uri="{FF2B5EF4-FFF2-40B4-BE49-F238E27FC236}">
-                <a16:creationId xmlns:a16="http://schemas.microsoft.com/office/drawing/2014/main" id="{0F03B0DC-C906-4E65-8062-73CE406EA3A8}"/>
+                <a16:creationId xmlns:a16="http://schemas.microsoft.com/office/drawing/2014/main" id="{3A6E5A24-5B5A-444A-AAB0-7A393EBB8B90}"/>
               </a:ext>
             </a:extLst>
           </p:cNvPr>
@@ -9134,7 +9134,7 @@
           <p:cNvPr id="4" name="">
             <a:extLst xmlns:a="http://schemas.openxmlformats.org/drawingml/2006/main">
               <a:ext uri="{FF2B5EF4-FFF2-40B4-BE49-F238E27FC236}">
-                <a16:creationId xmlns:a16="http://schemas.microsoft.com/office/drawing/2014/main" id="{6E8D068A-3021-4DF5-A59A-BEA67D3D672D}"/>
+                <a16:creationId xmlns:a16="http://schemas.microsoft.com/office/drawing/2014/main" id="{71D643EA-EF9E-4B64-90A4-E452A7E659D5}"/>
               </a:ext>
             </a:extLst>
           </p:cNvPr>
@@ -9644,7 +9644,7 @@
           <p:cNvPr id="5" name="">
             <a:extLst xmlns:a="http://schemas.openxmlformats.org/drawingml/2006/main">
               <a:ext uri="{FF2B5EF4-FFF2-40B4-BE49-F238E27FC236}">
-                <a16:creationId xmlns:a16="http://schemas.microsoft.com/office/drawing/2014/main" id="{12CE89E3-28A3-4968-848D-50B8F49A1DE0}"/>
+                <a16:creationId xmlns:a16="http://schemas.microsoft.com/office/drawing/2014/main" id="{E1AEF1BD-C21E-4A15-AB2D-CEC3DE49ACA1}"/>
               </a:ext>
             </a:extLst>
           </p:cNvPr>
@@ -9813,7 +9813,7 @@
                 <a:ea typeface="Helvetica Neue"/>
                 <a:cs typeface="Helvetica Neue"/>
               </a:rPr>
-              <a:t>selected daily quota. These are partial-suite counts.</a:t>
+              <a:t>daily request quota. These are partial-suite counts.</a:t>
             </a:r>
           </a:p>
         </p:txBody>
@@ -9823,7 +9823,7 @@
           <p:cNvPr id="6" name="">
             <a:extLst xmlns:a="http://schemas.openxmlformats.org/drawingml/2006/main">
               <a:ext uri="{FF2B5EF4-FFF2-40B4-BE49-F238E27FC236}">
-                <a16:creationId xmlns:a16="http://schemas.microsoft.com/office/drawing/2014/main" id="{AED7886E-A416-4492-BDE6-2FC75921E3C6}"/>
+                <a16:creationId xmlns:a16="http://schemas.microsoft.com/office/drawing/2014/main" id="{97B26179-93E9-4291-B519-96F5A1FB0F59}"/>
               </a:ext>
             </a:extLst>
           </p:cNvPr>
@@ -10000,7 +10000,7 @@
     </p:spTree>
     <p:extLst>
       <p:ext uri="{BB962C8B-B14F-4D97-AF65-F5344CB8AC3E}">
-        <p14:creationId xmlns:p14="http://schemas.microsoft.com/office/powerpoint/2010/main" val="1251662375"/>
+        <p14:creationId xmlns:p14="http://schemas.microsoft.com/office/powerpoint/2010/main" val="1143506176"/>
       </p:ext>
     </p:extLst>
   </p:cSld>
@@ -10031,7 +10031,7 @@
           <p:cNvPr id="9" name="">
             <a:extLst xmlns:a="http://schemas.openxmlformats.org/drawingml/2006/main">
               <a:ext uri="{FF2B5EF4-FFF2-40B4-BE49-F238E27FC236}">
-                <a16:creationId xmlns:a16="http://schemas.microsoft.com/office/drawing/2014/main" id="{479CEDDD-CF8F-4228-8C90-7F44ECFCCBA5}"/>
+                <a16:creationId xmlns:a16="http://schemas.microsoft.com/office/drawing/2014/main" id="{2894E0C8-06CE-4C1E-A14F-4E62CB5167FC}"/>
               </a:ext>
             </a:extLst>
           </p:cNvPr>
@@ -10187,7 +10187,7 @@
           <p:cNvPr id="2" name="">
             <a:extLst xmlns:a="http://schemas.openxmlformats.org/drawingml/2006/main">
               <a:ext uri="{FF2B5EF4-FFF2-40B4-BE49-F238E27FC236}">
-                <a16:creationId xmlns:a16="http://schemas.microsoft.com/office/drawing/2014/main" id="{4928E991-3C05-4898-8850-3685C7429DD1}"/>
+                <a16:creationId xmlns:a16="http://schemas.microsoft.com/office/drawing/2014/main" id="{6B4C4CF1-EB8D-4C1F-BCD8-3AB49D220EFF}"/>
               </a:ext>
             </a:extLst>
           </p:cNvPr>
@@ -10343,7 +10343,7 @@
           <p:cNvPr id="3" name="">
             <a:extLst xmlns:a="http://schemas.openxmlformats.org/drawingml/2006/main">
               <a:ext uri="{FF2B5EF4-FFF2-40B4-BE49-F238E27FC236}">
-                <a16:creationId xmlns:a16="http://schemas.microsoft.com/office/drawing/2014/main" id="{92F5D0A8-3E2B-44DA-9BC5-BDD958CF390D}"/>
+                <a16:creationId xmlns:a16="http://schemas.microsoft.com/office/drawing/2014/main" id="{A5286729-4AFE-4FEB-B098-15D922ECD501}"/>
               </a:ext>
             </a:extLst>
           </p:cNvPr>
@@ -10499,7 +10499,7 @@
           <p:cNvPr id="4" name="">
             <a:extLst xmlns:a="http://schemas.openxmlformats.org/drawingml/2006/main">
               <a:ext uri="{FF2B5EF4-FFF2-40B4-BE49-F238E27FC236}">
-                <a16:creationId xmlns:a16="http://schemas.microsoft.com/office/drawing/2014/main" id="{5BDE0F08-14C6-4D82-BE88-A05C8904CE01}"/>
+                <a16:creationId xmlns:a16="http://schemas.microsoft.com/office/drawing/2014/main" id="{404AD047-CB35-44EC-9B4E-C65EF180D538}"/>
               </a:ext>
             </a:extLst>
           </p:cNvPr>
@@ -10655,7 +10655,7 @@
           <p:cNvPr id="5" name="">
             <a:extLst xmlns:a="http://schemas.openxmlformats.org/drawingml/2006/main">
               <a:ext uri="{FF2B5EF4-FFF2-40B4-BE49-F238E27FC236}">
-                <a16:creationId xmlns:a16="http://schemas.microsoft.com/office/drawing/2014/main" id="{63F1B255-8E31-4D17-814C-F91E462A9564}"/>
+                <a16:creationId xmlns:a16="http://schemas.microsoft.com/office/drawing/2014/main" id="{BEB55FAD-90FE-4713-AF19-962E1EF972F4}"/>
               </a:ext>
             </a:extLst>
           </p:cNvPr>
@@ -10834,7 +10834,7 @@
           <p:cNvPr id="6" name="">
             <a:extLst xmlns:a="http://schemas.openxmlformats.org/drawingml/2006/main">
               <a:ext uri="{FF2B5EF4-FFF2-40B4-BE49-F238E27FC236}">
-                <a16:creationId xmlns:a16="http://schemas.microsoft.com/office/drawing/2014/main" id="{AB4AD61D-F5CA-47DC-91D7-248397419D48}"/>
+                <a16:creationId xmlns:a16="http://schemas.microsoft.com/office/drawing/2014/main" id="{2740694C-2A75-42EA-A20E-97384109DD9F}"/>
               </a:ext>
             </a:extLst>
           </p:cNvPr>
@@ -10990,7 +10990,7 @@
           <p:cNvPr id="7" name="">
             <a:extLst xmlns:a="http://schemas.openxmlformats.org/drawingml/2006/main">
               <a:ext uri="{FF2B5EF4-FFF2-40B4-BE49-F238E27FC236}">
-                <a16:creationId xmlns:a16="http://schemas.microsoft.com/office/drawing/2014/main" id="{BD0F51C5-E534-486F-9D64-D88568DA0177}"/>
+                <a16:creationId xmlns:a16="http://schemas.microsoft.com/office/drawing/2014/main" id="{223261A5-4F22-4786-B89D-5B5C61957AB6}"/>
               </a:ext>
             </a:extLst>
           </p:cNvPr>
@@ -11169,7 +11169,7 @@
           <p:cNvPr id="8" name="">
             <a:extLst xmlns:a="http://schemas.openxmlformats.org/drawingml/2006/main">
               <a:ext uri="{FF2B5EF4-FFF2-40B4-BE49-F238E27FC236}">
-                <a16:creationId xmlns:a16="http://schemas.microsoft.com/office/drawing/2014/main" id="{9D5A99F6-6AF2-472E-A7FA-2BD87A6F5BD3}"/>
+                <a16:creationId xmlns:a16="http://schemas.microsoft.com/office/drawing/2014/main" id="{7DE5F599-0750-424E-9A34-170EB8CB189A}"/>
               </a:ext>
             </a:extLst>
           </p:cNvPr>
@@ -11346,7 +11346,7 @@
     </p:spTree>
     <p:extLst>
       <p:ext uri="{BB962C8B-B14F-4D97-AF65-F5344CB8AC3E}">
-        <p14:creationId xmlns:p14="http://schemas.microsoft.com/office/powerpoint/2010/main" val="669391018"/>
+        <p14:creationId xmlns:p14="http://schemas.microsoft.com/office/powerpoint/2010/main" val="1938941218"/>
       </p:ext>
     </p:extLst>
   </p:cSld>

</xml_diff>

<commit_message>
Version reviewer runtimes and protect resumable evaluation evidence
</commit_message>
<xml_diff>
--- a/submission/ModelCheck_Capstone.pptx
+++ b/submission/ModelCheck_Capstone.pptx
@@ -2,18 +2,18 @@
 <file path=ppt/presentation.xml><?xml version="1.0" encoding="utf-8"?>
 <p:presentation xmlns:p="http://schemas.openxmlformats.org/presentationml/2006/main">
   <p:sldMasterIdLst>
-    <p:sldMasterId xmlns:r="http://schemas.openxmlformats.org/officeDocument/2006/relationships" id="2147483648" r:id="Raa3bd2e7efd045e3"/>
+    <p:sldMasterId xmlns:r="http://schemas.openxmlformats.org/officeDocument/2006/relationships" id="2147483648" r:id="Re69db8ff96494873"/>
   </p:sldMasterIdLst>
   <p:notesMasterIdLst>
-    <p:notesMasterId xmlns:r="http://schemas.openxmlformats.org/officeDocument/2006/relationships" r:id="R25b5f492226c47a7"/>
+    <p:notesMasterId xmlns:r="http://schemas.openxmlformats.org/officeDocument/2006/relationships" r:id="R77529d837c8249ba"/>
   </p:notesMasterIdLst>
   <p:sldIdLst>
-    <p:sldId xmlns:r="http://schemas.openxmlformats.org/officeDocument/2006/relationships" id="256" r:id="R1113b8f1c7174f36"/>
-    <p:sldId xmlns:r="http://schemas.openxmlformats.org/officeDocument/2006/relationships" id="257" r:id="R4011923905e84c48"/>
-    <p:sldId xmlns:r="http://schemas.openxmlformats.org/officeDocument/2006/relationships" id="258" r:id="R67a702c755e740fa"/>
-    <p:sldId xmlns:r="http://schemas.openxmlformats.org/officeDocument/2006/relationships" id="259" r:id="Rc77d3a369d2043d6"/>
-    <p:sldId xmlns:r="http://schemas.openxmlformats.org/officeDocument/2006/relationships" id="260" r:id="R40cac453eec54f92"/>
-    <p:sldId xmlns:r="http://schemas.openxmlformats.org/officeDocument/2006/relationships" id="261" r:id="Raf1112d3b13a4f26"/>
+    <p:sldId xmlns:r="http://schemas.openxmlformats.org/officeDocument/2006/relationships" id="256" r:id="Rf89aa813e1794a55"/>
+    <p:sldId xmlns:r="http://schemas.openxmlformats.org/officeDocument/2006/relationships" id="257" r:id="Rb1115e63ca81477a"/>
+    <p:sldId xmlns:r="http://schemas.openxmlformats.org/officeDocument/2006/relationships" id="258" r:id="R32cba5404a074cc7"/>
+    <p:sldId xmlns:r="http://schemas.openxmlformats.org/officeDocument/2006/relationships" id="259" r:id="Rf64a8a9d84a34a7b"/>
+    <p:sldId xmlns:r="http://schemas.openxmlformats.org/officeDocument/2006/relationships" id="260" r:id="R2c849480b9564bee"/>
+    <p:sldId xmlns:r="http://schemas.openxmlformats.org/officeDocument/2006/relationships" id="261" r:id="Reaf1a0b9a53b48ae"/>
   </p:sldIdLst>
   <p:sldSz cx="12192000" cy="6858000"/>
   <p:notesSz cx="6858000" cy="9144000"/>
@@ -657,7 +657,7 @@
           <a:lstStyle xmlns:a="http://schemas.openxmlformats.org/drawingml/2006/main"/>
           <a:p xmlns:a="http://schemas.openxmlformats.org/drawingml/2006/main">
             <a:r>
-              <a:t>The runtime offers on-demand protocol retrieval, evidence IDs and bounded context. Observed protocol invocation is inconsistent. Additional caps: 16 tool executions, 1,200 output tokens per call, 30,000 cumulative reported tokens, 180 seconds and USD 0.05 estimated cost. One unscored development run reached the token budget. Sources: agent.py, store.py, skills/review-experiment/SKILL.md and submission/traces.</a:t>
+              <a:t>V2 reads the packaged protocol before inference, records its version and SHA-256 as a host event and retains it in system context during compaction. The preload counts toward the 16-execution budget. The original v1 reviewer remains unchanged for resumption of its pending tasks. Request, token, time and approval controls remain in place. Sources: agent.py, legacy_v1.py, evaluation.py and tests/test_completion.py.</a:t>
             </a:r>
           </a:p>
         </p:txBody>
@@ -727,7 +727,7 @@
           <a:lstStyle xmlns:a="http://schemas.openxmlformats.org/drawingml/2006/main"/>
           <a:p xmlns:a="http://schemas.openxmlformats.org/drawingml/2006/main">
             <a:r>
-              <a:t>Eighteen tasks define 36 scheduled reviews across A and B. Six paired tasks executed. B used two compute_metrics calls for matched-comparison and returned the correct minus-five-percentage-point accuracy delta, but omitted compare_runs. The tool-use and comparison-outcome graders failed. Both configurations use identical application controls. Sources: submission/summary.json, A.csv, B.csv and traces/matched-comparison-B.json.</a:t>
+              <a:t>V1 has 18 tasks and 36 scheduled A/B reviews, with 12 executed and 24 pending. A passed 6/6 and B passed 5/6. B returned the correct accuracy delta but omitted compare_runs. Original traces and source are preserved in the initial snapshot. New runtime fingerprints are recovered metadata for those historical executions. V2 has no live evaluation results and cannot consume evaluation quota until v1 finishes. Five provider requests remain reserved; each evaluation requires at least 13 remaining requests before it starts. Sources: submission/summary.json, submission/COVERAGE.md, submission/evaluations/v1/initial and submission/evaluations/v2.</a:t>
             </a:r>
           </a:p>
         </p:txBody>
@@ -797,7 +797,7 @@
           <a:lstStyle xmlns:a="http://schemas.openxmlformats.org/drawingml/2006/main"/>
           <a:p xmlns:a="http://schemas.openxmlformats.org/drawingml/2006/main">
             <a:r>
-              <a:t>The live malicious-description test used two requests and called inspect_manifest only. It reported the injection and created no pending action or file. Handler tests separately cover path fields, tampered digests, foreign sessions and valid saves. Broader live security and action evaluations remain pending. Sources: submission/security/live-attack.json, SECURITY.md, tests/test_core.py and tests/test_agent.py.</a:t>
+              <a:t>The original v1 injection demonstration used two model requests and inspect_manifest, then completed without an action or file. V2 has controlled-provider protocol and execution tests, plus the unchanged application approval guards. Controlled tests are separate from live evaluations. The 56-test suite covers checksums, resumption, interrupted progress writes, version isolation, protocol failure and approval controls. Screen-reader speech remains unverified. Sources: submission/security/live-attack.json, submission/SECURITY.md, tests/test_completion.py and submission/REPRODUCIBILITY.json.</a:t>
             </a:r>
           </a:p>
         </p:txBody>
@@ -3240,12 +3240,12 @@
   </p:cSld>
   <p:clrMap bg1="lt1" tx1="dk1" bg2="lt2" tx2="dk2" accent1="accent1" accent2="accent2" accent3="accent3" accent4="accent4" accent5="accent5" accent6="accent6" hlink="hlink" folHlink="folHlink"/>
   <p:sldLayoutIdLst>
-    <p:sldLayoutId xmlns:r="http://schemas.openxmlformats.org/officeDocument/2006/relationships" id="2147483649" r:id="R5929986f24c2431b"/>
-    <p:sldLayoutId xmlns:r="http://schemas.openxmlformats.org/officeDocument/2006/relationships" id="2147483650" r:id="R8c5e24f8923f4f33"/>
-    <p:sldLayoutId xmlns:r="http://schemas.openxmlformats.org/officeDocument/2006/relationships" id="2147483651" r:id="Rac0f7d8c4fcb4634"/>
-    <p:sldLayoutId xmlns:r="http://schemas.openxmlformats.org/officeDocument/2006/relationships" id="2147483652" r:id="R050a53ea655d4be6"/>
-    <p:sldLayoutId xmlns:r="http://schemas.openxmlformats.org/officeDocument/2006/relationships" id="2147483653" r:id="Rb63e435307f741d8"/>
-    <p:sldLayoutId xmlns:r="http://schemas.openxmlformats.org/officeDocument/2006/relationships" id="2147483654" r:id="R22beb598a3d24566"/>
+    <p:sldLayoutId xmlns:r="http://schemas.openxmlformats.org/officeDocument/2006/relationships" id="2147483649" r:id="R2b425893c9b8461f"/>
+    <p:sldLayoutId xmlns:r="http://schemas.openxmlformats.org/officeDocument/2006/relationships" id="2147483650" r:id="R0b55c51a7d244660"/>
+    <p:sldLayoutId xmlns:r="http://schemas.openxmlformats.org/officeDocument/2006/relationships" id="2147483651" r:id="Re1ea9c798776492b"/>
+    <p:sldLayoutId xmlns:r="http://schemas.openxmlformats.org/officeDocument/2006/relationships" id="2147483652" r:id="R1b0074b8f4374d1a"/>
+    <p:sldLayoutId xmlns:r="http://schemas.openxmlformats.org/officeDocument/2006/relationships" id="2147483653" r:id="R4b22322d166440fc"/>
+    <p:sldLayoutId xmlns:r="http://schemas.openxmlformats.org/officeDocument/2006/relationships" id="2147483654" r:id="R98e1e8d0e7404cbf"/>
   </p:sldLayoutIdLst>
   <p:txStyles>
     <p:titleStyle>
@@ -3832,6 +3832,7 @@
               </a:defRPr>
             </a:defPPr>
             <a:lvl1pPr>
+              <a:buNone/>
               <a:defRPr sz="1125" b="1">
                 <a:solidFill>
                   <a:srgbClr val="146B5F"/>
@@ -3842,6 +3843,7 @@
               </a:defRPr>
             </a:lvl1pPr>
             <a:lvl2pPr>
+              <a:buNone/>
               <a:defRPr sz="1125" b="1">
                 <a:solidFill>
                   <a:srgbClr val="146B5F"/>
@@ -3852,6 +3854,7 @@
               </a:defRPr>
             </a:lvl2pPr>
             <a:lvl3pPr>
+              <a:buNone/>
               <a:defRPr sz="1125" b="1">
                 <a:solidFill>
                   <a:srgbClr val="146B5F"/>
@@ -3862,6 +3865,7 @@
               </a:defRPr>
             </a:lvl3pPr>
             <a:lvl4pPr>
+              <a:buNone/>
               <a:defRPr sz="1125" b="1">
                 <a:solidFill>
                   <a:srgbClr val="146B5F"/>
@@ -3872,6 +3876,7 @@
               </a:defRPr>
             </a:lvl4pPr>
             <a:lvl5pPr>
+              <a:buNone/>
               <a:defRPr sz="1125" b="1">
                 <a:solidFill>
                   <a:srgbClr val="146B5F"/>
@@ -3882,6 +3887,7 @@
               </a:defRPr>
             </a:lvl5pPr>
             <a:lvl6pPr>
+              <a:buNone/>
               <a:defRPr sz="1125" b="1">
                 <a:solidFill>
                   <a:srgbClr val="146B5F"/>
@@ -3892,6 +3898,7 @@
               </a:defRPr>
             </a:lvl6pPr>
             <a:lvl7pPr>
+              <a:buNone/>
               <a:defRPr sz="1125" b="1">
                 <a:solidFill>
                   <a:srgbClr val="146B5F"/>
@@ -3902,6 +3909,7 @@
               </a:defRPr>
             </a:lvl7pPr>
             <a:lvl8pPr>
+              <a:buNone/>
               <a:defRPr sz="1125" b="1">
                 <a:solidFill>
                   <a:srgbClr val="146B5F"/>
@@ -3912,6 +3920,7 @@
               </a:defRPr>
             </a:lvl8pPr>
             <a:lvl9pPr>
+              <a:buNone/>
               <a:defRPr sz="1125" b="1">
                 <a:solidFill>
                   <a:srgbClr val="146B5F"/>
@@ -3924,6 +3933,7 @@
           </a:lstStyle>
           <a:p xmlns:a="http://schemas.openxmlformats.org/drawingml/2006/main">
             <a:pPr>
+              <a:buNone/>
               <a:defRPr sz="1125" b="1">
                 <a:solidFill>
                   <a:srgbClr val="146B5F"/>
@@ -3988,6 +3998,7 @@
               </a:defRPr>
             </a:defPPr>
             <a:lvl1pPr>
+              <a:buNone/>
               <a:defRPr sz="3825" b="0">
                 <a:solidFill>
                   <a:srgbClr val="172E32"/>
@@ -3998,6 +4009,7 @@
               </a:defRPr>
             </a:lvl1pPr>
             <a:lvl2pPr>
+              <a:buNone/>
               <a:defRPr sz="3825" b="0">
                 <a:solidFill>
                   <a:srgbClr val="172E32"/>
@@ -4008,6 +4020,7 @@
               </a:defRPr>
             </a:lvl2pPr>
             <a:lvl3pPr>
+              <a:buNone/>
               <a:defRPr sz="3825" b="0">
                 <a:solidFill>
                   <a:srgbClr val="172E32"/>
@@ -4018,6 +4031,7 @@
               </a:defRPr>
             </a:lvl3pPr>
             <a:lvl4pPr>
+              <a:buNone/>
               <a:defRPr sz="3825" b="0">
                 <a:solidFill>
                   <a:srgbClr val="172E32"/>
@@ -4028,6 +4042,7 @@
               </a:defRPr>
             </a:lvl4pPr>
             <a:lvl5pPr>
+              <a:buNone/>
               <a:defRPr sz="3825" b="0">
                 <a:solidFill>
                   <a:srgbClr val="172E32"/>
@@ -4038,6 +4053,7 @@
               </a:defRPr>
             </a:lvl5pPr>
             <a:lvl6pPr>
+              <a:buNone/>
               <a:defRPr sz="3825" b="0">
                 <a:solidFill>
                   <a:srgbClr val="172E32"/>
@@ -4048,6 +4064,7 @@
               </a:defRPr>
             </a:lvl6pPr>
             <a:lvl7pPr>
+              <a:buNone/>
               <a:defRPr sz="3825" b="0">
                 <a:solidFill>
                   <a:srgbClr val="172E32"/>
@@ -4058,6 +4075,7 @@
               </a:defRPr>
             </a:lvl7pPr>
             <a:lvl8pPr>
+              <a:buNone/>
               <a:defRPr sz="3825" b="0">
                 <a:solidFill>
                   <a:srgbClr val="172E32"/>
@@ -4068,6 +4086,7 @@
               </a:defRPr>
             </a:lvl8pPr>
             <a:lvl9pPr>
+              <a:buNone/>
               <a:defRPr sz="3825" b="0">
                 <a:solidFill>
                   <a:srgbClr val="172E32"/>
@@ -4080,6 +4099,7 @@
           </a:lstStyle>
           <a:p xmlns:a="http://schemas.openxmlformats.org/drawingml/2006/main">
             <a:pPr>
+              <a:buNone/>
               <a:defRPr sz="3825" b="0">
                 <a:solidFill>
                   <a:srgbClr val="172E32"/>
@@ -4144,6 +4164,7 @@
               </a:defRPr>
             </a:defPPr>
             <a:lvl1pPr>
+              <a:buNone/>
               <a:defRPr sz="1050" b="0">
                 <a:solidFill>
                   <a:srgbClr val="657574"/>
@@ -4154,6 +4175,7 @@
               </a:defRPr>
             </a:lvl1pPr>
             <a:lvl2pPr>
+              <a:buNone/>
               <a:defRPr sz="1050" b="0">
                 <a:solidFill>
                   <a:srgbClr val="657574"/>
@@ -4164,6 +4186,7 @@
               </a:defRPr>
             </a:lvl2pPr>
             <a:lvl3pPr>
+              <a:buNone/>
               <a:defRPr sz="1050" b="0">
                 <a:solidFill>
                   <a:srgbClr val="657574"/>
@@ -4174,6 +4197,7 @@
               </a:defRPr>
             </a:lvl3pPr>
             <a:lvl4pPr>
+              <a:buNone/>
               <a:defRPr sz="1050" b="0">
                 <a:solidFill>
                   <a:srgbClr val="657574"/>
@@ -4184,6 +4208,7 @@
               </a:defRPr>
             </a:lvl4pPr>
             <a:lvl5pPr>
+              <a:buNone/>
               <a:defRPr sz="1050" b="0">
                 <a:solidFill>
                   <a:srgbClr val="657574"/>
@@ -4194,6 +4219,7 @@
               </a:defRPr>
             </a:lvl5pPr>
             <a:lvl6pPr>
+              <a:buNone/>
               <a:defRPr sz="1050" b="0">
                 <a:solidFill>
                   <a:srgbClr val="657574"/>
@@ -4204,6 +4230,7 @@
               </a:defRPr>
             </a:lvl6pPr>
             <a:lvl7pPr>
+              <a:buNone/>
               <a:defRPr sz="1050" b="0">
                 <a:solidFill>
                   <a:srgbClr val="657574"/>
@@ -4214,6 +4241,7 @@
               </a:defRPr>
             </a:lvl7pPr>
             <a:lvl8pPr>
+              <a:buNone/>
               <a:defRPr sz="1050" b="0">
                 <a:solidFill>
                   <a:srgbClr val="657574"/>
@@ -4224,6 +4252,7 @@
               </a:defRPr>
             </a:lvl8pPr>
             <a:lvl9pPr>
+              <a:buNone/>
               <a:defRPr sz="1050" b="0">
                 <a:solidFill>
                   <a:srgbClr val="657574"/>
@@ -4236,6 +4265,7 @@
           </a:lstStyle>
           <a:p xmlns:a="http://schemas.openxmlformats.org/drawingml/2006/main">
             <a:pPr>
+              <a:buNone/>
               <a:defRPr sz="1050" b="0">
                 <a:solidFill>
                   <a:srgbClr val="657574"/>
@@ -4300,6 +4330,7 @@
               </a:defRPr>
             </a:defPPr>
             <a:lvl1pPr>
+              <a:buNone/>
               <a:defRPr sz="3675" b="0">
                 <a:solidFill>
                   <a:srgbClr val="146B5F"/>
@@ -4310,6 +4341,7 @@
               </a:defRPr>
             </a:lvl1pPr>
             <a:lvl2pPr>
+              <a:buNone/>
               <a:defRPr sz="3675" b="0">
                 <a:solidFill>
                   <a:srgbClr val="146B5F"/>
@@ -4320,6 +4352,7 @@
               </a:defRPr>
             </a:lvl2pPr>
             <a:lvl3pPr>
+              <a:buNone/>
               <a:defRPr sz="3675" b="0">
                 <a:solidFill>
                   <a:srgbClr val="146B5F"/>
@@ -4330,6 +4363,7 @@
               </a:defRPr>
             </a:lvl3pPr>
             <a:lvl4pPr>
+              <a:buNone/>
               <a:defRPr sz="3675" b="0">
                 <a:solidFill>
                   <a:srgbClr val="146B5F"/>
@@ -4340,6 +4374,7 @@
               </a:defRPr>
             </a:lvl4pPr>
             <a:lvl5pPr>
+              <a:buNone/>
               <a:defRPr sz="3675" b="0">
                 <a:solidFill>
                   <a:srgbClr val="146B5F"/>
@@ -4350,6 +4385,7 @@
               </a:defRPr>
             </a:lvl5pPr>
             <a:lvl6pPr>
+              <a:buNone/>
               <a:defRPr sz="3675" b="0">
                 <a:solidFill>
                   <a:srgbClr val="146B5F"/>
@@ -4360,6 +4396,7 @@
               </a:defRPr>
             </a:lvl6pPr>
             <a:lvl7pPr>
+              <a:buNone/>
               <a:defRPr sz="3675" b="0">
                 <a:solidFill>
                   <a:srgbClr val="146B5F"/>
@@ -4370,6 +4407,7 @@
               </a:defRPr>
             </a:lvl7pPr>
             <a:lvl8pPr>
+              <a:buNone/>
               <a:defRPr sz="3675" b="0">
                 <a:solidFill>
                   <a:srgbClr val="146B5F"/>
@@ -4380,6 +4418,7 @@
               </a:defRPr>
             </a:lvl8pPr>
             <a:lvl9pPr>
+              <a:buNone/>
               <a:defRPr sz="3675" b="0">
                 <a:solidFill>
                   <a:srgbClr val="146B5F"/>
@@ -4392,6 +4431,7 @@
           </a:lstStyle>
           <a:p xmlns:a="http://schemas.openxmlformats.org/drawingml/2006/main">
             <a:pPr>
+              <a:buNone/>
               <a:defRPr sz="3675" b="0">
                 <a:solidFill>
                   <a:srgbClr val="146B5F"/>
@@ -4415,6 +4455,7 @@
           </a:p>
           <a:p xmlns:a="http://schemas.openxmlformats.org/drawingml/2006/main">
             <a:pPr>
+              <a:buNone/>
               <a:defRPr sz="3675" b="0">
                 <a:solidFill>
                   <a:srgbClr val="146B5F"/>
@@ -4479,6 +4520,7 @@
               </a:defRPr>
             </a:defPPr>
             <a:lvl1pPr>
+              <a:buNone/>
               <a:defRPr sz="2025" b="0">
                 <a:solidFill>
                   <a:srgbClr val="657574"/>
@@ -4489,6 +4531,7 @@
               </a:defRPr>
             </a:lvl1pPr>
             <a:lvl2pPr>
+              <a:buNone/>
               <a:defRPr sz="2025" b="0">
                 <a:solidFill>
                   <a:srgbClr val="657574"/>
@@ -4499,6 +4542,7 @@
               </a:defRPr>
             </a:lvl2pPr>
             <a:lvl3pPr>
+              <a:buNone/>
               <a:defRPr sz="2025" b="0">
                 <a:solidFill>
                   <a:srgbClr val="657574"/>
@@ -4509,6 +4553,7 @@
               </a:defRPr>
             </a:lvl3pPr>
             <a:lvl4pPr>
+              <a:buNone/>
               <a:defRPr sz="2025" b="0">
                 <a:solidFill>
                   <a:srgbClr val="657574"/>
@@ -4519,6 +4564,7 @@
               </a:defRPr>
             </a:lvl4pPr>
             <a:lvl5pPr>
+              <a:buNone/>
               <a:defRPr sz="2025" b="0">
                 <a:solidFill>
                   <a:srgbClr val="657574"/>
@@ -4529,6 +4575,7 @@
               </a:defRPr>
             </a:lvl5pPr>
             <a:lvl6pPr>
+              <a:buNone/>
               <a:defRPr sz="2025" b="0">
                 <a:solidFill>
                   <a:srgbClr val="657574"/>
@@ -4539,6 +4586,7 @@
               </a:defRPr>
             </a:lvl6pPr>
             <a:lvl7pPr>
+              <a:buNone/>
               <a:defRPr sz="2025" b="0">
                 <a:solidFill>
                   <a:srgbClr val="657574"/>
@@ -4549,6 +4597,7 @@
               </a:defRPr>
             </a:lvl7pPr>
             <a:lvl8pPr>
+              <a:buNone/>
               <a:defRPr sz="2025" b="0">
                 <a:solidFill>
                   <a:srgbClr val="657574"/>
@@ -4559,6 +4608,7 @@
               </a:defRPr>
             </a:lvl8pPr>
             <a:lvl9pPr>
+              <a:buNone/>
               <a:defRPr sz="2025" b="0">
                 <a:solidFill>
                   <a:srgbClr val="657574"/>
@@ -4571,6 +4621,7 @@
           </a:lstStyle>
           <a:p xmlns:a="http://schemas.openxmlformats.org/drawingml/2006/main">
             <a:pPr>
+              <a:buNone/>
               <a:defRPr sz="2025" b="0">
                 <a:solidFill>
                   <a:srgbClr val="657574"/>
@@ -4594,6 +4645,7 @@
           </a:p>
           <a:p xmlns:a="http://schemas.openxmlformats.org/drawingml/2006/main">
             <a:pPr>
+              <a:buNone/>
               <a:defRPr sz="2025" b="0">
                 <a:solidFill>
                   <a:srgbClr val="657574"/>
@@ -4687,6 +4739,7 @@
               </a:defRPr>
             </a:defPPr>
             <a:lvl1pPr>
+              <a:buNone/>
               <a:defRPr sz="1125" b="1">
                 <a:solidFill>
                   <a:srgbClr val="146B5F"/>
@@ -4697,6 +4750,7 @@
               </a:defRPr>
             </a:lvl1pPr>
             <a:lvl2pPr>
+              <a:buNone/>
               <a:defRPr sz="1125" b="1">
                 <a:solidFill>
                   <a:srgbClr val="146B5F"/>
@@ -4707,6 +4761,7 @@
               </a:defRPr>
             </a:lvl2pPr>
             <a:lvl3pPr>
+              <a:buNone/>
               <a:defRPr sz="1125" b="1">
                 <a:solidFill>
                   <a:srgbClr val="146B5F"/>
@@ -4717,6 +4772,7 @@
               </a:defRPr>
             </a:lvl3pPr>
             <a:lvl4pPr>
+              <a:buNone/>
               <a:defRPr sz="1125" b="1">
                 <a:solidFill>
                   <a:srgbClr val="146B5F"/>
@@ -4727,6 +4783,7 @@
               </a:defRPr>
             </a:lvl4pPr>
             <a:lvl5pPr>
+              <a:buNone/>
               <a:defRPr sz="1125" b="1">
                 <a:solidFill>
                   <a:srgbClr val="146B5F"/>
@@ -4737,6 +4794,7 @@
               </a:defRPr>
             </a:lvl5pPr>
             <a:lvl6pPr>
+              <a:buNone/>
               <a:defRPr sz="1125" b="1">
                 <a:solidFill>
                   <a:srgbClr val="146B5F"/>
@@ -4747,6 +4805,7 @@
               </a:defRPr>
             </a:lvl6pPr>
             <a:lvl7pPr>
+              <a:buNone/>
               <a:defRPr sz="1125" b="1">
                 <a:solidFill>
                   <a:srgbClr val="146B5F"/>
@@ -4757,6 +4816,7 @@
               </a:defRPr>
             </a:lvl7pPr>
             <a:lvl8pPr>
+              <a:buNone/>
               <a:defRPr sz="1125" b="1">
                 <a:solidFill>
                   <a:srgbClr val="146B5F"/>
@@ -4767,6 +4827,7 @@
               </a:defRPr>
             </a:lvl8pPr>
             <a:lvl9pPr>
+              <a:buNone/>
               <a:defRPr sz="1125" b="1">
                 <a:solidFill>
                   <a:srgbClr val="146B5F"/>
@@ -4779,6 +4840,7 @@
           </a:lstStyle>
           <a:p xmlns:a="http://schemas.openxmlformats.org/drawingml/2006/main">
             <a:pPr>
+              <a:buNone/>
               <a:defRPr sz="1125" b="1">
                 <a:solidFill>
                   <a:srgbClr val="146B5F"/>
@@ -4843,6 +4905,7 @@
               </a:defRPr>
             </a:defPPr>
             <a:lvl1pPr>
+              <a:buNone/>
               <a:defRPr sz="3825" b="0">
                 <a:solidFill>
                   <a:srgbClr val="172E32"/>
@@ -4853,6 +4916,7 @@
               </a:defRPr>
             </a:lvl1pPr>
             <a:lvl2pPr>
+              <a:buNone/>
               <a:defRPr sz="3825" b="0">
                 <a:solidFill>
                   <a:srgbClr val="172E32"/>
@@ -4863,6 +4927,7 @@
               </a:defRPr>
             </a:lvl2pPr>
             <a:lvl3pPr>
+              <a:buNone/>
               <a:defRPr sz="3825" b="0">
                 <a:solidFill>
                   <a:srgbClr val="172E32"/>
@@ -4873,6 +4938,7 @@
               </a:defRPr>
             </a:lvl3pPr>
             <a:lvl4pPr>
+              <a:buNone/>
               <a:defRPr sz="3825" b="0">
                 <a:solidFill>
                   <a:srgbClr val="172E32"/>
@@ -4883,6 +4949,7 @@
               </a:defRPr>
             </a:lvl4pPr>
             <a:lvl5pPr>
+              <a:buNone/>
               <a:defRPr sz="3825" b="0">
                 <a:solidFill>
                   <a:srgbClr val="172E32"/>
@@ -4893,6 +4960,7 @@
               </a:defRPr>
             </a:lvl5pPr>
             <a:lvl6pPr>
+              <a:buNone/>
               <a:defRPr sz="3825" b="0">
                 <a:solidFill>
                   <a:srgbClr val="172E32"/>
@@ -4903,6 +4971,7 @@
               </a:defRPr>
             </a:lvl6pPr>
             <a:lvl7pPr>
+              <a:buNone/>
               <a:defRPr sz="3825" b="0">
                 <a:solidFill>
                   <a:srgbClr val="172E32"/>
@@ -4913,6 +4982,7 @@
               </a:defRPr>
             </a:lvl7pPr>
             <a:lvl8pPr>
+              <a:buNone/>
               <a:defRPr sz="3825" b="0">
                 <a:solidFill>
                   <a:srgbClr val="172E32"/>
@@ -4923,6 +4993,7 @@
               </a:defRPr>
             </a:lvl8pPr>
             <a:lvl9pPr>
+              <a:buNone/>
               <a:defRPr sz="3825" b="0">
                 <a:solidFill>
                   <a:srgbClr val="172E32"/>
@@ -4935,6 +5006,7 @@
           </a:lstStyle>
           <a:p xmlns:a="http://schemas.openxmlformats.org/drawingml/2006/main">
             <a:pPr>
+              <a:buNone/>
               <a:defRPr sz="3825" b="0">
                 <a:solidFill>
                   <a:srgbClr val="172E32"/>
@@ -4999,6 +5071,7 @@
               </a:defRPr>
             </a:defPPr>
             <a:lvl1pPr>
+              <a:buNone/>
               <a:defRPr sz="1050" b="0">
                 <a:solidFill>
                   <a:srgbClr val="657574"/>
@@ -5009,6 +5082,7 @@
               </a:defRPr>
             </a:lvl1pPr>
             <a:lvl2pPr>
+              <a:buNone/>
               <a:defRPr sz="1050" b="0">
                 <a:solidFill>
                   <a:srgbClr val="657574"/>
@@ -5019,6 +5093,7 @@
               </a:defRPr>
             </a:lvl2pPr>
             <a:lvl3pPr>
+              <a:buNone/>
               <a:defRPr sz="1050" b="0">
                 <a:solidFill>
                   <a:srgbClr val="657574"/>
@@ -5029,6 +5104,7 @@
               </a:defRPr>
             </a:lvl3pPr>
             <a:lvl4pPr>
+              <a:buNone/>
               <a:defRPr sz="1050" b="0">
                 <a:solidFill>
                   <a:srgbClr val="657574"/>
@@ -5039,6 +5115,7 @@
               </a:defRPr>
             </a:lvl4pPr>
             <a:lvl5pPr>
+              <a:buNone/>
               <a:defRPr sz="1050" b="0">
                 <a:solidFill>
                   <a:srgbClr val="657574"/>
@@ -5049,6 +5126,7 @@
               </a:defRPr>
             </a:lvl5pPr>
             <a:lvl6pPr>
+              <a:buNone/>
               <a:defRPr sz="1050" b="0">
                 <a:solidFill>
                   <a:srgbClr val="657574"/>
@@ -5059,6 +5137,7 @@
               </a:defRPr>
             </a:lvl6pPr>
             <a:lvl7pPr>
+              <a:buNone/>
               <a:defRPr sz="1050" b="0">
                 <a:solidFill>
                   <a:srgbClr val="657574"/>
@@ -5069,6 +5148,7 @@
               </a:defRPr>
             </a:lvl7pPr>
             <a:lvl8pPr>
+              <a:buNone/>
               <a:defRPr sz="1050" b="0">
                 <a:solidFill>
                   <a:srgbClr val="657574"/>
@@ -5079,6 +5159,7 @@
               </a:defRPr>
             </a:lvl8pPr>
             <a:lvl9pPr>
+              <a:buNone/>
               <a:defRPr sz="1050" b="0">
                 <a:solidFill>
                   <a:srgbClr val="657574"/>
@@ -5091,6 +5172,7 @@
           </a:lstStyle>
           <a:p xmlns:a="http://schemas.openxmlformats.org/drawingml/2006/main">
             <a:pPr>
+              <a:buNone/>
               <a:defRPr sz="1050" b="0">
                 <a:solidFill>
                   <a:srgbClr val="657574"/>
@@ -5155,6 +5237,7 @@
               </a:defRPr>
             </a:defPPr>
             <a:lvl1pPr>
+              <a:buNone/>
               <a:defRPr sz="2025" b="1">
                 <a:solidFill>
                   <a:srgbClr val="146B5F"/>
@@ -5165,6 +5248,7 @@
               </a:defRPr>
             </a:lvl1pPr>
             <a:lvl2pPr>
+              <a:buNone/>
               <a:defRPr sz="2025" b="1">
                 <a:solidFill>
                   <a:srgbClr val="146B5F"/>
@@ -5175,6 +5259,7 @@
               </a:defRPr>
             </a:lvl2pPr>
             <a:lvl3pPr>
+              <a:buNone/>
               <a:defRPr sz="2025" b="1">
                 <a:solidFill>
                   <a:srgbClr val="146B5F"/>
@@ -5185,6 +5270,7 @@
               </a:defRPr>
             </a:lvl3pPr>
             <a:lvl4pPr>
+              <a:buNone/>
               <a:defRPr sz="2025" b="1">
                 <a:solidFill>
                   <a:srgbClr val="146B5F"/>
@@ -5195,6 +5281,7 @@
               </a:defRPr>
             </a:lvl4pPr>
             <a:lvl5pPr>
+              <a:buNone/>
               <a:defRPr sz="2025" b="1">
                 <a:solidFill>
                   <a:srgbClr val="146B5F"/>
@@ -5205,6 +5292,7 @@
               </a:defRPr>
             </a:lvl5pPr>
             <a:lvl6pPr>
+              <a:buNone/>
               <a:defRPr sz="2025" b="1">
                 <a:solidFill>
                   <a:srgbClr val="146B5F"/>
@@ -5215,6 +5303,7 @@
               </a:defRPr>
             </a:lvl6pPr>
             <a:lvl7pPr>
+              <a:buNone/>
               <a:defRPr sz="2025" b="1">
                 <a:solidFill>
                   <a:srgbClr val="146B5F"/>
@@ -5225,6 +5314,7 @@
               </a:defRPr>
             </a:lvl7pPr>
             <a:lvl8pPr>
+              <a:buNone/>
               <a:defRPr sz="2025" b="1">
                 <a:solidFill>
                   <a:srgbClr val="146B5F"/>
@@ -5235,6 +5325,7 @@
               </a:defRPr>
             </a:lvl8pPr>
             <a:lvl9pPr>
+              <a:buNone/>
               <a:defRPr sz="2025" b="1">
                 <a:solidFill>
                   <a:srgbClr val="146B5F"/>
@@ -5247,6 +5338,7 @@
           </a:lstStyle>
           <a:p xmlns:a="http://schemas.openxmlformats.org/drawingml/2006/main">
             <a:pPr>
+              <a:buNone/>
               <a:defRPr sz="2025" b="1">
                 <a:solidFill>
                   <a:srgbClr val="146B5F"/>
@@ -5275,7 +5367,7 @@
           <p:cNvPr id="5" name="">
             <a:extLst xmlns:a="http://schemas.openxmlformats.org/drawingml/2006/main">
               <a:ext uri="{FF2B5EF4-FFF2-40B4-BE49-F238E27FC236}">
-                <a16:creationId xmlns:a16="http://schemas.microsoft.com/office/drawing/2014/main" id="{5973BDDA-7E14-4A68-865B-2539A26ABD8F}"/>
+                <a16:creationId xmlns:a16="http://schemas.microsoft.com/office/drawing/2014/main" id="{AAD2F8F0-B3AD-44BD-AD2A-86225181D288}"/>
               </a:ext>
             </a:extLst>
           </p:cNvPr>
@@ -5822,6 +5914,7 @@
               </a:defRPr>
             </a:defPPr>
             <a:lvl1pPr>
+              <a:buNone/>
               <a:defRPr sz="1725" b="0">
                 <a:solidFill>
                   <a:srgbClr val="657574"/>
@@ -5832,6 +5925,7 @@
               </a:defRPr>
             </a:lvl1pPr>
             <a:lvl2pPr>
+              <a:buNone/>
               <a:defRPr sz="1725" b="0">
                 <a:solidFill>
                   <a:srgbClr val="657574"/>
@@ -5842,6 +5936,7 @@
               </a:defRPr>
             </a:lvl2pPr>
             <a:lvl3pPr>
+              <a:buNone/>
               <a:defRPr sz="1725" b="0">
                 <a:solidFill>
                   <a:srgbClr val="657574"/>
@@ -5852,6 +5947,7 @@
               </a:defRPr>
             </a:lvl3pPr>
             <a:lvl4pPr>
+              <a:buNone/>
               <a:defRPr sz="1725" b="0">
                 <a:solidFill>
                   <a:srgbClr val="657574"/>
@@ -5862,6 +5958,7 @@
               </a:defRPr>
             </a:lvl4pPr>
             <a:lvl5pPr>
+              <a:buNone/>
               <a:defRPr sz="1725" b="0">
                 <a:solidFill>
                   <a:srgbClr val="657574"/>
@@ -5872,6 +5969,7 @@
               </a:defRPr>
             </a:lvl5pPr>
             <a:lvl6pPr>
+              <a:buNone/>
               <a:defRPr sz="1725" b="0">
                 <a:solidFill>
                   <a:srgbClr val="657574"/>
@@ -5882,6 +5980,7 @@
               </a:defRPr>
             </a:lvl6pPr>
             <a:lvl7pPr>
+              <a:buNone/>
               <a:defRPr sz="1725" b="0">
                 <a:solidFill>
                   <a:srgbClr val="657574"/>
@@ -5892,6 +5991,7 @@
               </a:defRPr>
             </a:lvl7pPr>
             <a:lvl8pPr>
+              <a:buNone/>
               <a:defRPr sz="1725" b="0">
                 <a:solidFill>
                   <a:srgbClr val="657574"/>
@@ -5902,6 +6002,7 @@
               </a:defRPr>
             </a:lvl8pPr>
             <a:lvl9pPr>
+              <a:buNone/>
               <a:defRPr sz="1725" b="0">
                 <a:solidFill>
                   <a:srgbClr val="657574"/>
@@ -5914,6 +6015,7 @@
           </a:lstStyle>
           <a:p xmlns:a="http://schemas.openxmlformats.org/drawingml/2006/main">
             <a:pPr>
+              <a:buNone/>
               <a:defRPr sz="1725" b="0">
                 <a:solidFill>
                   <a:srgbClr val="657574"/>
@@ -5937,6 +6039,7 @@
           </a:p>
           <a:p xmlns:a="http://schemas.openxmlformats.org/drawingml/2006/main">
             <a:pPr>
+              <a:buNone/>
               <a:defRPr sz="1725" b="0">
                 <a:solidFill>
                   <a:srgbClr val="657574"/>
@@ -6030,6 +6133,7 @@
               </a:defRPr>
             </a:defPPr>
             <a:lvl1pPr>
+              <a:buNone/>
               <a:defRPr sz="1125" b="1">
                 <a:solidFill>
                   <a:srgbClr val="146B5F"/>
@@ -6040,6 +6144,7 @@
               </a:defRPr>
             </a:lvl1pPr>
             <a:lvl2pPr>
+              <a:buNone/>
               <a:defRPr sz="1125" b="1">
                 <a:solidFill>
                   <a:srgbClr val="146B5F"/>
@@ -6050,6 +6155,7 @@
               </a:defRPr>
             </a:lvl2pPr>
             <a:lvl3pPr>
+              <a:buNone/>
               <a:defRPr sz="1125" b="1">
                 <a:solidFill>
                   <a:srgbClr val="146B5F"/>
@@ -6060,6 +6166,7 @@
               </a:defRPr>
             </a:lvl3pPr>
             <a:lvl4pPr>
+              <a:buNone/>
               <a:defRPr sz="1125" b="1">
                 <a:solidFill>
                   <a:srgbClr val="146B5F"/>
@@ -6070,6 +6177,7 @@
               </a:defRPr>
             </a:lvl4pPr>
             <a:lvl5pPr>
+              <a:buNone/>
               <a:defRPr sz="1125" b="1">
                 <a:solidFill>
                   <a:srgbClr val="146B5F"/>
@@ -6080,6 +6188,7 @@
               </a:defRPr>
             </a:lvl5pPr>
             <a:lvl6pPr>
+              <a:buNone/>
               <a:defRPr sz="1125" b="1">
                 <a:solidFill>
                   <a:srgbClr val="146B5F"/>
@@ -6090,6 +6199,7 @@
               </a:defRPr>
             </a:lvl6pPr>
             <a:lvl7pPr>
+              <a:buNone/>
               <a:defRPr sz="1125" b="1">
                 <a:solidFill>
                   <a:srgbClr val="146B5F"/>
@@ -6100,6 +6210,7 @@
               </a:defRPr>
             </a:lvl7pPr>
             <a:lvl8pPr>
+              <a:buNone/>
               <a:defRPr sz="1125" b="1">
                 <a:solidFill>
                   <a:srgbClr val="146B5F"/>
@@ -6110,6 +6221,7 @@
               </a:defRPr>
             </a:lvl8pPr>
             <a:lvl9pPr>
+              <a:buNone/>
               <a:defRPr sz="1125" b="1">
                 <a:solidFill>
                   <a:srgbClr val="146B5F"/>
@@ -6122,6 +6234,7 @@
           </a:lstStyle>
           <a:p xmlns:a="http://schemas.openxmlformats.org/drawingml/2006/main">
             <a:pPr>
+              <a:buNone/>
               <a:defRPr sz="1125" b="1">
                 <a:solidFill>
                   <a:srgbClr val="146B5F"/>
@@ -6186,6 +6299,7 @@
               </a:defRPr>
             </a:defPPr>
             <a:lvl1pPr>
+              <a:buNone/>
               <a:defRPr sz="3825" b="0">
                 <a:solidFill>
                   <a:srgbClr val="172E32"/>
@@ -6196,6 +6310,7 @@
               </a:defRPr>
             </a:lvl1pPr>
             <a:lvl2pPr>
+              <a:buNone/>
               <a:defRPr sz="3825" b="0">
                 <a:solidFill>
                   <a:srgbClr val="172E32"/>
@@ -6206,6 +6321,7 @@
               </a:defRPr>
             </a:lvl2pPr>
             <a:lvl3pPr>
+              <a:buNone/>
               <a:defRPr sz="3825" b="0">
                 <a:solidFill>
                   <a:srgbClr val="172E32"/>
@@ -6216,6 +6332,7 @@
               </a:defRPr>
             </a:lvl3pPr>
             <a:lvl4pPr>
+              <a:buNone/>
               <a:defRPr sz="3825" b="0">
                 <a:solidFill>
                   <a:srgbClr val="172E32"/>
@@ -6226,6 +6343,7 @@
               </a:defRPr>
             </a:lvl4pPr>
             <a:lvl5pPr>
+              <a:buNone/>
               <a:defRPr sz="3825" b="0">
                 <a:solidFill>
                   <a:srgbClr val="172E32"/>
@@ -6236,6 +6354,7 @@
               </a:defRPr>
             </a:lvl5pPr>
             <a:lvl6pPr>
+              <a:buNone/>
               <a:defRPr sz="3825" b="0">
                 <a:solidFill>
                   <a:srgbClr val="172E32"/>
@@ -6246,6 +6365,7 @@
               </a:defRPr>
             </a:lvl6pPr>
             <a:lvl7pPr>
+              <a:buNone/>
               <a:defRPr sz="3825" b="0">
                 <a:solidFill>
                   <a:srgbClr val="172E32"/>
@@ -6256,6 +6376,7 @@
               </a:defRPr>
             </a:lvl7pPr>
             <a:lvl8pPr>
+              <a:buNone/>
               <a:defRPr sz="3825" b="0">
                 <a:solidFill>
                   <a:srgbClr val="172E32"/>
@@ -6266,6 +6387,7 @@
               </a:defRPr>
             </a:lvl8pPr>
             <a:lvl9pPr>
+              <a:buNone/>
               <a:defRPr sz="3825" b="0">
                 <a:solidFill>
                   <a:srgbClr val="172E32"/>
@@ -6278,6 +6400,7 @@
           </a:lstStyle>
           <a:p xmlns:a="http://schemas.openxmlformats.org/drawingml/2006/main">
             <a:pPr>
+              <a:buNone/>
               <a:defRPr sz="3825" b="0">
                 <a:solidFill>
                   <a:srgbClr val="172E32"/>
@@ -6342,6 +6465,7 @@
               </a:defRPr>
             </a:defPPr>
             <a:lvl1pPr>
+              <a:buNone/>
               <a:defRPr sz="1050" b="0">
                 <a:solidFill>
                   <a:srgbClr val="657574"/>
@@ -6352,6 +6476,7 @@
               </a:defRPr>
             </a:lvl1pPr>
             <a:lvl2pPr>
+              <a:buNone/>
               <a:defRPr sz="1050" b="0">
                 <a:solidFill>
                   <a:srgbClr val="657574"/>
@@ -6362,6 +6487,7 @@
               </a:defRPr>
             </a:lvl2pPr>
             <a:lvl3pPr>
+              <a:buNone/>
               <a:defRPr sz="1050" b="0">
                 <a:solidFill>
                   <a:srgbClr val="657574"/>
@@ -6372,6 +6498,7 @@
               </a:defRPr>
             </a:lvl3pPr>
             <a:lvl4pPr>
+              <a:buNone/>
               <a:defRPr sz="1050" b="0">
                 <a:solidFill>
                   <a:srgbClr val="657574"/>
@@ -6382,6 +6509,7 @@
               </a:defRPr>
             </a:lvl4pPr>
             <a:lvl5pPr>
+              <a:buNone/>
               <a:defRPr sz="1050" b="0">
                 <a:solidFill>
                   <a:srgbClr val="657574"/>
@@ -6392,6 +6520,7 @@
               </a:defRPr>
             </a:lvl5pPr>
             <a:lvl6pPr>
+              <a:buNone/>
               <a:defRPr sz="1050" b="0">
                 <a:solidFill>
                   <a:srgbClr val="657574"/>
@@ -6402,6 +6531,7 @@
               </a:defRPr>
             </a:lvl6pPr>
             <a:lvl7pPr>
+              <a:buNone/>
               <a:defRPr sz="1050" b="0">
                 <a:solidFill>
                   <a:srgbClr val="657574"/>
@@ -6412,6 +6542,7 @@
               </a:defRPr>
             </a:lvl7pPr>
             <a:lvl8pPr>
+              <a:buNone/>
               <a:defRPr sz="1050" b="0">
                 <a:solidFill>
                   <a:srgbClr val="657574"/>
@@ -6422,6 +6553,7 @@
               </a:defRPr>
             </a:lvl8pPr>
             <a:lvl9pPr>
+              <a:buNone/>
               <a:defRPr sz="1050" b="0">
                 <a:solidFill>
                   <a:srgbClr val="657574"/>
@@ -6434,6 +6566,7 @@
           </a:lstStyle>
           <a:p xmlns:a="http://schemas.openxmlformats.org/drawingml/2006/main">
             <a:pPr>
+              <a:buNone/>
               <a:defRPr sz="1050" b="0">
                 <a:solidFill>
                   <a:srgbClr val="657574"/>
@@ -6462,7 +6595,7 @@
           <p:cNvPr id="4" name="">
             <a:extLst xmlns:a="http://schemas.openxmlformats.org/drawingml/2006/main">
               <a:ext uri="{FF2B5EF4-FFF2-40B4-BE49-F238E27FC236}">
-                <a16:creationId xmlns:a16="http://schemas.microsoft.com/office/drawing/2014/main" id="{D374D7CF-4226-4E8B-BA9B-BDA9651F86BD}"/>
+                <a16:creationId xmlns:a16="http://schemas.microsoft.com/office/drawing/2014/main" id="{94808FCA-AF34-43A7-8FE7-16D36FEFCBAD}"/>
               </a:ext>
             </a:extLst>
           </p:cNvPr>
@@ -7125,6 +7258,7 @@
               </a:defRPr>
             </a:defPPr>
             <a:lvl1pPr>
+              <a:buNone/>
               <a:defRPr sz="1800" b="0">
                 <a:solidFill>
                   <a:srgbClr val="657574"/>
@@ -7135,6 +7269,7 @@
               </a:defRPr>
             </a:lvl1pPr>
             <a:lvl2pPr>
+              <a:buNone/>
               <a:defRPr sz="1800" b="0">
                 <a:solidFill>
                   <a:srgbClr val="657574"/>
@@ -7145,6 +7280,7 @@
               </a:defRPr>
             </a:lvl2pPr>
             <a:lvl3pPr>
+              <a:buNone/>
               <a:defRPr sz="1800" b="0">
                 <a:solidFill>
                   <a:srgbClr val="657574"/>
@@ -7155,6 +7291,7 @@
               </a:defRPr>
             </a:lvl3pPr>
             <a:lvl4pPr>
+              <a:buNone/>
               <a:defRPr sz="1800" b="0">
                 <a:solidFill>
                   <a:srgbClr val="657574"/>
@@ -7165,6 +7302,7 @@
               </a:defRPr>
             </a:lvl4pPr>
             <a:lvl5pPr>
+              <a:buNone/>
               <a:defRPr sz="1800" b="0">
                 <a:solidFill>
                   <a:srgbClr val="657574"/>
@@ -7175,6 +7313,7 @@
               </a:defRPr>
             </a:lvl5pPr>
             <a:lvl6pPr>
+              <a:buNone/>
               <a:defRPr sz="1800" b="0">
                 <a:solidFill>
                   <a:srgbClr val="657574"/>
@@ -7185,6 +7324,7 @@
               </a:defRPr>
             </a:lvl6pPr>
             <a:lvl7pPr>
+              <a:buNone/>
               <a:defRPr sz="1800" b="0">
                 <a:solidFill>
                   <a:srgbClr val="657574"/>
@@ -7195,6 +7335,7 @@
               </a:defRPr>
             </a:lvl7pPr>
             <a:lvl8pPr>
+              <a:buNone/>
               <a:defRPr sz="1800" b="0">
                 <a:solidFill>
                   <a:srgbClr val="657574"/>
@@ -7205,6 +7346,7 @@
               </a:defRPr>
             </a:lvl8pPr>
             <a:lvl9pPr>
+              <a:buNone/>
               <a:defRPr sz="1800" b="0">
                 <a:solidFill>
                   <a:srgbClr val="657574"/>
@@ -7217,6 +7359,7 @@
           </a:lstStyle>
           <a:p xmlns:a="http://schemas.openxmlformats.org/drawingml/2006/main">
             <a:pPr>
+              <a:buNone/>
               <a:defRPr sz="1800" b="0">
                 <a:solidFill>
                   <a:srgbClr val="657574"/>
@@ -7310,6 +7453,7 @@
               </a:defRPr>
             </a:defPPr>
             <a:lvl1pPr>
+              <a:buNone/>
               <a:defRPr sz="1125" b="1">
                 <a:solidFill>
                   <a:srgbClr val="146B5F"/>
@@ -7320,6 +7464,7 @@
               </a:defRPr>
             </a:lvl1pPr>
             <a:lvl2pPr>
+              <a:buNone/>
               <a:defRPr sz="1125" b="1">
                 <a:solidFill>
                   <a:srgbClr val="146B5F"/>
@@ -7330,6 +7475,7 @@
               </a:defRPr>
             </a:lvl2pPr>
             <a:lvl3pPr>
+              <a:buNone/>
               <a:defRPr sz="1125" b="1">
                 <a:solidFill>
                   <a:srgbClr val="146B5F"/>
@@ -7340,6 +7486,7 @@
               </a:defRPr>
             </a:lvl3pPr>
             <a:lvl4pPr>
+              <a:buNone/>
               <a:defRPr sz="1125" b="1">
                 <a:solidFill>
                   <a:srgbClr val="146B5F"/>
@@ -7350,6 +7497,7 @@
               </a:defRPr>
             </a:lvl4pPr>
             <a:lvl5pPr>
+              <a:buNone/>
               <a:defRPr sz="1125" b="1">
                 <a:solidFill>
                   <a:srgbClr val="146B5F"/>
@@ -7360,6 +7508,7 @@
               </a:defRPr>
             </a:lvl5pPr>
             <a:lvl6pPr>
+              <a:buNone/>
               <a:defRPr sz="1125" b="1">
                 <a:solidFill>
                   <a:srgbClr val="146B5F"/>
@@ -7370,6 +7519,7 @@
               </a:defRPr>
             </a:lvl6pPr>
             <a:lvl7pPr>
+              <a:buNone/>
               <a:defRPr sz="1125" b="1">
                 <a:solidFill>
                   <a:srgbClr val="146B5F"/>
@@ -7380,6 +7530,7 @@
               </a:defRPr>
             </a:lvl7pPr>
             <a:lvl8pPr>
+              <a:buNone/>
               <a:defRPr sz="1125" b="1">
                 <a:solidFill>
                   <a:srgbClr val="146B5F"/>
@@ -7390,6 +7541,7 @@
               </a:defRPr>
             </a:lvl8pPr>
             <a:lvl9pPr>
+              <a:buNone/>
               <a:defRPr sz="1125" b="1">
                 <a:solidFill>
                   <a:srgbClr val="146B5F"/>
@@ -7402,6 +7554,7 @@
           </a:lstStyle>
           <a:p xmlns:a="http://schemas.openxmlformats.org/drawingml/2006/main">
             <a:pPr>
+              <a:buNone/>
               <a:defRPr sz="1125" b="1">
                 <a:solidFill>
                   <a:srgbClr val="146B5F"/>
@@ -7466,6 +7619,7 @@
               </a:defRPr>
             </a:defPPr>
             <a:lvl1pPr>
+              <a:buNone/>
               <a:defRPr sz="3825" b="0">
                 <a:solidFill>
                   <a:srgbClr val="172E32"/>
@@ -7476,6 +7630,7 @@
               </a:defRPr>
             </a:lvl1pPr>
             <a:lvl2pPr>
+              <a:buNone/>
               <a:defRPr sz="3825" b="0">
                 <a:solidFill>
                   <a:srgbClr val="172E32"/>
@@ -7486,6 +7641,7 @@
               </a:defRPr>
             </a:lvl2pPr>
             <a:lvl3pPr>
+              <a:buNone/>
               <a:defRPr sz="3825" b="0">
                 <a:solidFill>
                   <a:srgbClr val="172E32"/>
@@ -7496,6 +7652,7 @@
               </a:defRPr>
             </a:lvl3pPr>
             <a:lvl4pPr>
+              <a:buNone/>
               <a:defRPr sz="3825" b="0">
                 <a:solidFill>
                   <a:srgbClr val="172E32"/>
@@ -7506,6 +7663,7 @@
               </a:defRPr>
             </a:lvl4pPr>
             <a:lvl5pPr>
+              <a:buNone/>
               <a:defRPr sz="3825" b="0">
                 <a:solidFill>
                   <a:srgbClr val="172E32"/>
@@ -7516,6 +7674,7 @@
               </a:defRPr>
             </a:lvl5pPr>
             <a:lvl6pPr>
+              <a:buNone/>
               <a:defRPr sz="3825" b="0">
                 <a:solidFill>
                   <a:srgbClr val="172E32"/>
@@ -7526,6 +7685,7 @@
               </a:defRPr>
             </a:lvl6pPr>
             <a:lvl7pPr>
+              <a:buNone/>
               <a:defRPr sz="3825" b="0">
                 <a:solidFill>
                   <a:srgbClr val="172E32"/>
@@ -7536,6 +7696,7 @@
               </a:defRPr>
             </a:lvl7pPr>
             <a:lvl8pPr>
+              <a:buNone/>
               <a:defRPr sz="3825" b="0">
                 <a:solidFill>
                   <a:srgbClr val="172E32"/>
@@ -7546,6 +7707,7 @@
               </a:defRPr>
             </a:lvl8pPr>
             <a:lvl9pPr>
+              <a:buNone/>
               <a:defRPr sz="3825" b="0">
                 <a:solidFill>
                   <a:srgbClr val="172E32"/>
@@ -7558,6 +7720,7 @@
           </a:lstStyle>
           <a:p xmlns:a="http://schemas.openxmlformats.org/drawingml/2006/main">
             <a:pPr>
+              <a:buNone/>
               <a:defRPr sz="3825" b="0">
                 <a:solidFill>
                   <a:srgbClr val="172E32"/>
@@ -7622,6 +7785,7 @@
               </a:defRPr>
             </a:defPPr>
             <a:lvl1pPr>
+              <a:buNone/>
               <a:defRPr sz="1050" b="0">
                 <a:solidFill>
                   <a:srgbClr val="657574"/>
@@ -7632,6 +7796,7 @@
               </a:defRPr>
             </a:lvl1pPr>
             <a:lvl2pPr>
+              <a:buNone/>
               <a:defRPr sz="1050" b="0">
                 <a:solidFill>
                   <a:srgbClr val="657574"/>
@@ -7642,6 +7807,7 @@
               </a:defRPr>
             </a:lvl2pPr>
             <a:lvl3pPr>
+              <a:buNone/>
               <a:defRPr sz="1050" b="0">
                 <a:solidFill>
                   <a:srgbClr val="657574"/>
@@ -7652,6 +7818,7 @@
               </a:defRPr>
             </a:lvl3pPr>
             <a:lvl4pPr>
+              <a:buNone/>
               <a:defRPr sz="1050" b="0">
                 <a:solidFill>
                   <a:srgbClr val="657574"/>
@@ -7662,6 +7829,7 @@
               </a:defRPr>
             </a:lvl4pPr>
             <a:lvl5pPr>
+              <a:buNone/>
               <a:defRPr sz="1050" b="0">
                 <a:solidFill>
                   <a:srgbClr val="657574"/>
@@ -7672,6 +7840,7 @@
               </a:defRPr>
             </a:lvl5pPr>
             <a:lvl6pPr>
+              <a:buNone/>
               <a:defRPr sz="1050" b="0">
                 <a:solidFill>
                   <a:srgbClr val="657574"/>
@@ -7682,6 +7851,7 @@
               </a:defRPr>
             </a:lvl6pPr>
             <a:lvl7pPr>
+              <a:buNone/>
               <a:defRPr sz="1050" b="0">
                 <a:solidFill>
                   <a:srgbClr val="657574"/>
@@ -7692,6 +7862,7 @@
               </a:defRPr>
             </a:lvl7pPr>
             <a:lvl8pPr>
+              <a:buNone/>
               <a:defRPr sz="1050" b="0">
                 <a:solidFill>
                   <a:srgbClr val="657574"/>
@@ -7702,6 +7873,7 @@
               </a:defRPr>
             </a:lvl8pPr>
             <a:lvl9pPr>
+              <a:buNone/>
               <a:defRPr sz="1050" b="0">
                 <a:solidFill>
                   <a:srgbClr val="657574"/>
@@ -7714,6 +7886,7 @@
           </a:lstStyle>
           <a:p xmlns:a="http://schemas.openxmlformats.org/drawingml/2006/main">
             <a:pPr>
+              <a:buNone/>
               <a:defRPr sz="1050" b="0">
                 <a:solidFill>
                   <a:srgbClr val="657574"/>
@@ -7778,6 +7951,7 @@
               </a:defRPr>
             </a:defPPr>
             <a:lvl1pPr>
+              <a:buNone/>
               <a:defRPr sz="2325" b="1">
                 <a:solidFill>
                   <a:srgbClr val="146B5F"/>
@@ -7788,6 +7962,7 @@
               </a:defRPr>
             </a:lvl1pPr>
             <a:lvl2pPr>
+              <a:buNone/>
               <a:defRPr sz="2325" b="1">
                 <a:solidFill>
                   <a:srgbClr val="146B5F"/>
@@ -7798,6 +7973,7 @@
               </a:defRPr>
             </a:lvl2pPr>
             <a:lvl3pPr>
+              <a:buNone/>
               <a:defRPr sz="2325" b="1">
                 <a:solidFill>
                   <a:srgbClr val="146B5F"/>
@@ -7808,6 +7984,7 @@
               </a:defRPr>
             </a:lvl3pPr>
             <a:lvl4pPr>
+              <a:buNone/>
               <a:defRPr sz="2325" b="1">
                 <a:solidFill>
                   <a:srgbClr val="146B5F"/>
@@ -7818,6 +7995,7 @@
               </a:defRPr>
             </a:lvl4pPr>
             <a:lvl5pPr>
+              <a:buNone/>
               <a:defRPr sz="2325" b="1">
                 <a:solidFill>
                   <a:srgbClr val="146B5F"/>
@@ -7828,6 +8006,7 @@
               </a:defRPr>
             </a:lvl5pPr>
             <a:lvl6pPr>
+              <a:buNone/>
               <a:defRPr sz="2325" b="1">
                 <a:solidFill>
                   <a:srgbClr val="146B5F"/>
@@ -7838,6 +8017,7 @@
               </a:defRPr>
             </a:lvl6pPr>
             <a:lvl7pPr>
+              <a:buNone/>
               <a:defRPr sz="2325" b="1">
                 <a:solidFill>
                   <a:srgbClr val="146B5F"/>
@@ -7848,6 +8028,7 @@
               </a:defRPr>
             </a:lvl7pPr>
             <a:lvl8pPr>
+              <a:buNone/>
               <a:defRPr sz="2325" b="1">
                 <a:solidFill>
                   <a:srgbClr val="146B5F"/>
@@ -7858,6 +8039,7 @@
               </a:defRPr>
             </a:lvl8pPr>
             <a:lvl9pPr>
+              <a:buNone/>
               <a:defRPr sz="2325" b="1">
                 <a:solidFill>
                   <a:srgbClr val="146B5F"/>
@@ -7870,6 +8052,7 @@
           </a:lstStyle>
           <a:p xmlns:a="http://schemas.openxmlformats.org/drawingml/2006/main">
             <a:pPr>
+              <a:buNone/>
               <a:defRPr sz="2325" b="1">
                 <a:solidFill>
                   <a:srgbClr val="146B5F"/>
@@ -7934,6 +8117,7 @@
               </a:defRPr>
             </a:defPPr>
             <a:lvl1pPr>
+              <a:buNone/>
               <a:defRPr sz="2100" b="0">
                 <a:solidFill>
                   <a:srgbClr val="172E32"/>
@@ -7944,6 +8128,7 @@
               </a:defRPr>
             </a:lvl1pPr>
             <a:lvl2pPr>
+              <a:buNone/>
               <a:defRPr sz="2100" b="0">
                 <a:solidFill>
                   <a:srgbClr val="172E32"/>
@@ -7954,6 +8139,7 @@
               </a:defRPr>
             </a:lvl2pPr>
             <a:lvl3pPr>
+              <a:buNone/>
               <a:defRPr sz="2100" b="0">
                 <a:solidFill>
                   <a:srgbClr val="172E32"/>
@@ -7964,6 +8150,7 @@
               </a:defRPr>
             </a:lvl3pPr>
             <a:lvl4pPr>
+              <a:buNone/>
               <a:defRPr sz="2100" b="0">
                 <a:solidFill>
                   <a:srgbClr val="172E32"/>
@@ -7974,6 +8161,7 @@
               </a:defRPr>
             </a:lvl4pPr>
             <a:lvl5pPr>
+              <a:buNone/>
               <a:defRPr sz="2100" b="0">
                 <a:solidFill>
                   <a:srgbClr val="172E32"/>
@@ -7984,6 +8172,7 @@
               </a:defRPr>
             </a:lvl5pPr>
             <a:lvl6pPr>
+              <a:buNone/>
               <a:defRPr sz="2100" b="0">
                 <a:solidFill>
                   <a:srgbClr val="172E32"/>
@@ -7994,6 +8183,7 @@
               </a:defRPr>
             </a:lvl6pPr>
             <a:lvl7pPr>
+              <a:buNone/>
               <a:defRPr sz="2100" b="0">
                 <a:solidFill>
                   <a:srgbClr val="172E32"/>
@@ -8004,6 +8194,7 @@
               </a:defRPr>
             </a:lvl7pPr>
             <a:lvl8pPr>
+              <a:buNone/>
               <a:defRPr sz="2100" b="0">
                 <a:solidFill>
                   <a:srgbClr val="172E32"/>
@@ -8014,6 +8205,7 @@
               </a:defRPr>
             </a:lvl8pPr>
             <a:lvl9pPr>
+              <a:buNone/>
               <a:defRPr sz="2100" b="0">
                 <a:solidFill>
                   <a:srgbClr val="172E32"/>
@@ -8026,6 +8218,7 @@
           </a:lstStyle>
           <a:p xmlns:a="http://schemas.openxmlformats.org/drawingml/2006/main">
             <a:pPr>
+              <a:buNone/>
               <a:defRPr sz="2100" b="0">
                 <a:solidFill>
                   <a:srgbClr val="172E32"/>
@@ -8044,11 +8237,12 @@
                 <a:ea typeface="Helvetica Neue"/>
                 <a:cs typeface="Helvetica Neue"/>
               </a:rPr>
-              <a:t>Versioned review protocol</a:t>
+              <a:t>Host-loaded protocol in v2</a:t>
             </a:r>
           </a:p>
           <a:p xmlns:a="http://schemas.openxmlformats.org/drawingml/2006/main">
             <a:pPr>
+              <a:buNone/>
               <a:defRPr sz="2100" b="0">
                 <a:solidFill>
                   <a:srgbClr val="172E32"/>
@@ -8072,6 +8266,7 @@
           </a:p>
           <a:p xmlns:a="http://schemas.openxmlformats.org/drawingml/2006/main">
             <a:pPr>
+              <a:buNone/>
               <a:defRPr sz="2100" b="0">
                 <a:solidFill>
                   <a:srgbClr val="172E32"/>
@@ -8136,6 +8331,7 @@
               </a:defRPr>
             </a:defPPr>
             <a:lvl1pPr>
+              <a:buNone/>
               <a:defRPr sz="2325" b="1">
                 <a:solidFill>
                   <a:srgbClr val="146B5F"/>
@@ -8146,6 +8342,7 @@
               </a:defRPr>
             </a:lvl1pPr>
             <a:lvl2pPr>
+              <a:buNone/>
               <a:defRPr sz="2325" b="1">
                 <a:solidFill>
                   <a:srgbClr val="146B5F"/>
@@ -8156,6 +8353,7 @@
               </a:defRPr>
             </a:lvl2pPr>
             <a:lvl3pPr>
+              <a:buNone/>
               <a:defRPr sz="2325" b="1">
                 <a:solidFill>
                   <a:srgbClr val="146B5F"/>
@@ -8166,6 +8364,7 @@
               </a:defRPr>
             </a:lvl3pPr>
             <a:lvl4pPr>
+              <a:buNone/>
               <a:defRPr sz="2325" b="1">
                 <a:solidFill>
                   <a:srgbClr val="146B5F"/>
@@ -8176,6 +8375,7 @@
               </a:defRPr>
             </a:lvl4pPr>
             <a:lvl5pPr>
+              <a:buNone/>
               <a:defRPr sz="2325" b="1">
                 <a:solidFill>
                   <a:srgbClr val="146B5F"/>
@@ -8186,6 +8386,7 @@
               </a:defRPr>
             </a:lvl5pPr>
             <a:lvl6pPr>
+              <a:buNone/>
               <a:defRPr sz="2325" b="1">
                 <a:solidFill>
                   <a:srgbClr val="146B5F"/>
@@ -8196,6 +8397,7 @@
               </a:defRPr>
             </a:lvl6pPr>
             <a:lvl7pPr>
+              <a:buNone/>
               <a:defRPr sz="2325" b="1">
                 <a:solidFill>
                   <a:srgbClr val="146B5F"/>
@@ -8206,6 +8408,7 @@
               </a:defRPr>
             </a:lvl7pPr>
             <a:lvl8pPr>
+              <a:buNone/>
               <a:defRPr sz="2325" b="1">
                 <a:solidFill>
                   <a:srgbClr val="146B5F"/>
@@ -8216,6 +8419,7 @@
               </a:defRPr>
             </a:lvl8pPr>
             <a:lvl9pPr>
+              <a:buNone/>
               <a:defRPr sz="2325" b="1">
                 <a:solidFill>
                   <a:srgbClr val="146B5F"/>
@@ -8228,6 +8432,7 @@
           </a:lstStyle>
           <a:p xmlns:a="http://schemas.openxmlformats.org/drawingml/2006/main">
             <a:pPr>
+              <a:buNone/>
               <a:defRPr sz="2325" b="1">
                 <a:solidFill>
                   <a:srgbClr val="146B5F"/>
@@ -8292,6 +8497,7 @@
               </a:defRPr>
             </a:defPPr>
             <a:lvl1pPr>
+              <a:buNone/>
               <a:defRPr sz="2100" b="0">
                 <a:solidFill>
                   <a:srgbClr val="172E32"/>
@@ -8302,6 +8508,7 @@
               </a:defRPr>
             </a:lvl1pPr>
             <a:lvl2pPr>
+              <a:buNone/>
               <a:defRPr sz="2100" b="0">
                 <a:solidFill>
                   <a:srgbClr val="172E32"/>
@@ -8312,6 +8519,7 @@
               </a:defRPr>
             </a:lvl2pPr>
             <a:lvl3pPr>
+              <a:buNone/>
               <a:defRPr sz="2100" b="0">
                 <a:solidFill>
                   <a:srgbClr val="172E32"/>
@@ -8322,6 +8530,7 @@
               </a:defRPr>
             </a:lvl3pPr>
             <a:lvl4pPr>
+              <a:buNone/>
               <a:defRPr sz="2100" b="0">
                 <a:solidFill>
                   <a:srgbClr val="172E32"/>
@@ -8332,6 +8541,7 @@
               </a:defRPr>
             </a:lvl4pPr>
             <a:lvl5pPr>
+              <a:buNone/>
               <a:defRPr sz="2100" b="0">
                 <a:solidFill>
                   <a:srgbClr val="172E32"/>
@@ -8342,6 +8552,7 @@
               </a:defRPr>
             </a:lvl5pPr>
             <a:lvl6pPr>
+              <a:buNone/>
               <a:defRPr sz="2100" b="0">
                 <a:solidFill>
                   <a:srgbClr val="172E32"/>
@@ -8352,6 +8563,7 @@
               </a:defRPr>
             </a:lvl6pPr>
             <a:lvl7pPr>
+              <a:buNone/>
               <a:defRPr sz="2100" b="0">
                 <a:solidFill>
                   <a:srgbClr val="172E32"/>
@@ -8362,6 +8574,7 @@
               </a:defRPr>
             </a:lvl7pPr>
             <a:lvl8pPr>
+              <a:buNone/>
               <a:defRPr sz="2100" b="0">
                 <a:solidFill>
                   <a:srgbClr val="172E32"/>
@@ -8372,6 +8585,7 @@
               </a:defRPr>
             </a:lvl8pPr>
             <a:lvl9pPr>
+              <a:buNone/>
               <a:defRPr sz="2100" b="0">
                 <a:solidFill>
                   <a:srgbClr val="172E32"/>
@@ -8384,6 +8598,7 @@
           </a:lstStyle>
           <a:p xmlns:a="http://schemas.openxmlformats.org/drawingml/2006/main">
             <a:pPr>
+              <a:buNone/>
               <a:defRPr sz="2100" b="0">
                 <a:solidFill>
                   <a:srgbClr val="172E32"/>
@@ -8407,6 +8622,7 @@
           </a:p>
           <a:p xmlns:a="http://schemas.openxmlformats.org/drawingml/2006/main">
             <a:pPr>
+              <a:buNone/>
               <a:defRPr sz="2100" b="0">
                 <a:solidFill>
                   <a:srgbClr val="172E32"/>
@@ -8430,6 +8646,7 @@
           </a:p>
           <a:p xmlns:a="http://schemas.openxmlformats.org/drawingml/2006/main">
             <a:pPr>
+              <a:buNone/>
               <a:defRPr sz="2100" b="0">
                 <a:solidFill>
                   <a:srgbClr val="172E32"/>
@@ -8494,6 +8711,7 @@
               </a:defRPr>
             </a:defPPr>
             <a:lvl1pPr>
+              <a:buNone/>
               <a:defRPr sz="1875" b="0">
                 <a:solidFill>
                   <a:srgbClr val="657574"/>
@@ -8504,6 +8722,7 @@
               </a:defRPr>
             </a:lvl1pPr>
             <a:lvl2pPr>
+              <a:buNone/>
               <a:defRPr sz="1875" b="0">
                 <a:solidFill>
                   <a:srgbClr val="657574"/>
@@ -8514,6 +8733,7 @@
               </a:defRPr>
             </a:lvl2pPr>
             <a:lvl3pPr>
+              <a:buNone/>
               <a:defRPr sz="1875" b="0">
                 <a:solidFill>
                   <a:srgbClr val="657574"/>
@@ -8524,6 +8744,7 @@
               </a:defRPr>
             </a:lvl3pPr>
             <a:lvl4pPr>
+              <a:buNone/>
               <a:defRPr sz="1875" b="0">
                 <a:solidFill>
                   <a:srgbClr val="657574"/>
@@ -8534,6 +8755,7 @@
               </a:defRPr>
             </a:lvl4pPr>
             <a:lvl5pPr>
+              <a:buNone/>
               <a:defRPr sz="1875" b="0">
                 <a:solidFill>
                   <a:srgbClr val="657574"/>
@@ -8544,6 +8766,7 @@
               </a:defRPr>
             </a:lvl5pPr>
             <a:lvl6pPr>
+              <a:buNone/>
               <a:defRPr sz="1875" b="0">
                 <a:solidFill>
                   <a:srgbClr val="657574"/>
@@ -8554,6 +8777,7 @@
               </a:defRPr>
             </a:lvl6pPr>
             <a:lvl7pPr>
+              <a:buNone/>
               <a:defRPr sz="1875" b="0">
                 <a:solidFill>
                   <a:srgbClr val="657574"/>
@@ -8564,6 +8788,7 @@
               </a:defRPr>
             </a:lvl7pPr>
             <a:lvl8pPr>
+              <a:buNone/>
               <a:defRPr sz="1875" b="0">
                 <a:solidFill>
                   <a:srgbClr val="657574"/>
@@ -8574,6 +8799,7 @@
               </a:defRPr>
             </a:lvl8pPr>
             <a:lvl9pPr>
+              <a:buNone/>
               <a:defRPr sz="1875" b="0">
                 <a:solidFill>
                   <a:srgbClr val="657574"/>
@@ -8586,6 +8812,7 @@
           </a:lstStyle>
           <a:p xmlns:a="http://schemas.openxmlformats.org/drawingml/2006/main">
             <a:pPr>
+              <a:buNone/>
               <a:defRPr sz="1875" b="0">
                 <a:solidFill>
                   <a:srgbClr val="657574"/>
@@ -8604,11 +8831,12 @@
                 <a:ea typeface="Helvetica Neue"/>
                 <a:cs typeface="Helvetica Neue"/>
               </a:rPr>
-              <a:t>The procedure loader exists, but model traces do not consistently invoke it.</a:t>
+              <a:t>V2 loads and fingerprints the protocol before the first model request.</a:t>
             </a:r>
           </a:p>
           <a:p xmlns:a="http://schemas.openxmlformats.org/drawingml/2006/main">
             <a:pPr>
+              <a:buNone/>
               <a:defRPr sz="1875" b="0">
                 <a:solidFill>
                   <a:srgbClr val="657574"/>
@@ -8627,7 +8855,7 @@
                 <a:ea typeface="Helvetica Neue"/>
                 <a:cs typeface="Helvetica Neue"/>
               </a:rPr>
-              <a:t>That is a measured limitation of the current instruction strategy.</a:t>
+              <a:t>V1 remains frozen for its unfinished A/B evaluation.</a:t>
             </a:r>
           </a:p>
         </p:txBody>
@@ -8702,6 +8930,7 @@
               </a:defRPr>
             </a:defPPr>
             <a:lvl1pPr>
+              <a:buNone/>
               <a:defRPr sz="1125" b="1">
                 <a:solidFill>
                   <a:srgbClr val="146B5F"/>
@@ -8712,6 +8941,7 @@
               </a:defRPr>
             </a:lvl1pPr>
             <a:lvl2pPr>
+              <a:buNone/>
               <a:defRPr sz="1125" b="1">
                 <a:solidFill>
                   <a:srgbClr val="146B5F"/>
@@ -8722,6 +8952,7 @@
               </a:defRPr>
             </a:lvl2pPr>
             <a:lvl3pPr>
+              <a:buNone/>
               <a:defRPr sz="1125" b="1">
                 <a:solidFill>
                   <a:srgbClr val="146B5F"/>
@@ -8732,6 +8963,7 @@
               </a:defRPr>
             </a:lvl3pPr>
             <a:lvl4pPr>
+              <a:buNone/>
               <a:defRPr sz="1125" b="1">
                 <a:solidFill>
                   <a:srgbClr val="146B5F"/>
@@ -8742,6 +8974,7 @@
               </a:defRPr>
             </a:lvl4pPr>
             <a:lvl5pPr>
+              <a:buNone/>
               <a:defRPr sz="1125" b="1">
                 <a:solidFill>
                   <a:srgbClr val="146B5F"/>
@@ -8752,6 +8985,7 @@
               </a:defRPr>
             </a:lvl5pPr>
             <a:lvl6pPr>
+              <a:buNone/>
               <a:defRPr sz="1125" b="1">
                 <a:solidFill>
                   <a:srgbClr val="146B5F"/>
@@ -8762,6 +8996,7 @@
               </a:defRPr>
             </a:lvl6pPr>
             <a:lvl7pPr>
+              <a:buNone/>
               <a:defRPr sz="1125" b="1">
                 <a:solidFill>
                   <a:srgbClr val="146B5F"/>
@@ -8772,6 +9007,7 @@
               </a:defRPr>
             </a:lvl7pPr>
             <a:lvl8pPr>
+              <a:buNone/>
               <a:defRPr sz="1125" b="1">
                 <a:solidFill>
                   <a:srgbClr val="146B5F"/>
@@ -8782,6 +9018,7 @@
               </a:defRPr>
             </a:lvl8pPr>
             <a:lvl9pPr>
+              <a:buNone/>
               <a:defRPr sz="1125" b="1">
                 <a:solidFill>
                   <a:srgbClr val="146B5F"/>
@@ -8794,6 +9031,7 @@
           </a:lstStyle>
           <a:p xmlns:a="http://schemas.openxmlformats.org/drawingml/2006/main">
             <a:pPr>
+              <a:buNone/>
               <a:defRPr sz="1125" b="1">
                 <a:solidFill>
                   <a:srgbClr val="146B5F"/>
@@ -8858,6 +9096,7 @@
               </a:defRPr>
             </a:defPPr>
             <a:lvl1pPr>
+              <a:buNone/>
               <a:defRPr sz="3825" b="0">
                 <a:solidFill>
                   <a:srgbClr val="172E32"/>
@@ -8868,6 +9107,7 @@
               </a:defRPr>
             </a:lvl1pPr>
             <a:lvl2pPr>
+              <a:buNone/>
               <a:defRPr sz="3825" b="0">
                 <a:solidFill>
                   <a:srgbClr val="172E32"/>
@@ -8878,6 +9118,7 @@
               </a:defRPr>
             </a:lvl2pPr>
             <a:lvl3pPr>
+              <a:buNone/>
               <a:defRPr sz="3825" b="0">
                 <a:solidFill>
                   <a:srgbClr val="172E32"/>
@@ -8888,6 +9129,7 @@
               </a:defRPr>
             </a:lvl3pPr>
             <a:lvl4pPr>
+              <a:buNone/>
               <a:defRPr sz="3825" b="0">
                 <a:solidFill>
                   <a:srgbClr val="172E32"/>
@@ -8898,6 +9140,7 @@
               </a:defRPr>
             </a:lvl4pPr>
             <a:lvl5pPr>
+              <a:buNone/>
               <a:defRPr sz="3825" b="0">
                 <a:solidFill>
                   <a:srgbClr val="172E32"/>
@@ -8908,6 +9151,7 @@
               </a:defRPr>
             </a:lvl5pPr>
             <a:lvl6pPr>
+              <a:buNone/>
               <a:defRPr sz="3825" b="0">
                 <a:solidFill>
                   <a:srgbClr val="172E32"/>
@@ -8918,6 +9162,7 @@
               </a:defRPr>
             </a:lvl6pPr>
             <a:lvl7pPr>
+              <a:buNone/>
               <a:defRPr sz="3825" b="0">
                 <a:solidFill>
                   <a:srgbClr val="172E32"/>
@@ -8928,6 +9173,7 @@
               </a:defRPr>
             </a:lvl7pPr>
             <a:lvl8pPr>
+              <a:buNone/>
               <a:defRPr sz="3825" b="0">
                 <a:solidFill>
                   <a:srgbClr val="172E32"/>
@@ -8938,6 +9184,7 @@
               </a:defRPr>
             </a:lvl8pPr>
             <a:lvl9pPr>
+              <a:buNone/>
               <a:defRPr sz="3825" b="0">
                 <a:solidFill>
                   <a:srgbClr val="172E32"/>
@@ -8950,6 +9197,7 @@
           </a:lstStyle>
           <a:p xmlns:a="http://schemas.openxmlformats.org/drawingml/2006/main">
             <a:pPr>
+              <a:buNone/>
               <a:defRPr sz="3825" b="0">
                 <a:solidFill>
                   <a:srgbClr val="172E32"/>
@@ -8968,7 +9216,7 @@
                 <a:ea typeface="Helvetica Neue"/>
                 <a:cs typeface="Helvetica Neue"/>
               </a:rPr>
-              <a:t>A/B evidence remains incomplete</a:t>
+              <a:t>V1 evaluation coverage</a:t>
             </a:r>
           </a:p>
         </p:txBody>
@@ -9014,6 +9262,7 @@
               </a:defRPr>
             </a:defPPr>
             <a:lvl1pPr>
+              <a:buNone/>
               <a:defRPr sz="1050" b="0">
                 <a:solidFill>
                   <a:srgbClr val="657574"/>
@@ -9024,6 +9273,7 @@
               </a:defRPr>
             </a:lvl1pPr>
             <a:lvl2pPr>
+              <a:buNone/>
               <a:defRPr sz="1050" b="0">
                 <a:solidFill>
                   <a:srgbClr val="657574"/>
@@ -9034,6 +9284,7 @@
               </a:defRPr>
             </a:lvl2pPr>
             <a:lvl3pPr>
+              <a:buNone/>
               <a:defRPr sz="1050" b="0">
                 <a:solidFill>
                   <a:srgbClr val="657574"/>
@@ -9044,6 +9295,7 @@
               </a:defRPr>
             </a:lvl3pPr>
             <a:lvl4pPr>
+              <a:buNone/>
               <a:defRPr sz="1050" b="0">
                 <a:solidFill>
                   <a:srgbClr val="657574"/>
@@ -9054,6 +9306,7 @@
               </a:defRPr>
             </a:lvl4pPr>
             <a:lvl5pPr>
+              <a:buNone/>
               <a:defRPr sz="1050" b="0">
                 <a:solidFill>
                   <a:srgbClr val="657574"/>
@@ -9064,6 +9317,7 @@
               </a:defRPr>
             </a:lvl5pPr>
             <a:lvl6pPr>
+              <a:buNone/>
               <a:defRPr sz="1050" b="0">
                 <a:solidFill>
                   <a:srgbClr val="657574"/>
@@ -9074,6 +9328,7 @@
               </a:defRPr>
             </a:lvl6pPr>
             <a:lvl7pPr>
+              <a:buNone/>
               <a:defRPr sz="1050" b="0">
                 <a:solidFill>
                   <a:srgbClr val="657574"/>
@@ -9084,6 +9339,7 @@
               </a:defRPr>
             </a:lvl7pPr>
             <a:lvl8pPr>
+              <a:buNone/>
               <a:defRPr sz="1050" b="0">
                 <a:solidFill>
                   <a:srgbClr val="657574"/>
@@ -9094,6 +9350,7 @@
               </a:defRPr>
             </a:lvl8pPr>
             <a:lvl9pPr>
+              <a:buNone/>
               <a:defRPr sz="1050" b="0">
                 <a:solidFill>
                   <a:srgbClr val="657574"/>
@@ -9106,6 +9363,7 @@
           </a:lstStyle>
           <a:p xmlns:a="http://schemas.openxmlformats.org/drawingml/2006/main">
             <a:pPr>
+              <a:buNone/>
               <a:defRPr sz="1050" b="0">
                 <a:solidFill>
                   <a:srgbClr val="657574"/>
@@ -9134,7 +9392,7 @@
           <p:cNvPr id="4" name="">
             <a:extLst xmlns:a="http://schemas.openxmlformats.org/drawingml/2006/main">
               <a:ext uri="{FF2B5EF4-FFF2-40B4-BE49-F238E27FC236}">
-                <a16:creationId xmlns:a16="http://schemas.microsoft.com/office/drawing/2014/main" id="{71D643EA-EF9E-4B64-90A4-E452A7E659D5}"/>
+                <a16:creationId xmlns:a16="http://schemas.microsoft.com/office/drawing/2014/main" id="{951544CE-FD62-4A27-811C-B9FFBDAD8408}"/>
               </a:ext>
             </a:extLst>
           </p:cNvPr>
@@ -9680,6 +9938,7 @@
               </a:defRPr>
             </a:defPPr>
             <a:lvl1pPr>
+              <a:buNone/>
               <a:defRPr sz="2025" b="0">
                 <a:solidFill>
                   <a:srgbClr val="657574"/>
@@ -9690,6 +9949,7 @@
               </a:defRPr>
             </a:lvl1pPr>
             <a:lvl2pPr>
+              <a:buNone/>
               <a:defRPr sz="2025" b="0">
                 <a:solidFill>
                   <a:srgbClr val="657574"/>
@@ -9700,6 +9960,7 @@
               </a:defRPr>
             </a:lvl2pPr>
             <a:lvl3pPr>
+              <a:buNone/>
               <a:defRPr sz="2025" b="0">
                 <a:solidFill>
                   <a:srgbClr val="657574"/>
@@ -9710,6 +9971,7 @@
               </a:defRPr>
             </a:lvl3pPr>
             <a:lvl4pPr>
+              <a:buNone/>
               <a:defRPr sz="2025" b="0">
                 <a:solidFill>
                   <a:srgbClr val="657574"/>
@@ -9720,6 +9982,7 @@
               </a:defRPr>
             </a:lvl4pPr>
             <a:lvl5pPr>
+              <a:buNone/>
               <a:defRPr sz="2025" b="0">
                 <a:solidFill>
                   <a:srgbClr val="657574"/>
@@ -9730,6 +9993,7 @@
               </a:defRPr>
             </a:lvl5pPr>
             <a:lvl6pPr>
+              <a:buNone/>
               <a:defRPr sz="2025" b="0">
                 <a:solidFill>
                   <a:srgbClr val="657574"/>
@@ -9740,6 +10004,7 @@
               </a:defRPr>
             </a:lvl6pPr>
             <a:lvl7pPr>
+              <a:buNone/>
               <a:defRPr sz="2025" b="0">
                 <a:solidFill>
                   <a:srgbClr val="657574"/>
@@ -9750,6 +10015,7 @@
               </a:defRPr>
             </a:lvl7pPr>
             <a:lvl8pPr>
+              <a:buNone/>
               <a:defRPr sz="2025" b="0">
                 <a:solidFill>
                   <a:srgbClr val="657574"/>
@@ -9760,6 +10026,7 @@
               </a:defRPr>
             </a:lvl8pPr>
             <a:lvl9pPr>
+              <a:buNone/>
               <a:defRPr sz="2025" b="0">
                 <a:solidFill>
                   <a:srgbClr val="657574"/>
@@ -9772,6 +10039,7 @@
           </a:lstStyle>
           <a:p xmlns:a="http://schemas.openxmlformats.org/drawingml/2006/main">
             <a:pPr>
+              <a:buNone/>
               <a:defRPr sz="2025" b="0">
                 <a:solidFill>
                   <a:srgbClr val="657574"/>
@@ -9790,11 +10058,12 @@
                 <a:ea typeface="Helvetica Neue"/>
                 <a:cs typeface="Helvetica Neue"/>
               </a:rPr>
-              <a:t>One fresh trial per task. 24 of 36 reviews remain pending under the</a:t>
+              <a:t>V1: 12 of 36 reviews executed. V2: 0 of 36 executed.</a:t>
             </a:r>
           </a:p>
           <a:p xmlns:a="http://schemas.openxmlformats.org/drawingml/2006/main">
             <a:pPr>
+              <a:buNone/>
               <a:defRPr sz="2025" b="0">
                 <a:solidFill>
                   <a:srgbClr val="657574"/>
@@ -9813,7 +10082,7 @@
                 <a:ea typeface="Helvetica Neue"/>
                 <a:cs typeface="Helvetica Neue"/>
               </a:rPr>
-              <a:t>daily request quota. These are partial-suite counts.</a:t>
+              <a:t>V2 live evaluation starts after the v1 suite finishes.</a:t>
             </a:r>
           </a:p>
         </p:txBody>
@@ -9859,6 +10128,7 @@
               </a:defRPr>
             </a:defPPr>
             <a:lvl1pPr>
+              <a:buNone/>
               <a:defRPr sz="1800" b="0">
                 <a:solidFill>
                   <a:srgbClr val="172E32"/>
@@ -9869,6 +10139,7 @@
               </a:defRPr>
             </a:lvl1pPr>
             <a:lvl2pPr>
+              <a:buNone/>
               <a:defRPr sz="1800" b="0">
                 <a:solidFill>
                   <a:srgbClr val="172E32"/>
@@ -9879,6 +10150,7 @@
               </a:defRPr>
             </a:lvl2pPr>
             <a:lvl3pPr>
+              <a:buNone/>
               <a:defRPr sz="1800" b="0">
                 <a:solidFill>
                   <a:srgbClr val="172E32"/>
@@ -9889,6 +10161,7 @@
               </a:defRPr>
             </a:lvl3pPr>
             <a:lvl4pPr>
+              <a:buNone/>
               <a:defRPr sz="1800" b="0">
                 <a:solidFill>
                   <a:srgbClr val="172E32"/>
@@ -9899,6 +10172,7 @@
               </a:defRPr>
             </a:lvl4pPr>
             <a:lvl5pPr>
+              <a:buNone/>
               <a:defRPr sz="1800" b="0">
                 <a:solidFill>
                   <a:srgbClr val="172E32"/>
@@ -9909,6 +10183,7 @@
               </a:defRPr>
             </a:lvl5pPr>
             <a:lvl6pPr>
+              <a:buNone/>
               <a:defRPr sz="1800" b="0">
                 <a:solidFill>
                   <a:srgbClr val="172E32"/>
@@ -9919,6 +10194,7 @@
               </a:defRPr>
             </a:lvl6pPr>
             <a:lvl7pPr>
+              <a:buNone/>
               <a:defRPr sz="1800" b="0">
                 <a:solidFill>
                   <a:srgbClr val="172E32"/>
@@ -9929,6 +10205,7 @@
               </a:defRPr>
             </a:lvl7pPr>
             <a:lvl8pPr>
+              <a:buNone/>
               <a:defRPr sz="1800" b="0">
                 <a:solidFill>
                   <a:srgbClr val="172E32"/>
@@ -9939,6 +10216,7 @@
               </a:defRPr>
             </a:lvl8pPr>
             <a:lvl9pPr>
+              <a:buNone/>
               <a:defRPr sz="1800" b="0">
                 <a:solidFill>
                   <a:srgbClr val="172E32"/>
@@ -9951,6 +10229,7 @@
           </a:lstStyle>
           <a:p xmlns:a="http://schemas.openxmlformats.org/drawingml/2006/main">
             <a:pPr>
+              <a:buNone/>
               <a:defRPr sz="1800" b="0">
                 <a:solidFill>
                   <a:srgbClr val="172E32"/>
@@ -9974,6 +10253,7 @@
           </a:p>
           <a:p xmlns:a="http://schemas.openxmlformats.org/drawingml/2006/main">
             <a:pPr>
+              <a:buNone/>
               <a:defRPr sz="1800" b="0">
                 <a:solidFill>
                   <a:srgbClr val="172E32"/>
@@ -10067,6 +10347,7 @@
               </a:defRPr>
             </a:defPPr>
             <a:lvl1pPr>
+              <a:buNone/>
               <a:defRPr sz="1125" b="1">
                 <a:solidFill>
                   <a:srgbClr val="146B5F"/>
@@ -10077,6 +10358,7 @@
               </a:defRPr>
             </a:lvl1pPr>
             <a:lvl2pPr>
+              <a:buNone/>
               <a:defRPr sz="1125" b="1">
                 <a:solidFill>
                   <a:srgbClr val="146B5F"/>
@@ -10087,6 +10369,7 @@
               </a:defRPr>
             </a:lvl2pPr>
             <a:lvl3pPr>
+              <a:buNone/>
               <a:defRPr sz="1125" b="1">
                 <a:solidFill>
                   <a:srgbClr val="146B5F"/>
@@ -10097,6 +10380,7 @@
               </a:defRPr>
             </a:lvl3pPr>
             <a:lvl4pPr>
+              <a:buNone/>
               <a:defRPr sz="1125" b="1">
                 <a:solidFill>
                   <a:srgbClr val="146B5F"/>
@@ -10107,6 +10391,7 @@
               </a:defRPr>
             </a:lvl4pPr>
             <a:lvl5pPr>
+              <a:buNone/>
               <a:defRPr sz="1125" b="1">
                 <a:solidFill>
                   <a:srgbClr val="146B5F"/>
@@ -10117,6 +10402,7 @@
               </a:defRPr>
             </a:lvl5pPr>
             <a:lvl6pPr>
+              <a:buNone/>
               <a:defRPr sz="1125" b="1">
                 <a:solidFill>
                   <a:srgbClr val="146B5F"/>
@@ -10127,6 +10413,7 @@
               </a:defRPr>
             </a:lvl6pPr>
             <a:lvl7pPr>
+              <a:buNone/>
               <a:defRPr sz="1125" b="1">
                 <a:solidFill>
                   <a:srgbClr val="146B5F"/>
@@ -10137,6 +10424,7 @@
               </a:defRPr>
             </a:lvl7pPr>
             <a:lvl8pPr>
+              <a:buNone/>
               <a:defRPr sz="1125" b="1">
                 <a:solidFill>
                   <a:srgbClr val="146B5F"/>
@@ -10147,6 +10435,7 @@
               </a:defRPr>
             </a:lvl8pPr>
             <a:lvl9pPr>
+              <a:buNone/>
               <a:defRPr sz="1125" b="1">
                 <a:solidFill>
                   <a:srgbClr val="146B5F"/>
@@ -10159,6 +10448,7 @@
           </a:lstStyle>
           <a:p xmlns:a="http://schemas.openxmlformats.org/drawingml/2006/main">
             <a:pPr>
+              <a:buNone/>
               <a:defRPr sz="1125" b="1">
                 <a:solidFill>
                   <a:srgbClr val="146B5F"/>
@@ -10223,6 +10513,7 @@
               </a:defRPr>
             </a:defPPr>
             <a:lvl1pPr>
+              <a:buNone/>
               <a:defRPr sz="3825" b="0">
                 <a:solidFill>
                   <a:srgbClr val="172E32"/>
@@ -10233,6 +10524,7 @@
               </a:defRPr>
             </a:lvl1pPr>
             <a:lvl2pPr>
+              <a:buNone/>
               <a:defRPr sz="3825" b="0">
                 <a:solidFill>
                   <a:srgbClr val="172E32"/>
@@ -10243,6 +10535,7 @@
               </a:defRPr>
             </a:lvl2pPr>
             <a:lvl3pPr>
+              <a:buNone/>
               <a:defRPr sz="3825" b="0">
                 <a:solidFill>
                   <a:srgbClr val="172E32"/>
@@ -10253,6 +10546,7 @@
               </a:defRPr>
             </a:lvl3pPr>
             <a:lvl4pPr>
+              <a:buNone/>
               <a:defRPr sz="3825" b="0">
                 <a:solidFill>
                   <a:srgbClr val="172E32"/>
@@ -10263,6 +10557,7 @@
               </a:defRPr>
             </a:lvl4pPr>
             <a:lvl5pPr>
+              <a:buNone/>
               <a:defRPr sz="3825" b="0">
                 <a:solidFill>
                   <a:srgbClr val="172E32"/>
@@ -10273,6 +10568,7 @@
               </a:defRPr>
             </a:lvl5pPr>
             <a:lvl6pPr>
+              <a:buNone/>
               <a:defRPr sz="3825" b="0">
                 <a:solidFill>
                   <a:srgbClr val="172E32"/>
@@ -10283,6 +10579,7 @@
               </a:defRPr>
             </a:lvl6pPr>
             <a:lvl7pPr>
+              <a:buNone/>
               <a:defRPr sz="3825" b="0">
                 <a:solidFill>
                   <a:srgbClr val="172E32"/>
@@ -10293,6 +10590,7 @@
               </a:defRPr>
             </a:lvl7pPr>
             <a:lvl8pPr>
+              <a:buNone/>
               <a:defRPr sz="3825" b="0">
                 <a:solidFill>
                   <a:srgbClr val="172E32"/>
@@ -10303,6 +10601,7 @@
               </a:defRPr>
             </a:lvl8pPr>
             <a:lvl9pPr>
+              <a:buNone/>
               <a:defRPr sz="3825" b="0">
                 <a:solidFill>
                   <a:srgbClr val="172E32"/>
@@ -10315,6 +10614,7 @@
           </a:lstStyle>
           <a:p xmlns:a="http://schemas.openxmlformats.org/drawingml/2006/main">
             <a:pPr>
+              <a:buNone/>
               <a:defRPr sz="3825" b="0">
                 <a:solidFill>
                   <a:srgbClr val="172E32"/>
@@ -10379,6 +10679,7 @@
               </a:defRPr>
             </a:defPPr>
             <a:lvl1pPr>
+              <a:buNone/>
               <a:defRPr sz="1050" b="0">
                 <a:solidFill>
                   <a:srgbClr val="657574"/>
@@ -10389,6 +10690,7 @@
               </a:defRPr>
             </a:lvl1pPr>
             <a:lvl2pPr>
+              <a:buNone/>
               <a:defRPr sz="1050" b="0">
                 <a:solidFill>
                   <a:srgbClr val="657574"/>
@@ -10399,6 +10701,7 @@
               </a:defRPr>
             </a:lvl2pPr>
             <a:lvl3pPr>
+              <a:buNone/>
               <a:defRPr sz="1050" b="0">
                 <a:solidFill>
                   <a:srgbClr val="657574"/>
@@ -10409,6 +10712,7 @@
               </a:defRPr>
             </a:lvl3pPr>
             <a:lvl4pPr>
+              <a:buNone/>
               <a:defRPr sz="1050" b="0">
                 <a:solidFill>
                   <a:srgbClr val="657574"/>
@@ -10419,6 +10723,7 @@
               </a:defRPr>
             </a:lvl4pPr>
             <a:lvl5pPr>
+              <a:buNone/>
               <a:defRPr sz="1050" b="0">
                 <a:solidFill>
                   <a:srgbClr val="657574"/>
@@ -10429,6 +10734,7 @@
               </a:defRPr>
             </a:lvl5pPr>
             <a:lvl6pPr>
+              <a:buNone/>
               <a:defRPr sz="1050" b="0">
                 <a:solidFill>
                   <a:srgbClr val="657574"/>
@@ -10439,6 +10745,7 @@
               </a:defRPr>
             </a:lvl6pPr>
             <a:lvl7pPr>
+              <a:buNone/>
               <a:defRPr sz="1050" b="0">
                 <a:solidFill>
                   <a:srgbClr val="657574"/>
@@ -10449,6 +10756,7 @@
               </a:defRPr>
             </a:lvl7pPr>
             <a:lvl8pPr>
+              <a:buNone/>
               <a:defRPr sz="1050" b="0">
                 <a:solidFill>
                   <a:srgbClr val="657574"/>
@@ -10459,6 +10767,7 @@
               </a:defRPr>
             </a:lvl8pPr>
             <a:lvl9pPr>
+              <a:buNone/>
               <a:defRPr sz="1050" b="0">
                 <a:solidFill>
                   <a:srgbClr val="657574"/>
@@ -10471,6 +10780,7 @@
           </a:lstStyle>
           <a:p xmlns:a="http://schemas.openxmlformats.org/drawingml/2006/main">
             <a:pPr>
+              <a:buNone/>
               <a:defRPr sz="1050" b="0">
                 <a:solidFill>
                   <a:srgbClr val="657574"/>
@@ -10535,6 +10845,7 @@
               </a:defRPr>
             </a:defPPr>
             <a:lvl1pPr>
+              <a:buNone/>
               <a:defRPr sz="2325" b="1">
                 <a:solidFill>
                   <a:srgbClr val="146B5F"/>
@@ -10545,6 +10856,7 @@
               </a:defRPr>
             </a:lvl1pPr>
             <a:lvl2pPr>
+              <a:buNone/>
               <a:defRPr sz="2325" b="1">
                 <a:solidFill>
                   <a:srgbClr val="146B5F"/>
@@ -10555,6 +10867,7 @@
               </a:defRPr>
             </a:lvl2pPr>
             <a:lvl3pPr>
+              <a:buNone/>
               <a:defRPr sz="2325" b="1">
                 <a:solidFill>
                   <a:srgbClr val="146B5F"/>
@@ -10565,6 +10878,7 @@
               </a:defRPr>
             </a:lvl3pPr>
             <a:lvl4pPr>
+              <a:buNone/>
               <a:defRPr sz="2325" b="1">
                 <a:solidFill>
                   <a:srgbClr val="146B5F"/>
@@ -10575,6 +10889,7 @@
               </a:defRPr>
             </a:lvl4pPr>
             <a:lvl5pPr>
+              <a:buNone/>
               <a:defRPr sz="2325" b="1">
                 <a:solidFill>
                   <a:srgbClr val="146B5F"/>
@@ -10585,6 +10900,7 @@
               </a:defRPr>
             </a:lvl5pPr>
             <a:lvl6pPr>
+              <a:buNone/>
               <a:defRPr sz="2325" b="1">
                 <a:solidFill>
                   <a:srgbClr val="146B5F"/>
@@ -10595,6 +10911,7 @@
               </a:defRPr>
             </a:lvl6pPr>
             <a:lvl7pPr>
+              <a:buNone/>
               <a:defRPr sz="2325" b="1">
                 <a:solidFill>
                   <a:srgbClr val="146B5F"/>
@@ -10605,6 +10922,7 @@
               </a:defRPr>
             </a:lvl7pPr>
             <a:lvl8pPr>
+              <a:buNone/>
               <a:defRPr sz="2325" b="1">
                 <a:solidFill>
                   <a:srgbClr val="146B5F"/>
@@ -10615,6 +10933,7 @@
               </a:defRPr>
             </a:lvl8pPr>
             <a:lvl9pPr>
+              <a:buNone/>
               <a:defRPr sz="2325" b="1">
                 <a:solidFill>
                   <a:srgbClr val="146B5F"/>
@@ -10627,6 +10946,7 @@
           </a:lstStyle>
           <a:p xmlns:a="http://schemas.openxmlformats.org/drawingml/2006/main">
             <a:pPr>
+              <a:buNone/>
               <a:defRPr sz="2325" b="1">
                 <a:solidFill>
                   <a:srgbClr val="146B5F"/>
@@ -10645,7 +10965,7 @@
                 <a:ea typeface="Helvetica Neue"/>
                 <a:cs typeface="Helvetica Neue"/>
               </a:rPr>
-              <a:t>Observed live attack</a:t>
+              <a:t>Observed v1 live attack</a:t>
             </a:r>
           </a:p>
         </p:txBody>
@@ -10691,6 +11011,7 @@
               </a:defRPr>
             </a:defPPr>
             <a:lvl1pPr>
+              <a:buNone/>
               <a:defRPr sz="2175" b="0">
                 <a:solidFill>
                   <a:srgbClr val="172E32"/>
@@ -10701,6 +11022,7 @@
               </a:defRPr>
             </a:lvl1pPr>
             <a:lvl2pPr>
+              <a:buNone/>
               <a:defRPr sz="2175" b="0">
                 <a:solidFill>
                   <a:srgbClr val="172E32"/>
@@ -10711,6 +11033,7 @@
               </a:defRPr>
             </a:lvl2pPr>
             <a:lvl3pPr>
+              <a:buNone/>
               <a:defRPr sz="2175" b="0">
                 <a:solidFill>
                   <a:srgbClr val="172E32"/>
@@ -10721,6 +11044,7 @@
               </a:defRPr>
             </a:lvl3pPr>
             <a:lvl4pPr>
+              <a:buNone/>
               <a:defRPr sz="2175" b="0">
                 <a:solidFill>
                   <a:srgbClr val="172E32"/>
@@ -10731,6 +11055,7 @@
               </a:defRPr>
             </a:lvl4pPr>
             <a:lvl5pPr>
+              <a:buNone/>
               <a:defRPr sz="2175" b="0">
                 <a:solidFill>
                   <a:srgbClr val="172E32"/>
@@ -10741,6 +11066,7 @@
               </a:defRPr>
             </a:lvl5pPr>
             <a:lvl6pPr>
+              <a:buNone/>
               <a:defRPr sz="2175" b="0">
                 <a:solidFill>
                   <a:srgbClr val="172E32"/>
@@ -10751,6 +11077,7 @@
               </a:defRPr>
             </a:lvl6pPr>
             <a:lvl7pPr>
+              <a:buNone/>
               <a:defRPr sz="2175" b="0">
                 <a:solidFill>
                   <a:srgbClr val="172E32"/>
@@ -10761,6 +11088,7 @@
               </a:defRPr>
             </a:lvl7pPr>
             <a:lvl8pPr>
+              <a:buNone/>
               <a:defRPr sz="2175" b="0">
                 <a:solidFill>
                   <a:srgbClr val="172E32"/>
@@ -10771,6 +11099,7 @@
               </a:defRPr>
             </a:lvl8pPr>
             <a:lvl9pPr>
+              <a:buNone/>
               <a:defRPr sz="2175" b="0">
                 <a:solidFill>
                   <a:srgbClr val="172E32"/>
@@ -10783,6 +11112,7 @@
           </a:lstStyle>
           <a:p xmlns:a="http://schemas.openxmlformats.org/drawingml/2006/main">
             <a:pPr>
+              <a:buNone/>
               <a:defRPr sz="2175" b="0">
                 <a:solidFill>
                   <a:srgbClr val="172E32"/>
@@ -10806,6 +11136,7 @@
           </a:p>
           <a:p xmlns:a="http://schemas.openxmlformats.org/drawingml/2006/main">
             <a:pPr>
+              <a:buNone/>
               <a:defRPr sz="2175" b="0">
                 <a:solidFill>
                   <a:srgbClr val="172E32"/>
@@ -10870,6 +11201,7 @@
               </a:defRPr>
             </a:defPPr>
             <a:lvl1pPr>
+              <a:buNone/>
               <a:defRPr sz="2325" b="1">
                 <a:solidFill>
                   <a:srgbClr val="146B5F"/>
@@ -10880,6 +11212,7 @@
               </a:defRPr>
             </a:lvl1pPr>
             <a:lvl2pPr>
+              <a:buNone/>
               <a:defRPr sz="2325" b="1">
                 <a:solidFill>
                   <a:srgbClr val="146B5F"/>
@@ -10890,6 +11223,7 @@
               </a:defRPr>
             </a:lvl2pPr>
             <a:lvl3pPr>
+              <a:buNone/>
               <a:defRPr sz="2325" b="1">
                 <a:solidFill>
                   <a:srgbClr val="146B5F"/>
@@ -10900,6 +11234,7 @@
               </a:defRPr>
             </a:lvl3pPr>
             <a:lvl4pPr>
+              <a:buNone/>
               <a:defRPr sz="2325" b="1">
                 <a:solidFill>
                   <a:srgbClr val="146B5F"/>
@@ -10910,6 +11245,7 @@
               </a:defRPr>
             </a:lvl4pPr>
             <a:lvl5pPr>
+              <a:buNone/>
               <a:defRPr sz="2325" b="1">
                 <a:solidFill>
                   <a:srgbClr val="146B5F"/>
@@ -10920,6 +11256,7 @@
               </a:defRPr>
             </a:lvl5pPr>
             <a:lvl6pPr>
+              <a:buNone/>
               <a:defRPr sz="2325" b="1">
                 <a:solidFill>
                   <a:srgbClr val="146B5F"/>
@@ -10930,6 +11267,7 @@
               </a:defRPr>
             </a:lvl6pPr>
             <a:lvl7pPr>
+              <a:buNone/>
               <a:defRPr sz="2325" b="1">
                 <a:solidFill>
                   <a:srgbClr val="146B5F"/>
@@ -10940,6 +11278,7 @@
               </a:defRPr>
             </a:lvl7pPr>
             <a:lvl8pPr>
+              <a:buNone/>
               <a:defRPr sz="2325" b="1">
                 <a:solidFill>
                   <a:srgbClr val="146B5F"/>
@@ -10950,6 +11289,7 @@
               </a:defRPr>
             </a:lvl8pPr>
             <a:lvl9pPr>
+              <a:buNone/>
               <a:defRPr sz="2325" b="1">
                 <a:solidFill>
                   <a:srgbClr val="146B5F"/>
@@ -10962,6 +11302,7 @@
           </a:lstStyle>
           <a:p xmlns:a="http://schemas.openxmlformats.org/drawingml/2006/main">
             <a:pPr>
+              <a:buNone/>
               <a:defRPr sz="2325" b="1">
                 <a:solidFill>
                   <a:srgbClr val="146B5F"/>
@@ -11026,6 +11367,7 @@
               </a:defRPr>
             </a:defPPr>
             <a:lvl1pPr>
+              <a:buNone/>
               <a:defRPr sz="2100" b="0">
                 <a:solidFill>
                   <a:srgbClr val="172E32"/>
@@ -11036,6 +11378,7 @@
               </a:defRPr>
             </a:lvl1pPr>
             <a:lvl2pPr>
+              <a:buNone/>
               <a:defRPr sz="2100" b="0">
                 <a:solidFill>
                   <a:srgbClr val="172E32"/>
@@ -11046,6 +11389,7 @@
               </a:defRPr>
             </a:lvl2pPr>
             <a:lvl3pPr>
+              <a:buNone/>
               <a:defRPr sz="2100" b="0">
                 <a:solidFill>
                   <a:srgbClr val="172E32"/>
@@ -11056,6 +11400,7 @@
               </a:defRPr>
             </a:lvl3pPr>
             <a:lvl4pPr>
+              <a:buNone/>
               <a:defRPr sz="2100" b="0">
                 <a:solidFill>
                   <a:srgbClr val="172E32"/>
@@ -11066,6 +11411,7 @@
               </a:defRPr>
             </a:lvl4pPr>
             <a:lvl5pPr>
+              <a:buNone/>
               <a:defRPr sz="2100" b="0">
                 <a:solidFill>
                   <a:srgbClr val="172E32"/>
@@ -11076,6 +11422,7 @@
               </a:defRPr>
             </a:lvl5pPr>
             <a:lvl6pPr>
+              <a:buNone/>
               <a:defRPr sz="2100" b="0">
                 <a:solidFill>
                   <a:srgbClr val="172E32"/>
@@ -11086,6 +11433,7 @@
               </a:defRPr>
             </a:lvl6pPr>
             <a:lvl7pPr>
+              <a:buNone/>
               <a:defRPr sz="2100" b="0">
                 <a:solidFill>
                   <a:srgbClr val="172E32"/>
@@ -11096,6 +11444,7 @@
               </a:defRPr>
             </a:lvl7pPr>
             <a:lvl8pPr>
+              <a:buNone/>
               <a:defRPr sz="2100" b="0">
                 <a:solidFill>
                   <a:srgbClr val="172E32"/>
@@ -11106,6 +11455,7 @@
               </a:defRPr>
             </a:lvl8pPr>
             <a:lvl9pPr>
+              <a:buNone/>
               <a:defRPr sz="2100" b="0">
                 <a:solidFill>
                   <a:srgbClr val="172E32"/>
@@ -11118,6 +11468,7 @@
           </a:lstStyle>
           <a:p xmlns:a="http://schemas.openxmlformats.org/drawingml/2006/main">
             <a:pPr>
+              <a:buNone/>
               <a:defRPr sz="2100" b="0">
                 <a:solidFill>
                   <a:srgbClr val="172E32"/>
@@ -11141,6 +11492,7 @@
           </a:p>
           <a:p xmlns:a="http://schemas.openxmlformats.org/drawingml/2006/main">
             <a:pPr>
+              <a:buNone/>
               <a:defRPr sz="2100" b="0">
                 <a:solidFill>
                   <a:srgbClr val="172E32"/>
@@ -11205,6 +11557,7 @@
               </a:defRPr>
             </a:defPPr>
             <a:lvl1pPr>
+              <a:buNone/>
               <a:defRPr sz="1725" b="0">
                 <a:solidFill>
                   <a:srgbClr val="657574"/>
@@ -11215,6 +11568,7 @@
               </a:defRPr>
             </a:lvl1pPr>
             <a:lvl2pPr>
+              <a:buNone/>
               <a:defRPr sz="1725" b="0">
                 <a:solidFill>
                   <a:srgbClr val="657574"/>
@@ -11225,6 +11579,7 @@
               </a:defRPr>
             </a:lvl2pPr>
             <a:lvl3pPr>
+              <a:buNone/>
               <a:defRPr sz="1725" b="0">
                 <a:solidFill>
                   <a:srgbClr val="657574"/>
@@ -11235,6 +11590,7 @@
               </a:defRPr>
             </a:lvl3pPr>
             <a:lvl4pPr>
+              <a:buNone/>
               <a:defRPr sz="1725" b="0">
                 <a:solidFill>
                   <a:srgbClr val="657574"/>
@@ -11245,6 +11601,7 @@
               </a:defRPr>
             </a:lvl4pPr>
             <a:lvl5pPr>
+              <a:buNone/>
               <a:defRPr sz="1725" b="0">
                 <a:solidFill>
                   <a:srgbClr val="657574"/>
@@ -11255,6 +11612,7 @@
               </a:defRPr>
             </a:lvl5pPr>
             <a:lvl6pPr>
+              <a:buNone/>
               <a:defRPr sz="1725" b="0">
                 <a:solidFill>
                   <a:srgbClr val="657574"/>
@@ -11265,6 +11623,7 @@
               </a:defRPr>
             </a:lvl6pPr>
             <a:lvl7pPr>
+              <a:buNone/>
               <a:defRPr sz="1725" b="0">
                 <a:solidFill>
                   <a:srgbClr val="657574"/>
@@ -11275,6 +11634,7 @@
               </a:defRPr>
             </a:lvl7pPr>
             <a:lvl8pPr>
+              <a:buNone/>
               <a:defRPr sz="1725" b="0">
                 <a:solidFill>
                   <a:srgbClr val="657574"/>
@@ -11285,6 +11645,7 @@
               </a:defRPr>
             </a:lvl8pPr>
             <a:lvl9pPr>
+              <a:buNone/>
               <a:defRPr sz="1725" b="0">
                 <a:solidFill>
                   <a:srgbClr val="657574"/>
@@ -11297,6 +11658,7 @@
           </a:lstStyle>
           <a:p xmlns:a="http://schemas.openxmlformats.org/drawingml/2006/main">
             <a:pPr>
+              <a:buNone/>
               <a:defRPr sz="1725" b="0">
                 <a:solidFill>
                   <a:srgbClr val="657574"/>
@@ -11315,11 +11677,12 @@
                 <a:ea typeface="Helvetica Neue"/>
                 <a:cs typeface="Helvetica Neue"/>
               </a:rPr>
-              <a:t>Next: finish pending live evaluations, strengthen procedure invocation,</a:t>
+              <a:t>56 automated checks pass. Live v2 evaluation remains pending.</a:t>
             </a:r>
           </a:p>
           <a:p xmlns:a="http://schemas.openxmlformats.org/drawingml/2006/main">
             <a:pPr>
+              <a:buNone/>
               <a:defRPr sz="1725" b="0">
                 <a:solidFill>
                   <a:srgbClr val="657574"/>
@@ -11338,7 +11701,7 @@
                 <a:ea typeface="Helvetica Neue"/>
                 <a:cs typeface="Helvetica Neue"/>
               </a:rPr>
-              <a:t>and validate real experiment exports with traceable provenance.</a:t>
+              <a:t>Further validation depends on provider quota and real exports.</a:t>
             </a:r>
           </a:p>
         </p:txBody>

</xml_diff>

<commit_message>
Add captioned demo backup and record exhausted evaluation quota
</commit_message>
<xml_diff>
--- a/submission/ModelCheck_Capstone.pptx
+++ b/submission/ModelCheck_Capstone.pptx
@@ -2,18 +2,18 @@
 <file path=ppt/presentation.xml><?xml version="1.0" encoding="utf-8"?>
 <p:presentation xmlns:p="http://schemas.openxmlformats.org/presentationml/2006/main">
   <p:sldMasterIdLst>
-    <p:sldMasterId xmlns:r="http://schemas.openxmlformats.org/officeDocument/2006/relationships" id="2147483648" r:id="Re69db8ff96494873"/>
+    <p:sldMasterId xmlns:r="http://schemas.openxmlformats.org/officeDocument/2006/relationships" id="2147483648" r:id="Rd69dcd68864043ed"/>
   </p:sldMasterIdLst>
   <p:notesMasterIdLst>
-    <p:notesMasterId xmlns:r="http://schemas.openxmlformats.org/officeDocument/2006/relationships" r:id="R77529d837c8249ba"/>
+    <p:notesMasterId xmlns:r="http://schemas.openxmlformats.org/officeDocument/2006/relationships" r:id="Rebb0250554af4e7c"/>
   </p:notesMasterIdLst>
   <p:sldIdLst>
-    <p:sldId xmlns:r="http://schemas.openxmlformats.org/officeDocument/2006/relationships" id="256" r:id="Rf89aa813e1794a55"/>
-    <p:sldId xmlns:r="http://schemas.openxmlformats.org/officeDocument/2006/relationships" id="257" r:id="Rb1115e63ca81477a"/>
-    <p:sldId xmlns:r="http://schemas.openxmlformats.org/officeDocument/2006/relationships" id="258" r:id="R32cba5404a074cc7"/>
-    <p:sldId xmlns:r="http://schemas.openxmlformats.org/officeDocument/2006/relationships" id="259" r:id="Rf64a8a9d84a34a7b"/>
-    <p:sldId xmlns:r="http://schemas.openxmlformats.org/officeDocument/2006/relationships" id="260" r:id="R2c849480b9564bee"/>
-    <p:sldId xmlns:r="http://schemas.openxmlformats.org/officeDocument/2006/relationships" id="261" r:id="Reaf1a0b9a53b48ae"/>
+    <p:sldId xmlns:r="http://schemas.openxmlformats.org/officeDocument/2006/relationships" id="256" r:id="R21434e7db8774d6a"/>
+    <p:sldId xmlns:r="http://schemas.openxmlformats.org/officeDocument/2006/relationships" id="257" r:id="R2d7575e5e3784c92"/>
+    <p:sldId xmlns:r="http://schemas.openxmlformats.org/officeDocument/2006/relationships" id="258" r:id="Ref84d8c4d394428b"/>
+    <p:sldId xmlns:r="http://schemas.openxmlformats.org/officeDocument/2006/relationships" id="259" r:id="R3c7d2a73cff14538"/>
+    <p:sldId xmlns:r="http://schemas.openxmlformats.org/officeDocument/2006/relationships" id="260" r:id="R4b520b4317464359"/>
+    <p:sldId xmlns:r="http://schemas.openxmlformats.org/officeDocument/2006/relationships" id="261" r:id="Rde3540d602ad421d"/>
   </p:sldIdLst>
   <p:sldSz cx="12192000" cy="6858000"/>
   <p:notesSz cx="6858000" cy="9144000"/>
@@ -727,7 +727,7 @@
           <a:lstStyle xmlns:a="http://schemas.openxmlformats.org/drawingml/2006/main"/>
           <a:p xmlns:a="http://schemas.openxmlformats.org/drawingml/2006/main">
             <a:r>
-              <a:t>V1 has 18 tasks and 36 scheduled A/B reviews, with 12 executed and 24 pending. A passed 6/6 and B passed 5/6. B returned the correct accuracy delta but omitted compare_runs. Original traces and source are preserved in the initial snapshot. New runtime fingerprints are recovered metadata for those historical executions. V2 has no live evaluation results and cannot consume evaluation quota until v1 finishes. Five provider requests remain reserved; each evaluation requires at least 13 remaining requests before it starts. Sources: submission/summary.json, submission/COVERAGE.md, submission/evaluations/v1/initial and submission/evaluations/v2.</a:t>
+              <a:t>V1 has 18 tasks and 36 scheduled A/B reviews, with 12 executed and 24 pending. A passed 6/6 and B passed 5/6. B returned the correct accuracy delta but omitted compare_runs. Original traces and source are preserved in the initial snapshot. New runtime fingerprints are recovered metadata for those historical executions. V2 has no live evaluation results and cannot consume evaluation quota until v1 finishes. The latest allowance check reported zero requests remaining, so resumption sent no inference requests. The reserve policy requires at least 13 requests before an evaluation review starts: eight maximum plus five for the demo. A captioned browser recording in submission/demo demonstrates the original v1 replay and a fresh manual approval workflow. Sources: submission/summary.json, submission/COVERAGE.md, submission/evaluations/v1/initial and submission/evaluations/v2.</a:t>
             </a:r>
           </a:p>
         </p:txBody>
@@ -3240,12 +3240,12 @@
   </p:cSld>
   <p:clrMap bg1="lt1" tx1="dk1" bg2="lt2" tx2="dk2" accent1="accent1" accent2="accent2" accent3="accent3" accent4="accent4" accent5="accent5" accent6="accent6" hlink="hlink" folHlink="folHlink"/>
   <p:sldLayoutIdLst>
-    <p:sldLayoutId xmlns:r="http://schemas.openxmlformats.org/officeDocument/2006/relationships" id="2147483649" r:id="R2b425893c9b8461f"/>
-    <p:sldLayoutId xmlns:r="http://schemas.openxmlformats.org/officeDocument/2006/relationships" id="2147483650" r:id="R0b55c51a7d244660"/>
-    <p:sldLayoutId xmlns:r="http://schemas.openxmlformats.org/officeDocument/2006/relationships" id="2147483651" r:id="Re1ea9c798776492b"/>
-    <p:sldLayoutId xmlns:r="http://schemas.openxmlformats.org/officeDocument/2006/relationships" id="2147483652" r:id="R1b0074b8f4374d1a"/>
-    <p:sldLayoutId xmlns:r="http://schemas.openxmlformats.org/officeDocument/2006/relationships" id="2147483653" r:id="R4b22322d166440fc"/>
-    <p:sldLayoutId xmlns:r="http://schemas.openxmlformats.org/officeDocument/2006/relationships" id="2147483654" r:id="R98e1e8d0e7404cbf"/>
+    <p:sldLayoutId xmlns:r="http://schemas.openxmlformats.org/officeDocument/2006/relationships" id="2147483649" r:id="R409455274ade4fc0"/>
+    <p:sldLayoutId xmlns:r="http://schemas.openxmlformats.org/officeDocument/2006/relationships" id="2147483650" r:id="Raba63174104f4e17"/>
+    <p:sldLayoutId xmlns:r="http://schemas.openxmlformats.org/officeDocument/2006/relationships" id="2147483651" r:id="R6600c6dd15d44895"/>
+    <p:sldLayoutId xmlns:r="http://schemas.openxmlformats.org/officeDocument/2006/relationships" id="2147483652" r:id="R54f11945edc04844"/>
+    <p:sldLayoutId xmlns:r="http://schemas.openxmlformats.org/officeDocument/2006/relationships" id="2147483653" r:id="R9f752371489741fe"/>
+    <p:sldLayoutId xmlns:r="http://schemas.openxmlformats.org/officeDocument/2006/relationships" id="2147483654" r:id="Rd74df71dc72d4018"/>
   </p:sldLayoutIdLst>
   <p:txStyles>
     <p:titleStyle>
@@ -5367,7 +5367,7 @@
           <p:cNvPr id="5" name="">
             <a:extLst xmlns:a="http://schemas.openxmlformats.org/drawingml/2006/main">
               <a:ext uri="{FF2B5EF4-FFF2-40B4-BE49-F238E27FC236}">
-                <a16:creationId xmlns:a16="http://schemas.microsoft.com/office/drawing/2014/main" id="{AAD2F8F0-B3AD-44BD-AD2A-86225181D288}"/>
+                <a16:creationId xmlns:a16="http://schemas.microsoft.com/office/drawing/2014/main" id="{06BBE981-DDCF-473F-874D-0FFFF5E08D52}"/>
               </a:ext>
             </a:extLst>
           </p:cNvPr>
@@ -6595,7 +6595,7 @@
           <p:cNvPr id="4" name="">
             <a:extLst xmlns:a="http://schemas.openxmlformats.org/drawingml/2006/main">
               <a:ext uri="{FF2B5EF4-FFF2-40B4-BE49-F238E27FC236}">
-                <a16:creationId xmlns:a16="http://schemas.microsoft.com/office/drawing/2014/main" id="{94808FCA-AF34-43A7-8FE7-16D36FEFCBAD}"/>
+                <a16:creationId xmlns:a16="http://schemas.microsoft.com/office/drawing/2014/main" id="{8E8C8529-4061-4F7C-9E54-0004BDB940CB}"/>
               </a:ext>
             </a:extLst>
           </p:cNvPr>
@@ -9392,7 +9392,7 @@
           <p:cNvPr id="4" name="">
             <a:extLst xmlns:a="http://schemas.openxmlformats.org/drawingml/2006/main">
               <a:ext uri="{FF2B5EF4-FFF2-40B4-BE49-F238E27FC236}">
-                <a16:creationId xmlns:a16="http://schemas.microsoft.com/office/drawing/2014/main" id="{951544CE-FD62-4A27-811C-B9FFBDAD8408}"/>
+                <a16:creationId xmlns:a16="http://schemas.microsoft.com/office/drawing/2014/main" id="{96C65365-3532-4848-9359-3AD882A1662A}"/>
               </a:ext>
             </a:extLst>
           </p:cNvPr>
@@ -11131,7 +11131,7 @@
                 <a:ea typeface="Helvetica Neue"/>
                 <a:cs typeface="Helvetica Neue"/>
               </a:rPr>
-              <a:t>A run note requested an out-of-root save and bypassed approval.</a:t>
+              <a:t>A run note requested an out-of-root save and an approval bypass.</a:t>
             </a:r>
           </a:p>
           <a:p xmlns:a="http://schemas.openxmlformats.org/drawingml/2006/main">

</xml_diff>